<commit_message>
edits upt to Lecture 6
</commit_message>
<xml_diff>
--- a/Lecture_Slides/PH 123 Lecture 03.pptx
+++ b/Lecture_Slides/PH 123 Lecture 03.pptx
@@ -157,7 +157,7 @@
 <file path=ppt/revisionInfo.xml><?xml version="1.0" encoding="utf-8"?>
 <p1510:revInfo xmlns:a="http://schemas.openxmlformats.org/drawingml/2006/main" xmlns:r="http://schemas.openxmlformats.org/officeDocument/2006/relationships" xmlns:p1510="http://schemas.microsoft.com/office/powerpoint/2015/10/main">
   <p1510:revLst>
-    <p1510:client id="{0DB1FF66-FC41-4E46-8D6E-DEC24EAFA8A0}" v="85" dt="2026-01-08T23:39:43.893"/>
+    <p1510:client id="{42D05AEE-0230-4CD7-ACC7-45AADD8D1084}" v="17" dt="2026-04-22T20:42:07.520"/>
   </p1510:revLst>
 </p1510:revInfo>
 </file>
@@ -167,564 +167,65 @@
   <pc:docChgLst>
     <pc:chgData name="Lines, Todd" userId="afaf7c3a-e8aa-4568-882a-02ad8f9e19b0" providerId="ADAL" clId="{5FF5AC1B-ABA9-43D7-A1E3-2D92732CD6E2}"/>
     <pc:docChg chg="undo custSel addSld modSld">
-      <pc:chgData name="Lines, Todd" userId="afaf7c3a-e8aa-4568-882a-02ad8f9e19b0" providerId="ADAL" clId="{5FF5AC1B-ABA9-43D7-A1E3-2D92732CD6E2}" dt="2026-01-08T23:39:47.747" v="402" actId="21"/>
+      <pc:chgData name="Lines, Todd" userId="afaf7c3a-e8aa-4568-882a-02ad8f9e19b0" providerId="ADAL" clId="{5FF5AC1B-ABA9-43D7-A1E3-2D92732CD6E2}" dt="2026-04-22T20:42:07.520" v="497" actId="20577"/>
       <pc:docMkLst>
         <pc:docMk/>
       </pc:docMkLst>
-      <pc:sldChg chg="addSp modSp mod">
-        <pc:chgData name="Lines, Todd" userId="afaf7c3a-e8aa-4568-882a-02ad8f9e19b0" providerId="ADAL" clId="{5FF5AC1B-ABA9-43D7-A1E3-2D92732CD6E2}" dt="2026-01-08T21:17:37.813" v="179" actId="1076"/>
+      <pc:sldChg chg="modSp mod">
+        <pc:chgData name="Lines, Todd" userId="afaf7c3a-e8aa-4568-882a-02ad8f9e19b0" providerId="ADAL" clId="{5FF5AC1B-ABA9-43D7-A1E3-2D92732CD6E2}" dt="2026-04-22T20:29:32.286" v="404" actId="207"/>
         <pc:sldMkLst>
           <pc:docMk/>
-          <pc:sldMk cId="0" sldId="364"/>
+          <pc:sldMk cId="0" sldId="365"/>
         </pc:sldMkLst>
         <pc:spChg chg="mod">
-          <ac:chgData name="Lines, Todd" userId="afaf7c3a-e8aa-4568-882a-02ad8f9e19b0" providerId="ADAL" clId="{5FF5AC1B-ABA9-43D7-A1E3-2D92732CD6E2}" dt="2026-01-08T21:17:24.714" v="177" actId="14100"/>
+          <ac:chgData name="Lines, Todd" userId="afaf7c3a-e8aa-4568-882a-02ad8f9e19b0" providerId="ADAL" clId="{5FF5AC1B-ABA9-43D7-A1E3-2D92732CD6E2}" dt="2026-04-22T20:29:32.286" v="404" actId="207"/>
           <ac:spMkLst>
             <pc:docMk/>
-            <pc:sldMk cId="0" sldId="364"/>
-            <ac:spMk id="4112" creationId="{00000000-0000-0000-0000-000000000000}"/>
-          </ac:spMkLst>
-        </pc:spChg>
-        <pc:spChg chg="mod">
-          <ac:chgData name="Lines, Todd" userId="afaf7c3a-e8aa-4568-882a-02ad8f9e19b0" providerId="ADAL" clId="{5FF5AC1B-ABA9-43D7-A1E3-2D92732CD6E2}" dt="2026-01-08T21:17:37.813" v="179" actId="1076"/>
-          <ac:spMkLst>
-            <pc:docMk/>
-            <pc:sldMk cId="0" sldId="364"/>
-            <ac:spMk id="4113" creationId="{00000000-0000-0000-0000-000000000000}"/>
-          </ac:spMkLst>
-        </pc:spChg>
-        <pc:spChg chg="mod">
-          <ac:chgData name="Lines, Todd" userId="afaf7c3a-e8aa-4568-882a-02ad8f9e19b0" providerId="ADAL" clId="{5FF5AC1B-ABA9-43D7-A1E3-2D92732CD6E2}" dt="2026-01-08T21:17:37.813" v="179" actId="1076"/>
-          <ac:spMkLst>
-            <pc:docMk/>
-            <pc:sldMk cId="0" sldId="364"/>
-            <ac:spMk id="4115" creationId="{00000000-0000-0000-0000-000000000000}"/>
-          </ac:spMkLst>
-        </pc:spChg>
-        <pc:spChg chg="mod">
-          <ac:chgData name="Lines, Todd" userId="afaf7c3a-e8aa-4568-882a-02ad8f9e19b0" providerId="ADAL" clId="{5FF5AC1B-ABA9-43D7-A1E3-2D92732CD6E2}" dt="2026-01-08T21:17:37.813" v="179" actId="1076"/>
-          <ac:spMkLst>
-            <pc:docMk/>
-            <pc:sldMk cId="0" sldId="364"/>
-            <ac:spMk id="4118" creationId="{00000000-0000-0000-0000-000000000000}"/>
-          </ac:spMkLst>
-        </pc:spChg>
-        <pc:spChg chg="mod">
-          <ac:chgData name="Lines, Todd" userId="afaf7c3a-e8aa-4568-882a-02ad8f9e19b0" providerId="ADAL" clId="{5FF5AC1B-ABA9-43D7-A1E3-2D92732CD6E2}" dt="2026-01-08T21:17:37.813" v="179" actId="1076"/>
-          <ac:spMkLst>
-            <pc:docMk/>
-            <pc:sldMk cId="0" sldId="364"/>
-            <ac:spMk id="4119" creationId="{00000000-0000-0000-0000-000000000000}"/>
-          </ac:spMkLst>
-        </pc:spChg>
-        <pc:spChg chg="mod">
-          <ac:chgData name="Lines, Todd" userId="afaf7c3a-e8aa-4568-882a-02ad8f9e19b0" providerId="ADAL" clId="{5FF5AC1B-ABA9-43D7-A1E3-2D92732CD6E2}" dt="2026-01-08T21:17:10.487" v="175" actId="1076"/>
-          <ac:spMkLst>
-            <pc:docMk/>
-            <pc:sldMk cId="0" sldId="364"/>
-            <ac:spMk id="4120" creationId="{00000000-0000-0000-0000-000000000000}"/>
-          </ac:spMkLst>
-        </pc:spChg>
-        <pc:spChg chg="mod">
-          <ac:chgData name="Lines, Todd" userId="afaf7c3a-e8aa-4568-882a-02ad8f9e19b0" providerId="ADAL" clId="{5FF5AC1B-ABA9-43D7-A1E3-2D92732CD6E2}" dt="2026-01-08T21:17:37.813" v="179" actId="1076"/>
-          <ac:spMkLst>
-            <pc:docMk/>
-            <pc:sldMk cId="0" sldId="364"/>
-            <ac:spMk id="4121" creationId="{00000000-0000-0000-0000-000000000000}"/>
-          </ac:spMkLst>
-        </pc:spChg>
-        <pc:spChg chg="mod">
-          <ac:chgData name="Lines, Todd" userId="afaf7c3a-e8aa-4568-882a-02ad8f9e19b0" providerId="ADAL" clId="{5FF5AC1B-ABA9-43D7-A1E3-2D92732CD6E2}" dt="2026-01-08T21:17:37.813" v="179" actId="1076"/>
-          <ac:spMkLst>
-            <pc:docMk/>
-            <pc:sldMk cId="0" sldId="364"/>
-            <ac:spMk id="4123" creationId="{00000000-0000-0000-0000-000000000000}"/>
-          </ac:spMkLst>
-        </pc:spChg>
-        <pc:spChg chg="mod">
-          <ac:chgData name="Lines, Todd" userId="afaf7c3a-e8aa-4568-882a-02ad8f9e19b0" providerId="ADAL" clId="{5FF5AC1B-ABA9-43D7-A1E3-2D92732CD6E2}" dt="2026-01-08T21:17:37.813" v="179" actId="1076"/>
-          <ac:spMkLst>
-            <pc:docMk/>
-            <pc:sldMk cId="0" sldId="364"/>
-            <ac:spMk id="4124" creationId="{00000000-0000-0000-0000-000000000000}"/>
-          </ac:spMkLst>
-        </pc:spChg>
-        <pc:spChg chg="mod">
-          <ac:chgData name="Lines, Todd" userId="afaf7c3a-e8aa-4568-882a-02ad8f9e19b0" providerId="ADAL" clId="{5FF5AC1B-ABA9-43D7-A1E3-2D92732CD6E2}" dt="2026-01-08T21:17:37.813" v="179" actId="1076"/>
-          <ac:spMkLst>
-            <pc:docMk/>
-            <pc:sldMk cId="0" sldId="364"/>
-            <ac:spMk id="4125" creationId="{00000000-0000-0000-0000-000000000000}"/>
-          </ac:spMkLst>
-        </pc:spChg>
-        <pc:spChg chg="mod">
-          <ac:chgData name="Lines, Todd" userId="afaf7c3a-e8aa-4568-882a-02ad8f9e19b0" providerId="ADAL" clId="{5FF5AC1B-ABA9-43D7-A1E3-2D92732CD6E2}" dt="2026-01-08T21:17:37.813" v="179" actId="1076"/>
-          <ac:spMkLst>
-            <pc:docMk/>
-            <pc:sldMk cId="0" sldId="364"/>
-            <ac:spMk id="4128" creationId="{00000000-0000-0000-0000-000000000000}"/>
-          </ac:spMkLst>
-        </pc:spChg>
-        <pc:spChg chg="mod">
-          <ac:chgData name="Lines, Todd" userId="afaf7c3a-e8aa-4568-882a-02ad8f9e19b0" providerId="ADAL" clId="{5FF5AC1B-ABA9-43D7-A1E3-2D92732CD6E2}" dt="2026-01-08T21:17:37.813" v="179" actId="1076"/>
-          <ac:spMkLst>
-            <pc:docMk/>
-            <pc:sldMk cId="0" sldId="364"/>
-            <ac:spMk id="4129" creationId="{00000000-0000-0000-0000-000000000000}"/>
-          </ac:spMkLst>
-        </pc:spChg>
-        <pc:grpChg chg="add mod">
-          <ac:chgData name="Lines, Todd" userId="afaf7c3a-e8aa-4568-882a-02ad8f9e19b0" providerId="ADAL" clId="{5FF5AC1B-ABA9-43D7-A1E3-2D92732CD6E2}" dt="2026-01-08T21:17:32.793" v="178" actId="164"/>
-          <ac:grpSpMkLst>
-            <pc:docMk/>
-            <pc:sldMk cId="0" sldId="364"/>
-            <ac:grpSpMk id="2" creationId="{85C09F02-2C2C-5657-4F55-FC26B4A9060D}"/>
-          </ac:grpSpMkLst>
-        </pc:grpChg>
-        <pc:grpChg chg="mod">
-          <ac:chgData name="Lines, Todd" userId="afaf7c3a-e8aa-4568-882a-02ad8f9e19b0" providerId="ADAL" clId="{5FF5AC1B-ABA9-43D7-A1E3-2D92732CD6E2}" dt="2026-01-08T21:17:32.793" v="178" actId="164"/>
-          <ac:grpSpMkLst>
-            <pc:docMk/>
-            <pc:sldMk cId="0" sldId="364"/>
-            <ac:grpSpMk id="4102" creationId="{00000000-0000-0000-0000-000000000000}"/>
-          </ac:grpSpMkLst>
-        </pc:grpChg>
-        <pc:grpChg chg="mod">
-          <ac:chgData name="Lines, Todd" userId="afaf7c3a-e8aa-4568-882a-02ad8f9e19b0" providerId="ADAL" clId="{5FF5AC1B-ABA9-43D7-A1E3-2D92732CD6E2}" dt="2026-01-08T21:17:32.793" v="178" actId="164"/>
-          <ac:grpSpMkLst>
-            <pc:docMk/>
-            <pc:sldMk cId="0" sldId="364"/>
-            <ac:grpSpMk id="4106" creationId="{00000000-0000-0000-0000-000000000000}"/>
-          </ac:grpSpMkLst>
-        </pc:grpChg>
-        <pc:graphicFrameChg chg="mod">
-          <ac:chgData name="Lines, Todd" userId="afaf7c3a-e8aa-4568-882a-02ad8f9e19b0" providerId="ADAL" clId="{5FF5AC1B-ABA9-43D7-A1E3-2D92732CD6E2}" dt="2026-01-08T21:16:54.064" v="171" actId="1037"/>
-          <ac:graphicFrameMkLst>
-            <pc:docMk/>
-            <pc:sldMk cId="0" sldId="364"/>
-            <ac:graphicFrameMk id="4103" creationId="{00000000-0000-0000-0000-000000000000}"/>
-          </ac:graphicFrameMkLst>
-        </pc:graphicFrameChg>
-        <pc:graphicFrameChg chg="mod">
-          <ac:chgData name="Lines, Todd" userId="afaf7c3a-e8aa-4568-882a-02ad8f9e19b0" providerId="ADAL" clId="{5FF5AC1B-ABA9-43D7-A1E3-2D92732CD6E2}" dt="2026-01-08T21:16:54.064" v="171" actId="1037"/>
-          <ac:graphicFrameMkLst>
-            <pc:docMk/>
-            <pc:sldMk cId="0" sldId="364"/>
-            <ac:graphicFrameMk id="4105" creationId="{00000000-0000-0000-0000-000000000000}"/>
-          </ac:graphicFrameMkLst>
-        </pc:graphicFrameChg>
-        <pc:graphicFrameChg chg="mod">
-          <ac:chgData name="Lines, Todd" userId="afaf7c3a-e8aa-4568-882a-02ad8f9e19b0" providerId="ADAL" clId="{5FF5AC1B-ABA9-43D7-A1E3-2D92732CD6E2}" dt="2026-01-08T21:17:07.292" v="174" actId="1076"/>
-          <ac:graphicFrameMkLst>
-            <pc:docMk/>
-            <pc:sldMk cId="0" sldId="364"/>
-            <ac:graphicFrameMk id="4107" creationId="{00000000-0000-0000-0000-000000000000}"/>
-          </ac:graphicFrameMkLst>
-        </pc:graphicFrameChg>
-        <pc:graphicFrameChg chg="mod">
-          <ac:chgData name="Lines, Todd" userId="afaf7c3a-e8aa-4568-882a-02ad8f9e19b0" providerId="ADAL" clId="{5FF5AC1B-ABA9-43D7-A1E3-2D92732CD6E2}" dt="2026-01-08T21:17:03.645" v="173" actId="1076"/>
-          <ac:graphicFrameMkLst>
-            <pc:docMk/>
-            <pc:sldMk cId="0" sldId="364"/>
-            <ac:graphicFrameMk id="4109" creationId="{00000000-0000-0000-0000-000000000000}"/>
-          </ac:graphicFrameMkLst>
-        </pc:graphicFrameChg>
-        <pc:graphicFrameChg chg="mod">
-          <ac:chgData name="Lines, Todd" userId="afaf7c3a-e8aa-4568-882a-02ad8f9e19b0" providerId="ADAL" clId="{5FF5AC1B-ABA9-43D7-A1E3-2D92732CD6E2}" dt="2026-01-08T21:17:01.043" v="172" actId="1076"/>
-          <ac:graphicFrameMkLst>
-            <pc:docMk/>
-            <pc:sldMk cId="0" sldId="364"/>
-            <ac:graphicFrameMk id="4111" creationId="{00000000-0000-0000-0000-000000000000}"/>
-          </ac:graphicFrameMkLst>
-        </pc:graphicFrameChg>
-      </pc:sldChg>
-      <pc:sldChg chg="delSp modSp mod">
-        <pc:chgData name="Lines, Todd" userId="afaf7c3a-e8aa-4568-882a-02ad8f9e19b0" providerId="ADAL" clId="{5FF5AC1B-ABA9-43D7-A1E3-2D92732CD6E2}" dt="2026-01-08T23:14:59.101" v="297" actId="21"/>
-        <pc:sldMkLst>
-          <pc:docMk/>
-          <pc:sldMk cId="0" sldId="366"/>
-        </pc:sldMkLst>
-        <pc:spChg chg="mod">
-          <ac:chgData name="Lines, Todd" userId="afaf7c3a-e8aa-4568-882a-02ad8f9e19b0" providerId="ADAL" clId="{5FF5AC1B-ABA9-43D7-A1E3-2D92732CD6E2}" dt="2026-01-08T21:59:48.824" v="242" actId="1076"/>
-          <ac:spMkLst>
-            <pc:docMk/>
-            <pc:sldMk cId="0" sldId="366"/>
-            <ac:spMk id="6147" creationId="{00000000-0000-0000-0000-000000000000}"/>
-          </ac:spMkLst>
-        </pc:spChg>
-        <pc:spChg chg="mod">
-          <ac:chgData name="Lines, Todd" userId="afaf7c3a-e8aa-4568-882a-02ad8f9e19b0" providerId="ADAL" clId="{5FF5AC1B-ABA9-43D7-A1E3-2D92732CD6E2}" dt="2026-01-08T21:59:02.138" v="237" actId="1076"/>
-          <ac:spMkLst>
-            <pc:docMk/>
-            <pc:sldMk cId="0" sldId="366"/>
-            <ac:spMk id="6164" creationId="{00000000-0000-0000-0000-000000000000}"/>
-          </ac:spMkLst>
-        </pc:spChg>
-        <pc:spChg chg="mod">
-          <ac:chgData name="Lines, Todd" userId="afaf7c3a-e8aa-4568-882a-02ad8f9e19b0" providerId="ADAL" clId="{5FF5AC1B-ABA9-43D7-A1E3-2D92732CD6E2}" dt="2026-01-08T21:59:02.138" v="237" actId="1076"/>
-          <ac:spMkLst>
-            <pc:docMk/>
-            <pc:sldMk cId="0" sldId="366"/>
-            <ac:spMk id="6165" creationId="{00000000-0000-0000-0000-000000000000}"/>
-          </ac:spMkLst>
-        </pc:spChg>
-        <pc:spChg chg="mod">
-          <ac:chgData name="Lines, Todd" userId="afaf7c3a-e8aa-4568-882a-02ad8f9e19b0" providerId="ADAL" clId="{5FF5AC1B-ABA9-43D7-A1E3-2D92732CD6E2}" dt="2026-01-08T21:59:02.138" v="237" actId="1076"/>
-          <ac:spMkLst>
-            <pc:docMk/>
-            <pc:sldMk cId="0" sldId="366"/>
-            <ac:spMk id="6166" creationId="{00000000-0000-0000-0000-000000000000}"/>
-          </ac:spMkLst>
-        </pc:spChg>
-        <pc:spChg chg="mod">
-          <ac:chgData name="Lines, Todd" userId="afaf7c3a-e8aa-4568-882a-02ad8f9e19b0" providerId="ADAL" clId="{5FF5AC1B-ABA9-43D7-A1E3-2D92732CD6E2}" dt="2026-01-08T21:59:02.138" v="237" actId="1076"/>
-          <ac:spMkLst>
-            <pc:docMk/>
-            <pc:sldMk cId="0" sldId="366"/>
-            <ac:spMk id="6168" creationId="{00000000-0000-0000-0000-000000000000}"/>
-          </ac:spMkLst>
-        </pc:spChg>
-        <pc:spChg chg="mod">
-          <ac:chgData name="Lines, Todd" userId="afaf7c3a-e8aa-4568-882a-02ad8f9e19b0" providerId="ADAL" clId="{5FF5AC1B-ABA9-43D7-A1E3-2D92732CD6E2}" dt="2026-01-08T21:59:02.138" v="237" actId="1076"/>
-          <ac:spMkLst>
-            <pc:docMk/>
-            <pc:sldMk cId="0" sldId="366"/>
-            <ac:spMk id="6169" creationId="{00000000-0000-0000-0000-000000000000}"/>
-          </ac:spMkLst>
-        </pc:spChg>
-        <pc:spChg chg="mod">
-          <ac:chgData name="Lines, Todd" userId="afaf7c3a-e8aa-4568-882a-02ad8f9e19b0" providerId="ADAL" clId="{5FF5AC1B-ABA9-43D7-A1E3-2D92732CD6E2}" dt="2026-01-08T21:59:02.138" v="237" actId="1076"/>
-          <ac:spMkLst>
-            <pc:docMk/>
-            <pc:sldMk cId="0" sldId="366"/>
-            <ac:spMk id="6171" creationId="{00000000-0000-0000-0000-000000000000}"/>
-          </ac:spMkLst>
-        </pc:spChg>
-        <pc:spChg chg="mod">
-          <ac:chgData name="Lines, Todd" userId="afaf7c3a-e8aa-4568-882a-02ad8f9e19b0" providerId="ADAL" clId="{5FF5AC1B-ABA9-43D7-A1E3-2D92732CD6E2}" dt="2026-01-08T21:59:02.138" v="237" actId="1076"/>
-          <ac:spMkLst>
-            <pc:docMk/>
-            <pc:sldMk cId="0" sldId="366"/>
-            <ac:spMk id="6172" creationId="{00000000-0000-0000-0000-000000000000}"/>
-          </ac:spMkLst>
-        </pc:spChg>
-        <pc:spChg chg="mod">
-          <ac:chgData name="Lines, Todd" userId="afaf7c3a-e8aa-4568-882a-02ad8f9e19b0" providerId="ADAL" clId="{5FF5AC1B-ABA9-43D7-A1E3-2D92732CD6E2}" dt="2026-01-08T21:59:02.138" v="237" actId="1076"/>
-          <ac:spMkLst>
-            <pc:docMk/>
-            <pc:sldMk cId="0" sldId="366"/>
-            <ac:spMk id="6173" creationId="{00000000-0000-0000-0000-000000000000}"/>
-          </ac:spMkLst>
-        </pc:spChg>
-        <pc:spChg chg="mod">
-          <ac:chgData name="Lines, Todd" userId="afaf7c3a-e8aa-4568-882a-02ad8f9e19b0" providerId="ADAL" clId="{5FF5AC1B-ABA9-43D7-A1E3-2D92732CD6E2}" dt="2026-01-08T21:59:20.591" v="240" actId="207"/>
-          <ac:spMkLst>
-            <pc:docMk/>
-            <pc:sldMk cId="0" sldId="366"/>
-            <ac:spMk id="6175" creationId="{00000000-0000-0000-0000-000000000000}"/>
-          </ac:spMkLst>
-        </pc:spChg>
-        <pc:spChg chg="mod">
-          <ac:chgData name="Lines, Todd" userId="afaf7c3a-e8aa-4568-882a-02ad8f9e19b0" providerId="ADAL" clId="{5FF5AC1B-ABA9-43D7-A1E3-2D92732CD6E2}" dt="2026-01-08T21:59:02.138" v="237" actId="1076"/>
-          <ac:spMkLst>
-            <pc:docMk/>
-            <pc:sldMk cId="0" sldId="366"/>
-            <ac:spMk id="6176" creationId="{00000000-0000-0000-0000-000000000000}"/>
-          </ac:spMkLst>
-        </pc:spChg>
-        <pc:spChg chg="mod">
-          <ac:chgData name="Lines, Todd" userId="afaf7c3a-e8aa-4568-882a-02ad8f9e19b0" providerId="ADAL" clId="{5FF5AC1B-ABA9-43D7-A1E3-2D92732CD6E2}" dt="2026-01-08T21:59:02.138" v="237" actId="1076"/>
-          <ac:spMkLst>
-            <pc:docMk/>
-            <pc:sldMk cId="0" sldId="366"/>
-            <ac:spMk id="6177" creationId="{00000000-0000-0000-0000-000000000000}"/>
-          </ac:spMkLst>
-        </pc:spChg>
-        <pc:spChg chg="mod">
-          <ac:chgData name="Lines, Todd" userId="afaf7c3a-e8aa-4568-882a-02ad8f9e19b0" providerId="ADAL" clId="{5FF5AC1B-ABA9-43D7-A1E3-2D92732CD6E2}" dt="2026-01-08T21:59:12.895" v="238" actId="207"/>
-          <ac:spMkLst>
-            <pc:docMk/>
-            <pc:sldMk cId="0" sldId="366"/>
-            <ac:spMk id="6178" creationId="{00000000-0000-0000-0000-000000000000}"/>
-          </ac:spMkLst>
-        </pc:spChg>
-        <pc:grpChg chg="mod">
-          <ac:chgData name="Lines, Todd" userId="afaf7c3a-e8aa-4568-882a-02ad8f9e19b0" providerId="ADAL" clId="{5FF5AC1B-ABA9-43D7-A1E3-2D92732CD6E2}" dt="2026-01-08T21:58:38.927" v="235" actId="207"/>
-          <ac:grpSpMkLst>
-            <pc:docMk/>
-            <pc:sldMk cId="0" sldId="366"/>
-            <ac:grpSpMk id="6150" creationId="{00000000-0000-0000-0000-000000000000}"/>
-          </ac:grpSpMkLst>
-        </pc:grpChg>
-        <pc:grpChg chg="mod">
-          <ac:chgData name="Lines, Todd" userId="afaf7c3a-e8aa-4568-882a-02ad8f9e19b0" providerId="ADAL" clId="{5FF5AC1B-ABA9-43D7-A1E3-2D92732CD6E2}" dt="2026-01-08T21:59:15.276" v="239" actId="207"/>
-          <ac:grpSpMkLst>
-            <pc:docMk/>
-            <pc:sldMk cId="0" sldId="366"/>
-            <ac:grpSpMk id="6151" creationId="{00000000-0000-0000-0000-000000000000}"/>
-          </ac:grpSpMkLst>
-        </pc:grpChg>
-        <pc:graphicFrameChg chg="mod">
-          <ac:chgData name="Lines, Todd" userId="afaf7c3a-e8aa-4568-882a-02ad8f9e19b0" providerId="ADAL" clId="{5FF5AC1B-ABA9-43D7-A1E3-2D92732CD6E2}" dt="2026-01-08T21:20:21.231" v="182" actId="1076"/>
-          <ac:graphicFrameMkLst>
-            <pc:docMk/>
-            <pc:sldMk cId="0" sldId="366"/>
-            <ac:graphicFrameMk id="6155" creationId="{00000000-0000-0000-0000-000000000000}"/>
-          </ac:graphicFrameMkLst>
-        </pc:graphicFrameChg>
-        <pc:graphicFrameChg chg="mod">
-          <ac:chgData name="Lines, Todd" userId="afaf7c3a-e8aa-4568-882a-02ad8f9e19b0" providerId="ADAL" clId="{5FF5AC1B-ABA9-43D7-A1E3-2D92732CD6E2}" dt="2026-01-08T21:20:17.287" v="181" actId="1076"/>
-          <ac:graphicFrameMkLst>
-            <pc:docMk/>
-            <pc:sldMk cId="0" sldId="366"/>
-            <ac:graphicFrameMk id="6159" creationId="{00000000-0000-0000-0000-000000000000}"/>
-          </ac:graphicFrameMkLst>
-        </pc:graphicFrameChg>
-        <pc:graphicFrameChg chg="mod">
-          <ac:chgData name="Lines, Todd" userId="afaf7c3a-e8aa-4568-882a-02ad8f9e19b0" providerId="ADAL" clId="{5FF5AC1B-ABA9-43D7-A1E3-2D92732CD6E2}" dt="2026-01-08T21:20:14.127" v="180" actId="1076"/>
-          <ac:graphicFrameMkLst>
-            <pc:docMk/>
-            <pc:sldMk cId="0" sldId="366"/>
-            <ac:graphicFrameMk id="6161" creationId="{00000000-0000-0000-0000-000000000000}"/>
-          </ac:graphicFrameMkLst>
-        </pc:graphicFrameChg>
-        <pc:picChg chg="del">
-          <ac:chgData name="Lines, Todd" userId="afaf7c3a-e8aa-4568-882a-02ad8f9e19b0" providerId="ADAL" clId="{5FF5AC1B-ABA9-43D7-A1E3-2D92732CD6E2}" dt="2026-01-08T21:59:38.800" v="241" actId="21"/>
-          <ac:picMkLst>
-            <pc:docMk/>
-            <pc:sldMk cId="0" sldId="366"/>
-            <ac:picMk id="3" creationId="{E38C719D-D5E8-8D25-1AE0-EA7314A65928}"/>
-          </ac:picMkLst>
-        </pc:picChg>
-        <pc:picChg chg="del">
-          <ac:chgData name="Lines, Todd" userId="afaf7c3a-e8aa-4568-882a-02ad8f9e19b0" providerId="ADAL" clId="{5FF5AC1B-ABA9-43D7-A1E3-2D92732CD6E2}" dt="2026-01-08T21:59:57.574" v="243" actId="478"/>
-          <ac:picMkLst>
-            <pc:docMk/>
-            <pc:sldMk cId="0" sldId="366"/>
-            <ac:picMk id="4" creationId="{AFD4B73A-C93F-D228-2668-B827D041C345}"/>
-          </ac:picMkLst>
-        </pc:picChg>
-        <pc:picChg chg="del mod">
-          <ac:chgData name="Lines, Todd" userId="afaf7c3a-e8aa-4568-882a-02ad8f9e19b0" providerId="ADAL" clId="{5FF5AC1B-ABA9-43D7-A1E3-2D92732CD6E2}" dt="2026-01-08T22:00:15.909" v="245" actId="21"/>
-          <ac:picMkLst>
-            <pc:docMk/>
-            <pc:sldMk cId="0" sldId="366"/>
-            <ac:picMk id="5" creationId="{7BE4C455-E1DD-C851-C1B7-83FDF4E659B1}"/>
-          </ac:picMkLst>
-        </pc:picChg>
-        <pc:picChg chg="del mod">
-          <ac:chgData name="Lines, Todd" userId="afaf7c3a-e8aa-4568-882a-02ad8f9e19b0" providerId="ADAL" clId="{5FF5AC1B-ABA9-43D7-A1E3-2D92732CD6E2}" dt="2026-01-08T22:00:43.433" v="247" actId="21"/>
-          <ac:picMkLst>
-            <pc:docMk/>
-            <pc:sldMk cId="0" sldId="366"/>
-            <ac:picMk id="6" creationId="{11DCBF48-C19C-03CE-47B4-EB2FC70AA11B}"/>
-          </ac:picMkLst>
-        </pc:picChg>
-        <pc:picChg chg="del">
-          <ac:chgData name="Lines, Todd" userId="afaf7c3a-e8aa-4568-882a-02ad8f9e19b0" providerId="ADAL" clId="{5FF5AC1B-ABA9-43D7-A1E3-2D92732CD6E2}" dt="2026-01-08T23:14:11.422" v="294" actId="21"/>
-          <ac:picMkLst>
-            <pc:docMk/>
-            <pc:sldMk cId="0" sldId="366"/>
-            <ac:picMk id="7" creationId="{AC2BB7F3-43A6-CA69-2885-59A7B19F5026}"/>
-          </ac:picMkLst>
-        </pc:picChg>
-        <pc:picChg chg="del">
-          <ac:chgData name="Lines, Todd" userId="afaf7c3a-e8aa-4568-882a-02ad8f9e19b0" providerId="ADAL" clId="{5FF5AC1B-ABA9-43D7-A1E3-2D92732CD6E2}" dt="2026-01-08T23:14:32.318" v="295" actId="478"/>
-          <ac:picMkLst>
-            <pc:docMk/>
-            <pc:sldMk cId="0" sldId="366"/>
-            <ac:picMk id="8" creationId="{BC11CB57-5A98-6C42-0191-222462C84D16}"/>
-          </ac:picMkLst>
-        </pc:picChg>
-        <pc:picChg chg="del">
-          <ac:chgData name="Lines, Todd" userId="afaf7c3a-e8aa-4568-882a-02ad8f9e19b0" providerId="ADAL" clId="{5FF5AC1B-ABA9-43D7-A1E3-2D92732CD6E2}" dt="2026-01-08T23:14:43.324" v="296" actId="21"/>
-          <ac:picMkLst>
-            <pc:docMk/>
-            <pc:sldMk cId="0" sldId="366"/>
-            <ac:picMk id="9" creationId="{3AE1BCA3-E6C3-D14C-7DDB-B1F15A5B1BA1}"/>
-          </ac:picMkLst>
-        </pc:picChg>
-        <pc:picChg chg="del">
-          <ac:chgData name="Lines, Todd" userId="afaf7c3a-e8aa-4568-882a-02ad8f9e19b0" providerId="ADAL" clId="{5FF5AC1B-ABA9-43D7-A1E3-2D92732CD6E2}" dt="2026-01-08T23:14:59.101" v="297" actId="21"/>
-          <ac:picMkLst>
-            <pc:docMk/>
-            <pc:sldMk cId="0" sldId="366"/>
-            <ac:picMk id="10" creationId="{232DFF27-AAE0-4952-0F31-6EE6E555BE45}"/>
-          </ac:picMkLst>
-        </pc:picChg>
-      </pc:sldChg>
-      <pc:sldChg chg="addSp delSp modSp">
-        <pc:chgData name="Lines, Todd" userId="afaf7c3a-e8aa-4568-882a-02ad8f9e19b0" providerId="ADAL" clId="{5FF5AC1B-ABA9-43D7-A1E3-2D92732CD6E2}" dt="2026-01-08T23:34:52.810" v="397"/>
-        <pc:sldMkLst>
-          <pc:docMk/>
-          <pc:sldMk cId="0" sldId="367"/>
-        </pc:sldMkLst>
-        <pc:spChg chg="mod">
-          <ac:chgData name="Lines, Todd" userId="afaf7c3a-e8aa-4568-882a-02ad8f9e19b0" providerId="ADAL" clId="{5FF5AC1B-ABA9-43D7-A1E3-2D92732CD6E2}" dt="2026-01-08T23:34:52.810" v="397"/>
-          <ac:spMkLst>
-            <pc:docMk/>
-            <pc:sldMk cId="0" sldId="367"/>
-            <ac:spMk id="4" creationId="{F82396EC-7627-C7F7-B8C0-5D6205CB5F54}"/>
-          </ac:spMkLst>
-        </pc:spChg>
-        <pc:spChg chg="mod">
-          <ac:chgData name="Lines, Todd" userId="afaf7c3a-e8aa-4568-882a-02ad8f9e19b0" providerId="ADAL" clId="{5FF5AC1B-ABA9-43D7-A1E3-2D92732CD6E2}" dt="2026-01-08T23:34:52.810" v="397"/>
-          <ac:spMkLst>
-            <pc:docMk/>
-            <pc:sldMk cId="0" sldId="367"/>
-            <ac:spMk id="5" creationId="{27D2D34B-BD2E-B912-B5B6-1C57C6117090}"/>
-          </ac:spMkLst>
-        </pc:spChg>
-        <pc:spChg chg="mod">
-          <ac:chgData name="Lines, Todd" userId="afaf7c3a-e8aa-4568-882a-02ad8f9e19b0" providerId="ADAL" clId="{5FF5AC1B-ABA9-43D7-A1E3-2D92732CD6E2}" dt="2026-01-08T23:34:52.810" v="397"/>
-          <ac:spMkLst>
-            <pc:docMk/>
-            <pc:sldMk cId="0" sldId="367"/>
-            <ac:spMk id="6" creationId="{110FC0EE-4162-7D11-FB89-C5EF9BDB7B4F}"/>
-          </ac:spMkLst>
-        </pc:spChg>
-        <pc:spChg chg="mod">
-          <ac:chgData name="Lines, Todd" userId="afaf7c3a-e8aa-4568-882a-02ad8f9e19b0" providerId="ADAL" clId="{5FF5AC1B-ABA9-43D7-A1E3-2D92732CD6E2}" dt="2026-01-08T23:34:52.810" v="397"/>
-          <ac:spMkLst>
-            <pc:docMk/>
-            <pc:sldMk cId="0" sldId="367"/>
-            <ac:spMk id="8" creationId="{2EC6676D-4246-C14A-7E3C-2056F8764EAE}"/>
-          </ac:spMkLst>
-        </pc:spChg>
-        <pc:spChg chg="mod">
-          <ac:chgData name="Lines, Todd" userId="afaf7c3a-e8aa-4568-882a-02ad8f9e19b0" providerId="ADAL" clId="{5FF5AC1B-ABA9-43D7-A1E3-2D92732CD6E2}" dt="2026-01-08T23:34:52.810" v="397"/>
-          <ac:spMkLst>
-            <pc:docMk/>
-            <pc:sldMk cId="0" sldId="367"/>
-            <ac:spMk id="10" creationId="{2D881EC3-DE5B-AFA2-0E5C-DBFD76936DA9}"/>
-          </ac:spMkLst>
-        </pc:spChg>
-        <pc:spChg chg="mod">
-          <ac:chgData name="Lines, Todd" userId="afaf7c3a-e8aa-4568-882a-02ad8f9e19b0" providerId="ADAL" clId="{5FF5AC1B-ABA9-43D7-A1E3-2D92732CD6E2}" dt="2026-01-08T23:34:52.810" v="397"/>
-          <ac:spMkLst>
-            <pc:docMk/>
-            <pc:sldMk cId="0" sldId="367"/>
-            <ac:spMk id="11" creationId="{3EE7E2A4-37E8-A55A-5550-EDEAAB4D1C1D}"/>
-          </ac:spMkLst>
-        </pc:spChg>
-        <pc:spChg chg="mod">
-          <ac:chgData name="Lines, Todd" userId="afaf7c3a-e8aa-4568-882a-02ad8f9e19b0" providerId="ADAL" clId="{5FF5AC1B-ABA9-43D7-A1E3-2D92732CD6E2}" dt="2026-01-08T23:34:52.810" v="397"/>
-          <ac:spMkLst>
-            <pc:docMk/>
-            <pc:sldMk cId="0" sldId="367"/>
-            <ac:spMk id="13" creationId="{EBDFF7D3-9AA1-78F3-6D6A-85A040BF3819}"/>
-          </ac:spMkLst>
-        </pc:spChg>
-        <pc:spChg chg="mod">
-          <ac:chgData name="Lines, Todd" userId="afaf7c3a-e8aa-4568-882a-02ad8f9e19b0" providerId="ADAL" clId="{5FF5AC1B-ABA9-43D7-A1E3-2D92732CD6E2}" dt="2026-01-08T23:34:52.810" v="397"/>
-          <ac:spMkLst>
-            <pc:docMk/>
-            <pc:sldMk cId="0" sldId="367"/>
-            <ac:spMk id="14" creationId="{3DF22CED-FF3C-6196-ED58-D58739850471}"/>
-          </ac:spMkLst>
-        </pc:spChg>
-        <pc:spChg chg="mod">
-          <ac:chgData name="Lines, Todd" userId="afaf7c3a-e8aa-4568-882a-02ad8f9e19b0" providerId="ADAL" clId="{5FF5AC1B-ABA9-43D7-A1E3-2D92732CD6E2}" dt="2026-01-08T23:34:52.810" v="397"/>
-          <ac:spMkLst>
-            <pc:docMk/>
-            <pc:sldMk cId="0" sldId="367"/>
-            <ac:spMk id="15" creationId="{CE93DF16-F7D0-8C1C-4799-652DA49B42C6}"/>
-          </ac:spMkLst>
-        </pc:spChg>
-        <pc:spChg chg="mod">
-          <ac:chgData name="Lines, Todd" userId="afaf7c3a-e8aa-4568-882a-02ad8f9e19b0" providerId="ADAL" clId="{5FF5AC1B-ABA9-43D7-A1E3-2D92732CD6E2}" dt="2026-01-08T23:34:52.810" v="397"/>
-          <ac:spMkLst>
-            <pc:docMk/>
-            <pc:sldMk cId="0" sldId="367"/>
-            <ac:spMk id="16" creationId="{BD4FCF89-3DD8-CC4C-9385-FCAB1838CBF5}"/>
-          </ac:spMkLst>
-        </pc:spChg>
-        <pc:grpChg chg="del mod">
-          <ac:chgData name="Lines, Todd" userId="afaf7c3a-e8aa-4568-882a-02ad8f9e19b0" providerId="ADAL" clId="{5FF5AC1B-ABA9-43D7-A1E3-2D92732CD6E2}" dt="2026-01-08T23:34:52.171" v="396" actId="478"/>
-          <ac:grpSpMkLst>
-            <pc:docMk/>
-            <pc:sldMk cId="0" sldId="367"/>
-            <ac:grpSpMk id="7175" creationId="{00000000-0000-0000-0000-000000000000}"/>
-          </ac:grpSpMkLst>
-        </pc:grpChg>
-      </pc:sldChg>
-      <pc:sldChg chg="modSp mod">
-        <pc:chgData name="Lines, Todd" userId="afaf7c3a-e8aa-4568-882a-02ad8f9e19b0" providerId="ADAL" clId="{5FF5AC1B-ABA9-43D7-A1E3-2D92732CD6E2}" dt="2026-01-08T23:35:20.436" v="398" actId="207"/>
-        <pc:sldMkLst>
-          <pc:docMk/>
-          <pc:sldMk cId="0" sldId="368"/>
-        </pc:sldMkLst>
-        <pc:spChg chg="mod">
-          <ac:chgData name="Lines, Todd" userId="afaf7c3a-e8aa-4568-882a-02ad8f9e19b0" providerId="ADAL" clId="{5FF5AC1B-ABA9-43D7-A1E3-2D92732CD6E2}" dt="2026-01-08T23:35:20.436" v="398" actId="207"/>
-          <ac:spMkLst>
-            <pc:docMk/>
-            <pc:sldMk cId="0" sldId="368"/>
-            <ac:spMk id="8207" creationId="{00000000-0000-0000-0000-000000000000}"/>
+            <pc:sldMk cId="0" sldId="365"/>
+            <ac:spMk id="5144" creationId="{00000000-0000-0000-0000-000000000000}"/>
           </ac:spMkLst>
         </pc:spChg>
       </pc:sldChg>
-      <pc:sldChg chg="modSp mod">
-        <pc:chgData name="Lines, Todd" userId="afaf7c3a-e8aa-4568-882a-02ad8f9e19b0" providerId="ADAL" clId="{5FF5AC1B-ABA9-43D7-A1E3-2D92732CD6E2}" dt="2026-01-08T23:35:29.721" v="399" actId="207"/>
-        <pc:sldMkLst>
-          <pc:docMk/>
-          <pc:sldMk cId="0" sldId="369"/>
-        </pc:sldMkLst>
-        <pc:spChg chg="mod">
-          <ac:chgData name="Lines, Todd" userId="afaf7c3a-e8aa-4568-882a-02ad8f9e19b0" providerId="ADAL" clId="{5FF5AC1B-ABA9-43D7-A1E3-2D92732CD6E2}" dt="2026-01-08T23:35:29.721" v="399" actId="207"/>
-          <ac:spMkLst>
-            <pc:docMk/>
-            <pc:sldMk cId="0" sldId="369"/>
-            <ac:spMk id="9223" creationId="{00000000-0000-0000-0000-000000000000}"/>
-          </ac:spMkLst>
-        </pc:spChg>
-        <pc:spChg chg="mod">
-          <ac:chgData name="Lines, Todd" userId="afaf7c3a-e8aa-4568-882a-02ad8f9e19b0" providerId="ADAL" clId="{5FF5AC1B-ABA9-43D7-A1E3-2D92732CD6E2}" dt="2026-01-08T23:35:29.721" v="399" actId="207"/>
-          <ac:spMkLst>
-            <pc:docMk/>
-            <pc:sldMk cId="0" sldId="369"/>
-            <ac:spMk id="9233" creationId="{00000000-0000-0000-0000-000000000000}"/>
-          </ac:spMkLst>
-        </pc:spChg>
-        <pc:spChg chg="mod">
-          <ac:chgData name="Lines, Todd" userId="afaf7c3a-e8aa-4568-882a-02ad8f9e19b0" providerId="ADAL" clId="{5FF5AC1B-ABA9-43D7-A1E3-2D92732CD6E2}" dt="2026-01-08T23:35:29.721" v="399" actId="207"/>
-          <ac:spMkLst>
-            <pc:docMk/>
-            <pc:sldMk cId="0" sldId="369"/>
-            <ac:spMk id="9244" creationId="{00000000-0000-0000-0000-000000000000}"/>
-          </ac:spMkLst>
-        </pc:spChg>
-        <pc:spChg chg="mod">
-          <ac:chgData name="Lines, Todd" userId="afaf7c3a-e8aa-4568-882a-02ad8f9e19b0" providerId="ADAL" clId="{5FF5AC1B-ABA9-43D7-A1E3-2D92732CD6E2}" dt="2026-01-08T23:35:29.721" v="399" actId="207"/>
-          <ac:spMkLst>
-            <pc:docMk/>
-            <pc:sldMk cId="0" sldId="369"/>
-            <ac:spMk id="9253" creationId="{00000000-0000-0000-0000-000000000000}"/>
-          </ac:spMkLst>
-        </pc:spChg>
-      </pc:sldChg>
-      <pc:sldChg chg="modSp mod">
-        <pc:chgData name="Lines, Todd" userId="afaf7c3a-e8aa-4568-882a-02ad8f9e19b0" providerId="ADAL" clId="{5FF5AC1B-ABA9-43D7-A1E3-2D92732CD6E2}" dt="2026-01-08T23:35:35.804" v="400" actId="207"/>
-        <pc:sldMkLst>
-          <pc:docMk/>
-          <pc:sldMk cId="0" sldId="370"/>
-        </pc:sldMkLst>
-        <pc:spChg chg="mod">
-          <ac:chgData name="Lines, Todd" userId="afaf7c3a-e8aa-4568-882a-02ad8f9e19b0" providerId="ADAL" clId="{5FF5AC1B-ABA9-43D7-A1E3-2D92732CD6E2}" dt="2026-01-08T23:35:35.804" v="400" actId="207"/>
-          <ac:spMkLst>
-            <pc:docMk/>
-            <pc:sldMk cId="0" sldId="370"/>
-            <ac:spMk id="10256" creationId="{00000000-0000-0000-0000-000000000000}"/>
-          </ac:spMkLst>
-        </pc:spChg>
-      </pc:sldChg>
-      <pc:sldChg chg="modSp mod">
-        <pc:chgData name="Lines, Todd" userId="afaf7c3a-e8aa-4568-882a-02ad8f9e19b0" providerId="ADAL" clId="{5FF5AC1B-ABA9-43D7-A1E3-2D92732CD6E2}" dt="2026-01-08T21:21:14.224" v="185" actId="1076"/>
+      <pc:sldChg chg="addSp delSp modSp mod">
+        <pc:chgData name="Lines, Todd" userId="afaf7c3a-e8aa-4568-882a-02ad8f9e19b0" providerId="ADAL" clId="{5FF5AC1B-ABA9-43D7-A1E3-2D92732CD6E2}" dt="2026-04-22T20:40:50.491" v="463" actId="1076"/>
         <pc:sldMkLst>
           <pc:docMk/>
           <pc:sldMk cId="0" sldId="376"/>
         </pc:sldMkLst>
+        <pc:spChg chg="mod">
+          <ac:chgData name="Lines, Todd" userId="afaf7c3a-e8aa-4568-882a-02ad8f9e19b0" providerId="ADAL" clId="{5FF5AC1B-ABA9-43D7-A1E3-2D92732CD6E2}" dt="2026-04-22T20:40:43.061" v="460" actId="20577"/>
+          <ac:spMkLst>
+            <pc:docMk/>
+            <pc:sldMk cId="0" sldId="376"/>
+            <ac:spMk id="13316" creationId="{00000000-0000-0000-0000-000000000000}"/>
+          </ac:spMkLst>
+        </pc:spChg>
+        <pc:spChg chg="add mod">
+          <ac:chgData name="Lines, Todd" userId="afaf7c3a-e8aa-4568-882a-02ad8f9e19b0" providerId="ADAL" clId="{5FF5AC1B-ABA9-43D7-A1E3-2D92732CD6E2}" dt="2026-04-22T20:40:50.491" v="463" actId="1076"/>
+          <ac:spMkLst>
+            <pc:docMk/>
+            <pc:sldMk cId="0" sldId="376"/>
+            <ac:spMk id="13323" creationId="{00000000-0000-0000-0000-000000000000}"/>
+          </ac:spMkLst>
+        </pc:spChg>
+        <pc:graphicFrameChg chg="del mod replId">
+          <ac:chgData name="Lines, Todd" userId="afaf7c3a-e8aa-4568-882a-02ad8f9e19b0" providerId="ADAL" clId="{5FF5AC1B-ABA9-43D7-A1E3-2D92732CD6E2}" dt="2026-04-22T20:38:19.959" v="406"/>
+          <ac:graphicFrameMkLst>
+            <pc:docMk/>
+            <pc:sldMk cId="0" sldId="376"/>
+            <ac:graphicFrameMk id="2" creationId="{00000000-0000-0000-0000-000000000000}"/>
+          </ac:graphicFrameMkLst>
+        </pc:graphicFrameChg>
         <pc:graphicFrameChg chg="mod">
-          <ac:chgData name="Lines, Todd" userId="afaf7c3a-e8aa-4568-882a-02ad8f9e19b0" providerId="ADAL" clId="{5FF5AC1B-ABA9-43D7-A1E3-2D92732CD6E2}" dt="2026-01-08T21:21:14.224" v="185" actId="1076"/>
+          <ac:chgData name="Lines, Todd" userId="afaf7c3a-e8aa-4568-882a-02ad8f9e19b0" providerId="ADAL" clId="{5FF5AC1B-ABA9-43D7-A1E3-2D92732CD6E2}" dt="2026-04-22T20:40:27.908" v="454" actId="1076"/>
+          <ac:graphicFrameMkLst>
+            <pc:docMk/>
+            <pc:sldMk cId="0" sldId="376"/>
+            <ac:graphicFrameMk id="13318" creationId="{00000000-0000-0000-0000-000000000000}"/>
+          </ac:graphicFrameMkLst>
+        </pc:graphicFrameChg>
+        <pc:graphicFrameChg chg="mod">
+          <ac:chgData name="Lines, Todd" userId="afaf7c3a-e8aa-4568-882a-02ad8f9e19b0" providerId="ADAL" clId="{5FF5AC1B-ABA9-43D7-A1E3-2D92732CD6E2}" dt="2026-04-22T20:40:34.429" v="457" actId="1076"/>
           <ac:graphicFrameMkLst>
             <pc:docMk/>
             <pc:sldMk cId="0" sldId="376"/>
@@ -732,416 +233,91 @@
           </ac:graphicFrameMkLst>
         </pc:graphicFrameChg>
       </pc:sldChg>
-      <pc:sldChg chg="addSp delSp modSp mod">
-        <pc:chgData name="Lines, Todd" userId="afaf7c3a-e8aa-4568-882a-02ad8f9e19b0" providerId="ADAL" clId="{5FF5AC1B-ABA9-43D7-A1E3-2D92732CD6E2}" dt="2026-01-08T21:15:17.800" v="98" actId="20577"/>
+      <pc:sldChg chg="modSp mod">
+        <pc:chgData name="Lines, Todd" userId="afaf7c3a-e8aa-4568-882a-02ad8f9e19b0" providerId="ADAL" clId="{5FF5AC1B-ABA9-43D7-A1E3-2D92732CD6E2}" dt="2026-04-22T20:41:11.002" v="468" actId="1076"/>
         <pc:sldMkLst>
           <pc:docMk/>
-          <pc:sldMk cId="2400374094" sldId="402"/>
+          <pc:sldMk cId="0" sldId="377"/>
         </pc:sldMkLst>
-        <pc:spChg chg="add del">
-          <ac:chgData name="Lines, Todd" userId="afaf7c3a-e8aa-4568-882a-02ad8f9e19b0" providerId="ADAL" clId="{5FF5AC1B-ABA9-43D7-A1E3-2D92732CD6E2}" dt="2026-01-08T21:08:31.305" v="6" actId="478"/>
+        <pc:graphicFrameChg chg="mod ord">
+          <ac:chgData name="Lines, Todd" userId="afaf7c3a-e8aa-4568-882a-02ad8f9e19b0" providerId="ADAL" clId="{5FF5AC1B-ABA9-43D7-A1E3-2D92732CD6E2}" dt="2026-04-22T20:41:11.002" v="468" actId="1076"/>
+          <ac:graphicFrameMkLst>
+            <pc:docMk/>
+            <pc:sldMk cId="0" sldId="377"/>
+            <ac:graphicFrameMk id="14343" creationId="{00000000-0000-0000-0000-000000000000}"/>
+          </ac:graphicFrameMkLst>
+        </pc:graphicFrameChg>
+      </pc:sldChg>
+      <pc:sldChg chg="addSp delSp modSp mod">
+        <pc:chgData name="Lines, Todd" userId="afaf7c3a-e8aa-4568-882a-02ad8f9e19b0" providerId="ADAL" clId="{5FF5AC1B-ABA9-43D7-A1E3-2D92732CD6E2}" dt="2026-04-22T20:42:07.520" v="497" actId="20577"/>
+        <pc:sldMkLst>
+          <pc:docMk/>
+          <pc:sldMk cId="0" sldId="380"/>
+        </pc:sldMkLst>
+        <pc:spChg chg="add mod">
+          <ac:chgData name="Lines, Todd" userId="afaf7c3a-e8aa-4568-882a-02ad8f9e19b0" providerId="ADAL" clId="{5FF5AC1B-ABA9-43D7-A1E3-2D92732CD6E2}" dt="2026-04-22T20:41:38.723" v="478" actId="20577"/>
           <ac:spMkLst>
             <pc:docMk/>
-            <pc:sldMk cId="2400374094" sldId="402"/>
-            <ac:spMk id="2" creationId="{A9EAACB7-20D6-8601-FFC4-98CED63D9532}"/>
+            <pc:sldMk cId="0" sldId="380"/>
+            <ac:spMk id="17414" creationId="{00000000-0000-0000-0000-000000000000}"/>
           </ac:spMkLst>
         </pc:spChg>
         <pc:spChg chg="add mod">
-          <ac:chgData name="Lines, Todd" userId="afaf7c3a-e8aa-4568-882a-02ad8f9e19b0" providerId="ADAL" clId="{5FF5AC1B-ABA9-43D7-A1E3-2D92732CD6E2}" dt="2026-01-08T21:14:32.266" v="93" actId="207"/>
+          <ac:chgData name="Lines, Todd" userId="afaf7c3a-e8aa-4568-882a-02ad8f9e19b0" providerId="ADAL" clId="{5FF5AC1B-ABA9-43D7-A1E3-2D92732CD6E2}" dt="2026-04-22T20:41:27.353" v="473" actId="20577"/>
           <ac:spMkLst>
             <pc:docMk/>
-            <pc:sldMk cId="2400374094" sldId="402"/>
-            <ac:spMk id="3" creationId="{D163155F-F055-36CA-0716-A54E34E207F4}"/>
+            <pc:sldMk cId="0" sldId="380"/>
+            <ac:spMk id="17418" creationId="{00000000-0000-0000-0000-000000000000}"/>
           </ac:spMkLst>
         </pc:spChg>
         <pc:spChg chg="add mod">
-          <ac:chgData name="Lines, Todd" userId="afaf7c3a-e8aa-4568-882a-02ad8f9e19b0" providerId="ADAL" clId="{5FF5AC1B-ABA9-43D7-A1E3-2D92732CD6E2}" dt="2026-01-08T21:11:10.235" v="64" actId="1076"/>
+          <ac:chgData name="Lines, Todd" userId="afaf7c3a-e8aa-4568-882a-02ad8f9e19b0" providerId="ADAL" clId="{5FF5AC1B-ABA9-43D7-A1E3-2D92732CD6E2}" dt="2026-04-22T20:42:07.520" v="497" actId="20577"/>
           <ac:spMkLst>
             <pc:docMk/>
-            <pc:sldMk cId="2400374094" sldId="402"/>
-            <ac:spMk id="4" creationId="{3EF28A57-888A-A2E5-DA02-19020A0C493F}"/>
-          </ac:spMkLst>
-        </pc:spChg>
-        <pc:spChg chg="add del">
-          <ac:chgData name="Lines, Todd" userId="afaf7c3a-e8aa-4568-882a-02ad8f9e19b0" providerId="ADAL" clId="{5FF5AC1B-ABA9-43D7-A1E3-2D92732CD6E2}" dt="2026-01-08T21:11:59.313" v="68" actId="478"/>
-          <ac:spMkLst>
-            <pc:docMk/>
-            <pc:sldMk cId="2400374094" sldId="402"/>
-            <ac:spMk id="5" creationId="{9731CB6C-10EC-188C-E63D-13EE70299FE8}"/>
-          </ac:spMkLst>
-        </pc:spChg>
-        <pc:spChg chg="add del mod">
-          <ac:chgData name="Lines, Todd" userId="afaf7c3a-e8aa-4568-882a-02ad8f9e19b0" providerId="ADAL" clId="{5FF5AC1B-ABA9-43D7-A1E3-2D92732CD6E2}" dt="2026-01-08T21:12:44.974" v="73" actId="478"/>
-          <ac:spMkLst>
-            <pc:docMk/>
-            <pc:sldMk cId="2400374094" sldId="402"/>
-            <ac:spMk id="6" creationId="{1ACA707B-4AF2-E66D-C465-1B04F5EBD994}"/>
+            <pc:sldMk cId="0" sldId="380"/>
+            <ac:spMk id="17420" creationId="{00000000-0000-0000-0000-000000000000}"/>
           </ac:spMkLst>
         </pc:spChg>
         <pc:spChg chg="add mod">
-          <ac:chgData name="Lines, Todd" userId="afaf7c3a-e8aa-4568-882a-02ad8f9e19b0" providerId="ADAL" clId="{5FF5AC1B-ABA9-43D7-A1E3-2D92732CD6E2}" dt="2026-01-08T21:13:46.522" v="85" actId="164"/>
+          <ac:chgData name="Lines, Todd" userId="afaf7c3a-e8aa-4568-882a-02ad8f9e19b0" providerId="ADAL" clId="{5FF5AC1B-ABA9-43D7-A1E3-2D92732CD6E2}" dt="2026-04-22T20:41:52.778" v="486" actId="1076"/>
           <ac:spMkLst>
             <pc:docMk/>
-            <pc:sldMk cId="2400374094" sldId="402"/>
-            <ac:spMk id="7" creationId="{326745CC-438A-2784-8EB9-978AC48E2F0B}"/>
+            <pc:sldMk cId="0" sldId="380"/>
+            <ac:spMk id="17422" creationId="{00000000-0000-0000-0000-000000000000}"/>
           </ac:spMkLst>
         </pc:spChg>
-        <pc:spChg chg="add mod">
-          <ac:chgData name="Lines, Todd" userId="afaf7c3a-e8aa-4568-882a-02ad8f9e19b0" providerId="ADAL" clId="{5FF5AC1B-ABA9-43D7-A1E3-2D92732CD6E2}" dt="2026-01-08T21:13:46.522" v="85" actId="164"/>
-          <ac:spMkLst>
+        <pc:graphicFrameChg chg="del mod replId">
+          <ac:chgData name="Lines, Todd" userId="afaf7c3a-e8aa-4568-882a-02ad8f9e19b0" providerId="ADAL" clId="{5FF5AC1B-ABA9-43D7-A1E3-2D92732CD6E2}" dt="2026-04-22T20:41:23.126" v="470"/>
+          <ac:graphicFrameMkLst>
             <pc:docMk/>
-            <pc:sldMk cId="2400374094" sldId="402"/>
-            <ac:spMk id="8" creationId="{378BBCC4-1862-F325-561B-9C4493496212}"/>
-          </ac:spMkLst>
-        </pc:spChg>
-        <pc:spChg chg="add mod">
-          <ac:chgData name="Lines, Todd" userId="afaf7c3a-e8aa-4568-882a-02ad8f9e19b0" providerId="ADAL" clId="{5FF5AC1B-ABA9-43D7-A1E3-2D92732CD6E2}" dt="2026-01-08T21:14:10.854" v="92" actId="14100"/>
-          <ac:spMkLst>
+            <pc:sldMk cId="0" sldId="380"/>
+            <ac:graphicFrameMk id="2" creationId="{00000000-0000-0000-0000-000000000000}"/>
+          </ac:graphicFrameMkLst>
+        </pc:graphicFrameChg>
+        <pc:graphicFrameChg chg="del mod replId">
+          <ac:chgData name="Lines, Todd" userId="afaf7c3a-e8aa-4568-882a-02ad8f9e19b0" providerId="ADAL" clId="{5FF5AC1B-ABA9-43D7-A1E3-2D92732CD6E2}" dt="2026-04-22T20:41:35.319" v="475"/>
+          <ac:graphicFrameMkLst>
             <pc:docMk/>
-            <pc:sldMk cId="2400374094" sldId="402"/>
-            <ac:spMk id="10" creationId="{4B430866-DCF2-2003-4EC1-754BDA995C29}"/>
-          </ac:spMkLst>
-        </pc:spChg>
-        <pc:spChg chg="mod">
-          <ac:chgData name="Lines, Todd" userId="afaf7c3a-e8aa-4568-882a-02ad8f9e19b0" providerId="ADAL" clId="{5FF5AC1B-ABA9-43D7-A1E3-2D92732CD6E2}" dt="2026-01-08T21:15:17.800" v="98" actId="20577"/>
-          <ac:spMkLst>
+            <pc:sldMk cId="0" sldId="380"/>
+            <ac:graphicFrameMk id="4" creationId="{00000000-0000-0000-0000-000000000000}"/>
+          </ac:graphicFrameMkLst>
+        </pc:graphicFrameChg>
+        <pc:graphicFrameChg chg="del mod replId">
+          <ac:chgData name="Lines, Todd" userId="afaf7c3a-e8aa-4568-882a-02ad8f9e19b0" providerId="ADAL" clId="{5FF5AC1B-ABA9-43D7-A1E3-2D92732CD6E2}" dt="2026-04-22T20:41:43.019" v="480"/>
+          <ac:graphicFrameMkLst>
             <pc:docMk/>
-            <pc:sldMk cId="2400374094" sldId="402"/>
-            <ac:spMk id="27652" creationId="{00000000-0000-0000-0000-000000000000}"/>
-          </ac:spMkLst>
-        </pc:spChg>
-        <pc:spChg chg="del mod">
-          <ac:chgData name="Lines, Todd" userId="afaf7c3a-e8aa-4568-882a-02ad8f9e19b0" providerId="ADAL" clId="{5FF5AC1B-ABA9-43D7-A1E3-2D92732CD6E2}" dt="2026-01-08T21:13:48.671" v="86" actId="478"/>
-          <ac:spMkLst>
+            <pc:sldMk cId="0" sldId="380"/>
+            <ac:graphicFrameMk id="6" creationId="{00000000-0000-0000-0000-000000000000}"/>
+          </ac:graphicFrameMkLst>
+        </pc:graphicFrameChg>
+        <pc:graphicFrameChg chg="del mod replId">
+          <ac:chgData name="Lines, Todd" userId="afaf7c3a-e8aa-4568-882a-02ad8f9e19b0" providerId="ADAL" clId="{5FF5AC1B-ABA9-43D7-A1E3-2D92732CD6E2}" dt="2026-04-22T20:41:56.210" v="488"/>
+          <ac:graphicFrameMkLst>
             <pc:docMk/>
-            <pc:sldMk cId="2400374094" sldId="402"/>
-            <ac:spMk id="27653" creationId="{00000000-0000-0000-0000-000000000000}"/>
-          </ac:spMkLst>
-        </pc:spChg>
-        <pc:spChg chg="mod">
-          <ac:chgData name="Lines, Todd" userId="afaf7c3a-e8aa-4568-882a-02ad8f9e19b0" providerId="ADAL" clId="{5FF5AC1B-ABA9-43D7-A1E3-2D92732CD6E2}" dt="2026-01-08T21:07:34.201" v="4" actId="1076"/>
-          <ac:spMkLst>
-            <pc:docMk/>
-            <pc:sldMk cId="2400374094" sldId="402"/>
-            <ac:spMk id="27654" creationId="{00000000-0000-0000-0000-000000000000}"/>
-          </ac:spMkLst>
-        </pc:spChg>
-        <pc:spChg chg="mod">
-          <ac:chgData name="Lines, Todd" userId="afaf7c3a-e8aa-4568-882a-02ad8f9e19b0" providerId="ADAL" clId="{5FF5AC1B-ABA9-43D7-A1E3-2D92732CD6E2}" dt="2026-01-08T21:06:55.465" v="1" actId="207"/>
-          <ac:spMkLst>
-            <pc:docMk/>
-            <pc:sldMk cId="2400374094" sldId="402"/>
-            <ac:spMk id="27655" creationId="{00000000-0000-0000-0000-000000000000}"/>
-          </ac:spMkLst>
-        </pc:spChg>
-        <pc:spChg chg="mod">
-          <ac:chgData name="Lines, Todd" userId="afaf7c3a-e8aa-4568-882a-02ad8f9e19b0" providerId="ADAL" clId="{5FF5AC1B-ABA9-43D7-A1E3-2D92732CD6E2}" dt="2026-01-08T21:06:48.609" v="0" actId="207"/>
-          <ac:spMkLst>
-            <pc:docMk/>
-            <pc:sldMk cId="2400374094" sldId="402"/>
-            <ac:spMk id="27656" creationId="{00000000-0000-0000-0000-000000000000}"/>
-          </ac:spMkLst>
-        </pc:spChg>
-        <pc:spChg chg="mod ord">
-          <ac:chgData name="Lines, Todd" userId="afaf7c3a-e8aa-4568-882a-02ad8f9e19b0" providerId="ADAL" clId="{5FF5AC1B-ABA9-43D7-A1E3-2D92732CD6E2}" dt="2026-01-08T21:11:17.651" v="65" actId="166"/>
-          <ac:spMkLst>
-            <pc:docMk/>
-            <pc:sldMk cId="2400374094" sldId="402"/>
-            <ac:spMk id="27657" creationId="{00000000-0000-0000-0000-000000000000}"/>
-          </ac:spMkLst>
-        </pc:spChg>
-        <pc:spChg chg="mod">
-          <ac:chgData name="Lines, Todd" userId="afaf7c3a-e8aa-4568-882a-02ad8f9e19b0" providerId="ADAL" clId="{5FF5AC1B-ABA9-43D7-A1E3-2D92732CD6E2}" dt="2026-01-08T21:14:49.692" v="94" actId="1076"/>
-          <ac:spMkLst>
-            <pc:docMk/>
-            <pc:sldMk cId="2400374094" sldId="402"/>
-            <ac:spMk id="27659" creationId="{00000000-0000-0000-0000-000000000000}"/>
-          </ac:spMkLst>
-        </pc:spChg>
-        <pc:spChg chg="mod">
-          <ac:chgData name="Lines, Todd" userId="afaf7c3a-e8aa-4568-882a-02ad8f9e19b0" providerId="ADAL" clId="{5FF5AC1B-ABA9-43D7-A1E3-2D92732CD6E2}" dt="2026-01-08T21:07:06.263" v="2" actId="207"/>
-          <ac:spMkLst>
-            <pc:docMk/>
-            <pc:sldMk cId="2400374094" sldId="402"/>
-            <ac:spMk id="27665" creationId="{00000000-0000-0000-0000-000000000000}"/>
-          </ac:spMkLst>
-        </pc:spChg>
-        <pc:grpChg chg="add mod ord">
-          <ac:chgData name="Lines, Todd" userId="afaf7c3a-e8aa-4568-882a-02ad8f9e19b0" providerId="ADAL" clId="{5FF5AC1B-ABA9-43D7-A1E3-2D92732CD6E2}" dt="2026-01-08T21:13:58.804" v="89" actId="1076"/>
-          <ac:grpSpMkLst>
-            <pc:docMk/>
-            <pc:sldMk cId="2400374094" sldId="402"/>
-            <ac:grpSpMk id="9" creationId="{7C4A2966-EBB9-8FE6-C85E-EE408F251F34}"/>
-          </ac:grpSpMkLst>
-        </pc:grpChg>
-      </pc:sldChg>
-      <pc:sldChg chg="modSp mod">
-        <pc:chgData name="Lines, Todd" userId="afaf7c3a-e8aa-4568-882a-02ad8f9e19b0" providerId="ADAL" clId="{5FF5AC1B-ABA9-43D7-A1E3-2D92732CD6E2}" dt="2026-01-08T21:16:14.150" v="99" actId="207"/>
-        <pc:sldMkLst>
-          <pc:docMk/>
-          <pc:sldMk cId="0" sldId="407"/>
-        </pc:sldMkLst>
-        <pc:spChg chg="mod">
-          <ac:chgData name="Lines, Todd" userId="afaf7c3a-e8aa-4568-882a-02ad8f9e19b0" providerId="ADAL" clId="{5FF5AC1B-ABA9-43D7-A1E3-2D92732CD6E2}" dt="2026-01-08T21:16:14.150" v="99" actId="207"/>
-          <ac:spMkLst>
-            <pc:docMk/>
-            <pc:sldMk cId="0" sldId="407"/>
-            <ac:spMk id="27671" creationId="{00000000-0000-0000-0000-000000000000}"/>
-          </ac:spMkLst>
-        </pc:spChg>
-      </pc:sldChg>
-      <pc:sldChg chg="delSp modSp new mod">
-        <pc:chgData name="Lines, Todd" userId="afaf7c3a-e8aa-4568-882a-02ad8f9e19b0" providerId="ADAL" clId="{5FF5AC1B-ABA9-43D7-A1E3-2D92732CD6E2}" dt="2026-01-08T21:38:32.200" v="229" actId="27636"/>
-        <pc:sldMkLst>
-          <pc:docMk/>
-          <pc:sldMk cId="1413985921" sldId="413"/>
-        </pc:sldMkLst>
-        <pc:spChg chg="del">
-          <ac:chgData name="Lines, Todd" userId="afaf7c3a-e8aa-4568-882a-02ad8f9e19b0" providerId="ADAL" clId="{5FF5AC1B-ABA9-43D7-A1E3-2D92732CD6E2}" dt="2026-01-08T21:37:01.250" v="212" actId="478"/>
-          <ac:spMkLst>
-            <pc:docMk/>
-            <pc:sldMk cId="1413985921" sldId="413"/>
-            <ac:spMk id="2" creationId="{15A87B99-043E-10F4-7C22-8358F94A7440}"/>
-          </ac:spMkLst>
-        </pc:spChg>
-        <pc:spChg chg="mod">
-          <ac:chgData name="Lines, Todd" userId="afaf7c3a-e8aa-4568-882a-02ad8f9e19b0" providerId="ADAL" clId="{5FF5AC1B-ABA9-43D7-A1E3-2D92732CD6E2}" dt="2026-01-08T21:38:32.200" v="229" actId="27636"/>
-          <ac:spMkLst>
-            <pc:docMk/>
-            <pc:sldMk cId="1413985921" sldId="413"/>
-            <ac:spMk id="3" creationId="{B261AE2D-6D1D-1E90-BAFF-5A2311FC25D9}"/>
-          </ac:spMkLst>
-        </pc:spChg>
-      </pc:sldChg>
-      <pc:sldChg chg="addSp delSp modSp new mod">
-        <pc:chgData name="Lines, Todd" userId="afaf7c3a-e8aa-4568-882a-02ad8f9e19b0" providerId="ADAL" clId="{5FF5AC1B-ABA9-43D7-A1E3-2D92732CD6E2}" dt="2026-01-08T23:39:47.747" v="402" actId="21"/>
-        <pc:sldMkLst>
-          <pc:docMk/>
-          <pc:sldMk cId="179835989" sldId="414"/>
-        </pc:sldMkLst>
-        <pc:spChg chg="del">
-          <ac:chgData name="Lines, Todd" userId="afaf7c3a-e8aa-4568-882a-02ad8f9e19b0" providerId="ADAL" clId="{5FF5AC1B-ABA9-43D7-A1E3-2D92732CD6E2}" dt="2026-01-08T22:44:01.900" v="255" actId="478"/>
-          <ac:spMkLst>
-            <pc:docMk/>
-            <pc:sldMk cId="179835989" sldId="414"/>
-            <ac:spMk id="2" creationId="{AFAE0D5C-FB39-C2FE-506A-300D2F18B378}"/>
-          </ac:spMkLst>
-        </pc:spChg>
-        <pc:spChg chg="del">
-          <ac:chgData name="Lines, Todd" userId="afaf7c3a-e8aa-4568-882a-02ad8f9e19b0" providerId="ADAL" clId="{5FF5AC1B-ABA9-43D7-A1E3-2D92732CD6E2}" dt="2026-01-08T22:44:00.612" v="254" actId="478"/>
-          <ac:spMkLst>
-            <pc:docMk/>
-            <pc:sldMk cId="179835989" sldId="414"/>
-            <ac:spMk id="3" creationId="{BCE97C30-20EF-1E70-1D45-E91F11935F67}"/>
-          </ac:spMkLst>
-        </pc:spChg>
-        <pc:spChg chg="add">
-          <ac:chgData name="Lines, Todd" userId="afaf7c3a-e8aa-4568-882a-02ad8f9e19b0" providerId="ADAL" clId="{5FF5AC1B-ABA9-43D7-A1E3-2D92732CD6E2}" dt="2026-01-08T22:44:11.786" v="257" actId="11529"/>
-          <ac:spMkLst>
-            <pc:docMk/>
-            <pc:sldMk cId="179835989" sldId="414"/>
-            <ac:spMk id="6" creationId="{E8C19F6B-3C89-018C-164D-640DADACD52C}"/>
-          </ac:spMkLst>
-        </pc:spChg>
-        <pc:spChg chg="add mod">
-          <ac:chgData name="Lines, Todd" userId="afaf7c3a-e8aa-4568-882a-02ad8f9e19b0" providerId="ADAL" clId="{5FF5AC1B-ABA9-43D7-A1E3-2D92732CD6E2}" dt="2026-01-08T22:45:57.679" v="281" actId="1076"/>
-          <ac:spMkLst>
-            <pc:docMk/>
-            <pc:sldMk cId="179835989" sldId="414"/>
-            <ac:spMk id="16" creationId="{2789F83D-FD8C-ECAD-FDA5-8FD4D44F513F}"/>
-          </ac:spMkLst>
-        </pc:spChg>
-        <pc:spChg chg="add mod">
-          <ac:chgData name="Lines, Todd" userId="afaf7c3a-e8aa-4568-882a-02ad8f9e19b0" providerId="ADAL" clId="{5FF5AC1B-ABA9-43D7-A1E3-2D92732CD6E2}" dt="2026-01-08T22:46:10.566" v="286" actId="20577"/>
-          <ac:spMkLst>
-            <pc:docMk/>
-            <pc:sldMk cId="179835989" sldId="414"/>
-            <ac:spMk id="17" creationId="{E337BED4-5D27-E7B4-1FA6-AA2E0BEB8E3F}"/>
-          </ac:spMkLst>
-        </pc:spChg>
-        <pc:spChg chg="add mod">
-          <ac:chgData name="Lines, Todd" userId="afaf7c3a-e8aa-4568-882a-02ad8f9e19b0" providerId="ADAL" clId="{5FF5AC1B-ABA9-43D7-A1E3-2D92732CD6E2}" dt="2026-01-08T22:46:20.120" v="291" actId="20577"/>
-          <ac:spMkLst>
-            <pc:docMk/>
-            <pc:sldMk cId="179835989" sldId="414"/>
-            <ac:spMk id="18" creationId="{8EC256E5-826A-321E-EBE6-2857D1C22954}"/>
-          </ac:spMkLst>
-        </pc:spChg>
-        <pc:picChg chg="add mod">
-          <ac:chgData name="Lines, Todd" userId="afaf7c3a-e8aa-4568-882a-02ad8f9e19b0" providerId="ADAL" clId="{5FF5AC1B-ABA9-43D7-A1E3-2D92732CD6E2}" dt="2026-01-08T22:44:05.537" v="256" actId="1076"/>
-          <ac:picMkLst>
-            <pc:docMk/>
-            <pc:sldMk cId="179835989" sldId="414"/>
-            <ac:picMk id="5" creationId="{4D09A63A-F006-E248-95B0-24F9C5360C45}"/>
-          </ac:picMkLst>
-        </pc:picChg>
-        <pc:picChg chg="del mod">
-          <ac:chgData name="Lines, Todd" userId="afaf7c3a-e8aa-4568-882a-02ad8f9e19b0" providerId="ADAL" clId="{5FF5AC1B-ABA9-43D7-A1E3-2D92732CD6E2}" dt="2026-01-08T22:47:01.477" v="293" actId="21"/>
-          <ac:picMkLst>
-            <pc:docMk/>
-            <pc:sldMk cId="179835989" sldId="414"/>
-            <ac:picMk id="19" creationId="{D6605500-B939-92CC-6644-94E429A347E7}"/>
-          </ac:picMkLst>
-        </pc:picChg>
-        <pc:picChg chg="del mod">
-          <ac:chgData name="Lines, Todd" userId="afaf7c3a-e8aa-4568-882a-02ad8f9e19b0" providerId="ADAL" clId="{5FF5AC1B-ABA9-43D7-A1E3-2D92732CD6E2}" dt="2026-01-08T23:39:47.747" v="402" actId="21"/>
-          <ac:picMkLst>
-            <pc:docMk/>
-            <pc:sldMk cId="179835989" sldId="414"/>
-            <ac:picMk id="20" creationId="{731DDA73-3679-9830-1AC2-66A6E4DAA6C1}"/>
-          </ac:picMkLst>
-        </pc:picChg>
-        <pc:cxnChg chg="add mod">
-          <ac:chgData name="Lines, Todd" userId="afaf7c3a-e8aa-4568-882a-02ad8f9e19b0" providerId="ADAL" clId="{5FF5AC1B-ABA9-43D7-A1E3-2D92732CD6E2}" dt="2026-01-08T22:45:13.892" v="270" actId="1076"/>
-          <ac:cxnSpMkLst>
-            <pc:docMk/>
-            <pc:sldMk cId="179835989" sldId="414"/>
-            <ac:cxnSpMk id="8" creationId="{21956C4F-4D87-9954-650C-1A9496D5708F}"/>
-          </ac:cxnSpMkLst>
-        </pc:cxnChg>
-        <pc:cxnChg chg="add del mod">
-          <ac:chgData name="Lines, Todd" userId="afaf7c3a-e8aa-4568-882a-02ad8f9e19b0" providerId="ADAL" clId="{5FF5AC1B-ABA9-43D7-A1E3-2D92732CD6E2}" dt="2026-01-08T22:45:05.245" v="266" actId="478"/>
-          <ac:cxnSpMkLst>
-            <pc:docMk/>
-            <pc:sldMk cId="179835989" sldId="414"/>
-            <ac:cxnSpMk id="9" creationId="{9F86AD35-FF1B-1E79-1D03-005F15585C6D}"/>
-          </ac:cxnSpMkLst>
-        </pc:cxnChg>
-        <pc:cxnChg chg="add mod">
-          <ac:chgData name="Lines, Todd" userId="afaf7c3a-e8aa-4568-882a-02ad8f9e19b0" providerId="ADAL" clId="{5FF5AC1B-ABA9-43D7-A1E3-2D92732CD6E2}" dt="2026-01-08T22:45:31.672" v="274" actId="1076"/>
-          <ac:cxnSpMkLst>
-            <pc:docMk/>
-            <pc:sldMk cId="179835989" sldId="414"/>
-            <ac:cxnSpMk id="11" creationId="{6DEDD62D-B4CA-BBB1-8B25-81F94A62BAD7}"/>
-          </ac:cxnSpMkLst>
-        </pc:cxnChg>
-        <pc:cxnChg chg="add mod">
-          <ac:chgData name="Lines, Todd" userId="afaf7c3a-e8aa-4568-882a-02ad8f9e19b0" providerId="ADAL" clId="{5FF5AC1B-ABA9-43D7-A1E3-2D92732CD6E2}" dt="2026-01-08T22:45:33.484" v="275" actId="1076"/>
-          <ac:cxnSpMkLst>
-            <pc:docMk/>
-            <pc:sldMk cId="179835989" sldId="414"/>
-            <ac:cxnSpMk id="14" creationId="{C2FF504C-281A-FAB0-61F0-C3C7E14FB7BE}"/>
-          </ac:cxnSpMkLst>
-        </pc:cxnChg>
-      </pc:sldChg>
-      <pc:sldChg chg="addSp delSp modSp new mod">
-        <pc:chgData name="Lines, Todd" userId="afaf7c3a-e8aa-4568-882a-02ad8f9e19b0" providerId="ADAL" clId="{5FF5AC1B-ABA9-43D7-A1E3-2D92732CD6E2}" dt="2026-01-08T23:34:27.773" v="394" actId="1076"/>
-        <pc:sldMkLst>
-          <pc:docMk/>
-          <pc:sldMk cId="2146591160" sldId="415"/>
-        </pc:sldMkLst>
-        <pc:spChg chg="del">
-          <ac:chgData name="Lines, Todd" userId="afaf7c3a-e8aa-4568-882a-02ad8f9e19b0" providerId="ADAL" clId="{5FF5AC1B-ABA9-43D7-A1E3-2D92732CD6E2}" dt="2026-01-08T23:21:39.462" v="300" actId="478"/>
-          <ac:spMkLst>
-            <pc:docMk/>
-            <pc:sldMk cId="2146591160" sldId="415"/>
-            <ac:spMk id="2" creationId="{9DFC29F1-892E-CD79-F58D-29E0C7E4EC37}"/>
-          </ac:spMkLst>
-        </pc:spChg>
-        <pc:spChg chg="del">
-          <ac:chgData name="Lines, Todd" userId="afaf7c3a-e8aa-4568-882a-02ad8f9e19b0" providerId="ADAL" clId="{5FF5AC1B-ABA9-43D7-A1E3-2D92732CD6E2}" dt="2026-01-08T23:21:41.043" v="301" actId="478"/>
-          <ac:spMkLst>
-            <pc:docMk/>
-            <pc:sldMk cId="2146591160" sldId="415"/>
-            <ac:spMk id="3" creationId="{91390FCA-76CE-9186-427C-4B29AC68AA66}"/>
-          </ac:spMkLst>
-        </pc:spChg>
-        <pc:spChg chg="del">
-          <ac:chgData name="Lines, Todd" userId="afaf7c3a-e8aa-4568-882a-02ad8f9e19b0" providerId="ADAL" clId="{5FF5AC1B-ABA9-43D7-A1E3-2D92732CD6E2}" dt="2026-01-08T23:21:42.599" v="302" actId="478"/>
-          <ac:spMkLst>
-            <pc:docMk/>
-            <pc:sldMk cId="2146591160" sldId="415"/>
-            <ac:spMk id="4" creationId="{7B876BF2-488D-1996-FD9F-A1CEDF10A15E}"/>
-          </ac:spMkLst>
-        </pc:spChg>
-        <pc:spChg chg="add mod ord">
-          <ac:chgData name="Lines, Todd" userId="afaf7c3a-e8aa-4568-882a-02ad8f9e19b0" providerId="ADAL" clId="{5FF5AC1B-ABA9-43D7-A1E3-2D92732CD6E2}" dt="2026-01-08T23:34:27.773" v="394" actId="1076"/>
-          <ac:spMkLst>
-            <pc:docMk/>
-            <pc:sldMk cId="2146591160" sldId="415"/>
-            <ac:spMk id="7" creationId="{95E43228-DB83-7F73-A1D6-33E79086BDA2}"/>
-          </ac:spMkLst>
-        </pc:spChg>
-        <pc:spChg chg="add del mod">
-          <ac:chgData name="Lines, Todd" userId="afaf7c3a-e8aa-4568-882a-02ad8f9e19b0" providerId="ADAL" clId="{5FF5AC1B-ABA9-43D7-A1E3-2D92732CD6E2}" dt="2026-01-08T23:22:35.960" v="325"/>
-          <ac:spMkLst>
-            <pc:docMk/>
-            <pc:sldMk cId="2146591160" sldId="415"/>
-            <ac:spMk id="8" creationId="{A8E84FEF-3A47-3FB7-F9C0-F2316606152B}"/>
-          </ac:spMkLst>
-        </pc:spChg>
-        <pc:spChg chg="add mod ord">
-          <ac:chgData name="Lines, Todd" userId="afaf7c3a-e8aa-4568-882a-02ad8f9e19b0" providerId="ADAL" clId="{5FF5AC1B-ABA9-43D7-A1E3-2D92732CD6E2}" dt="2026-01-08T23:34:27.773" v="394" actId="1076"/>
-          <ac:spMkLst>
-            <pc:docMk/>
-            <pc:sldMk cId="2146591160" sldId="415"/>
-            <ac:spMk id="9" creationId="{D9DA714D-41B1-1968-2965-BC51181D0821}"/>
-          </ac:spMkLst>
-        </pc:spChg>
-        <pc:spChg chg="add mod ord">
-          <ac:chgData name="Lines, Todd" userId="afaf7c3a-e8aa-4568-882a-02ad8f9e19b0" providerId="ADAL" clId="{5FF5AC1B-ABA9-43D7-A1E3-2D92732CD6E2}" dt="2026-01-08T23:34:27.773" v="394" actId="1076"/>
-          <ac:spMkLst>
-            <pc:docMk/>
-            <pc:sldMk cId="2146591160" sldId="415"/>
-            <ac:spMk id="10" creationId="{4C028E71-F6AF-2F00-F28C-90E9FABBBC52}"/>
-          </ac:spMkLst>
-        </pc:spChg>
-        <pc:spChg chg="add del">
-          <ac:chgData name="Lines, Todd" userId="afaf7c3a-e8aa-4568-882a-02ad8f9e19b0" providerId="ADAL" clId="{5FF5AC1B-ABA9-43D7-A1E3-2D92732CD6E2}" dt="2026-01-08T23:26:54.773" v="378" actId="22"/>
-          <ac:spMkLst>
-            <pc:docMk/>
-            <pc:sldMk cId="2146591160" sldId="415"/>
-            <ac:spMk id="16" creationId="{2EE93902-08E0-6436-5944-6E52CB67B24F}"/>
-          </ac:spMkLst>
-        </pc:spChg>
-        <pc:picChg chg="add del mod">
-          <ac:chgData name="Lines, Todd" userId="afaf7c3a-e8aa-4568-882a-02ad8f9e19b0" providerId="ADAL" clId="{5FF5AC1B-ABA9-43D7-A1E3-2D92732CD6E2}" dt="2026-01-08T23:27:02.524" v="382" actId="478"/>
-          <ac:picMkLst>
-            <pc:docMk/>
-            <pc:sldMk cId="2146591160" sldId="415"/>
-            <ac:picMk id="6" creationId="{6F3EBD28-8AFA-D16E-8BD3-9DFDA783023D}"/>
-          </ac:picMkLst>
-        </pc:picChg>
-        <pc:picChg chg="del mod">
-          <ac:chgData name="Lines, Todd" userId="afaf7c3a-e8aa-4568-882a-02ad8f9e19b0" providerId="ADAL" clId="{5FF5AC1B-ABA9-43D7-A1E3-2D92732CD6E2}" dt="2026-01-08T23:25:07.355" v="362" actId="21"/>
-          <ac:picMkLst>
-            <pc:docMk/>
-            <pc:sldMk cId="2146591160" sldId="415"/>
-            <ac:picMk id="11" creationId="{DBE0A50A-BFC9-F417-AFF2-0BAE3856B24C}"/>
-          </ac:picMkLst>
-        </pc:picChg>
-        <pc:picChg chg="del">
-          <ac:chgData name="Lines, Todd" userId="afaf7c3a-e8aa-4568-882a-02ad8f9e19b0" providerId="ADAL" clId="{5FF5AC1B-ABA9-43D7-A1E3-2D92732CD6E2}" dt="2026-01-08T23:25:21.568" v="363" actId="21"/>
-          <ac:picMkLst>
-            <pc:docMk/>
-            <pc:sldMk cId="2146591160" sldId="415"/>
-            <ac:picMk id="12" creationId="{0F6DA6F9-3A40-D5EF-6C59-2F3A720217E6}"/>
-          </ac:picMkLst>
-        </pc:picChg>
-        <pc:picChg chg="add del mod">
-          <ac:chgData name="Lines, Todd" userId="afaf7c3a-e8aa-4568-882a-02ad8f9e19b0" providerId="ADAL" clId="{5FF5AC1B-ABA9-43D7-A1E3-2D92732CD6E2}" dt="2026-01-08T23:26:47.382" v="376" actId="22"/>
-          <ac:picMkLst>
-            <pc:docMk/>
-            <pc:sldMk cId="2146591160" sldId="415"/>
-            <ac:picMk id="14" creationId="{4E4E26B3-24F1-40D5-50F4-A86421BF0592}"/>
-          </ac:picMkLst>
-        </pc:picChg>
-        <pc:picChg chg="add mod">
-          <ac:chgData name="Lines, Todd" userId="afaf7c3a-e8aa-4568-882a-02ad8f9e19b0" providerId="ADAL" clId="{5FF5AC1B-ABA9-43D7-A1E3-2D92732CD6E2}" dt="2026-01-08T23:34:27.773" v="394" actId="1076"/>
-          <ac:picMkLst>
-            <pc:docMk/>
-            <pc:sldMk cId="2146591160" sldId="415"/>
-            <ac:picMk id="18" creationId="{352712F4-E230-D9C5-C869-A1052E581CB0}"/>
-          </ac:picMkLst>
-        </pc:picChg>
-        <pc:picChg chg="del mod">
-          <ac:chgData name="Lines, Todd" userId="afaf7c3a-e8aa-4568-882a-02ad8f9e19b0" providerId="ADAL" clId="{5FF5AC1B-ABA9-43D7-A1E3-2D92732CD6E2}" dt="2026-01-08T23:27:56.241" v="393" actId="21"/>
-          <ac:picMkLst>
-            <pc:docMk/>
-            <pc:sldMk cId="2146591160" sldId="415"/>
-            <ac:picMk id="19" creationId="{F03DD038-AEA4-A9D1-FA7E-B2DC8E2E4D91}"/>
-          </ac:picMkLst>
-        </pc:picChg>
+            <pc:sldMk cId="0" sldId="380"/>
+            <ac:graphicFrameMk id="8" creationId="{00000000-0000-0000-0000-000000000000}"/>
+          </ac:graphicFrameMkLst>
+        </pc:graphicFrameChg>
       </pc:sldChg>
     </pc:docChg>
   </pc:docChgLst>
@@ -1295,7 +471,7 @@
           <a:p>
             <a:fld id="{DE8946E1-4BD4-4BDB-BF97-56629F967A47}" type="datetimeFigureOut">
               <a:rPr lang="en-US" smtClean="0"/>
-              <a:t>1/8/2026</a:t>
+              <a:t>4/22/2026</a:t>
             </a:fld>
             <a:endParaRPr lang="en-US"/>
           </a:p>
@@ -1493,7 +669,7 @@
           <a:p>
             <a:fld id="{DE8946E1-4BD4-4BDB-BF97-56629F967A47}" type="datetimeFigureOut">
               <a:rPr lang="en-US" smtClean="0"/>
-              <a:t>1/8/2026</a:t>
+              <a:t>4/22/2026</a:t>
             </a:fld>
             <a:endParaRPr lang="en-US"/>
           </a:p>
@@ -1701,7 +877,7 @@
           <a:p>
             <a:fld id="{DE8946E1-4BD4-4BDB-BF97-56629F967A47}" type="datetimeFigureOut">
               <a:rPr lang="en-US" smtClean="0"/>
-              <a:t>1/8/2026</a:t>
+              <a:t>4/22/2026</a:t>
             </a:fld>
             <a:endParaRPr lang="en-US"/>
           </a:p>
@@ -1899,7 +1075,7 @@
           <a:p>
             <a:fld id="{DE8946E1-4BD4-4BDB-BF97-56629F967A47}" type="datetimeFigureOut">
               <a:rPr lang="en-US" smtClean="0"/>
-              <a:t>1/8/2026</a:t>
+              <a:t>4/22/2026</a:t>
             </a:fld>
             <a:endParaRPr lang="en-US"/>
           </a:p>
@@ -2174,7 +1350,7 @@
           <a:p>
             <a:fld id="{DE8946E1-4BD4-4BDB-BF97-56629F967A47}" type="datetimeFigureOut">
               <a:rPr lang="en-US" smtClean="0"/>
-              <a:t>1/8/2026</a:t>
+              <a:t>4/22/2026</a:t>
             </a:fld>
             <a:endParaRPr lang="en-US"/>
           </a:p>
@@ -2439,7 +1615,7 @@
           <a:p>
             <a:fld id="{DE8946E1-4BD4-4BDB-BF97-56629F967A47}" type="datetimeFigureOut">
               <a:rPr lang="en-US" smtClean="0"/>
-              <a:t>1/8/2026</a:t>
+              <a:t>4/22/2026</a:t>
             </a:fld>
             <a:endParaRPr lang="en-US"/>
           </a:p>
@@ -2851,7 +2027,7 @@
           <a:p>
             <a:fld id="{DE8946E1-4BD4-4BDB-BF97-56629F967A47}" type="datetimeFigureOut">
               <a:rPr lang="en-US" smtClean="0"/>
-              <a:t>1/8/2026</a:t>
+              <a:t>4/22/2026</a:t>
             </a:fld>
             <a:endParaRPr lang="en-US"/>
           </a:p>
@@ -2992,7 +2168,7 @@
           <a:p>
             <a:fld id="{DE8946E1-4BD4-4BDB-BF97-56629F967A47}" type="datetimeFigureOut">
               <a:rPr lang="en-US" smtClean="0"/>
-              <a:t>1/8/2026</a:t>
+              <a:t>4/22/2026</a:t>
             </a:fld>
             <a:endParaRPr lang="en-US"/>
           </a:p>
@@ -3105,7 +2281,7 @@
           <a:p>
             <a:fld id="{DE8946E1-4BD4-4BDB-BF97-56629F967A47}" type="datetimeFigureOut">
               <a:rPr lang="en-US" smtClean="0"/>
-              <a:t>1/8/2026</a:t>
+              <a:t>4/22/2026</a:t>
             </a:fld>
             <a:endParaRPr lang="en-US"/>
           </a:p>
@@ -3416,7 +2592,7 @@
           <a:p>
             <a:fld id="{DE8946E1-4BD4-4BDB-BF97-56629F967A47}" type="datetimeFigureOut">
               <a:rPr lang="en-US" smtClean="0"/>
-              <a:t>1/8/2026</a:t>
+              <a:t>4/22/2026</a:t>
             </a:fld>
             <a:endParaRPr lang="en-US"/>
           </a:p>
@@ -3704,7 +2880,7 @@
           <a:p>
             <a:fld id="{DE8946E1-4BD4-4BDB-BF97-56629F967A47}" type="datetimeFigureOut">
               <a:rPr lang="en-US" smtClean="0"/>
-              <a:t>1/8/2026</a:t>
+              <a:t>4/22/2026</a:t>
             </a:fld>
             <a:endParaRPr lang="en-US"/>
           </a:p>
@@ -3945,7 +3121,7 @@
           <a:p>
             <a:fld id="{DE8946E1-4BD4-4BDB-BF97-56629F967A47}" type="datetimeFigureOut">
               <a:rPr lang="en-US" smtClean="0"/>
-              <a:t>1/8/2026</a:t>
+              <a:t>4/22/2026</a:t>
             </a:fld>
             <a:endParaRPr lang="en-US"/>
           </a:p>
@@ -7526,8 +6702,8 @@
           <a:chExt cx="0" cy="0"/>
         </a:xfrm>
       </p:grpSpPr>
-      <mc:AlternateContent xmlns:mc="http://schemas.openxmlformats.org/markup-compatibility/2006">
-        <mc:Choice xmlns:a14="http://schemas.microsoft.com/office/drawing/2010/main" Requires="a14">
+      <mc:AlternateContent xmlns:mc="http://schemas.openxmlformats.org/markup-compatibility/2006" xmlns:a14="http://schemas.microsoft.com/office/drawing/2010/main">
+        <mc:Choice Requires="a14">
           <p:sp>
             <p:nvSpPr>
               <p:cNvPr id="3" name="Content Placeholder 2">
@@ -7566,46 +6742,62 @@
                     </m:oMathParaPr>
                     <m:oMath xmlns:m="http://schemas.openxmlformats.org/officeDocument/2006/math">
                       <m:r>
-                        <a:rPr lang="en-US" i="1"/>
+                        <a:rPr lang="en-US" i="1">
+                          <a:latin typeface="Cambria Math" panose="02040503050406030204" pitchFamily="18" charset="0"/>
+                        </a:rPr>
                         <m:t>𝑥</m:t>
                       </m:r>
                       <m:d>
                         <m:dPr>
                           <m:ctrlPr>
-                            <a:rPr lang="en-US" i="1"/>
+                            <a:rPr lang="en-US" i="1">
+                              <a:latin typeface="Cambria Math" panose="02040503050406030204" pitchFamily="18" charset="0"/>
+                            </a:rPr>
                           </m:ctrlPr>
                         </m:dPr>
                         <m:e>
                           <m:r>
-                            <a:rPr lang="en-US" i="1"/>
+                            <a:rPr lang="en-US" i="1">
+                              <a:latin typeface="Cambria Math" panose="02040503050406030204" pitchFamily="18" charset="0"/>
+                            </a:rPr>
                             <m:t>𝑡</m:t>
                           </m:r>
                         </m:e>
                       </m:d>
                       <m:r>
-                        <a:rPr lang="en-US" i="1"/>
+                        <a:rPr lang="en-US" i="1">
+                          <a:latin typeface="Cambria Math" panose="02040503050406030204" pitchFamily="18" charset="0"/>
+                        </a:rPr>
                         <m:t>=</m:t>
                       </m:r>
                       <m:sSub>
                         <m:sSubPr>
                           <m:ctrlPr>
-                            <a:rPr lang="en-US" i="1"/>
+                            <a:rPr lang="en-US" i="1">
+                              <a:latin typeface="Cambria Math" panose="02040503050406030204" pitchFamily="18" charset="0"/>
+                            </a:rPr>
                           </m:ctrlPr>
                         </m:sSubPr>
                         <m:e>
                           <m:r>
-                            <a:rPr lang="en-US" i="1"/>
+                            <a:rPr lang="en-US" i="1">
+                              <a:latin typeface="Cambria Math" panose="02040503050406030204" pitchFamily="18" charset="0"/>
+                            </a:rPr>
                             <m:t>𝑥</m:t>
                           </m:r>
                           <m:func>
                             <m:funcPr>
                               <m:ctrlPr>
-                                <a:rPr lang="en-US" i="1"/>
+                                <a:rPr lang="en-US" i="1">
+                                  <a:latin typeface="Cambria Math" panose="02040503050406030204" pitchFamily="18" charset="0"/>
+                                </a:rPr>
                               </m:ctrlPr>
                             </m:funcPr>
                             <m:fName>
                               <m:r>
-                                <a:rPr lang="en-US" i="1"/>
+                                <a:rPr lang="en-US" i="1">
+                                  <a:latin typeface="Cambria Math" panose="02040503050406030204" pitchFamily="18" charset="0"/>
+                                </a:rPr>
                                 <m:t>𝑐𝑜𝑠</m:t>
                               </m:r>
                             </m:fName>
@@ -7613,37 +6805,51 @@
                               <m:d>
                                 <m:dPr>
                                   <m:ctrlPr>
-                                    <a:rPr lang="en-US" i="1"/>
+                                    <a:rPr lang="en-US" i="1">
+                                      <a:latin typeface="Cambria Math" panose="02040503050406030204" pitchFamily="18" charset="0"/>
+                                    </a:rPr>
                                   </m:ctrlPr>
                                 </m:dPr>
                                 <m:e>
                                   <m:r>
-                                    <a:rPr lang="en-US" i="1"/>
+                                    <a:rPr lang="en-US" i="1">
+                                      <a:latin typeface="Cambria Math" panose="02040503050406030204" pitchFamily="18" charset="0"/>
+                                    </a:rPr>
                                     <m:t>𝜔</m:t>
                                   </m:r>
                                   <m:r>
-                                    <a:rPr lang="en-US" i="1"/>
+                                    <a:rPr lang="en-US" i="1">
+                                      <a:latin typeface="Cambria Math" panose="02040503050406030204" pitchFamily="18" charset="0"/>
+                                    </a:rPr>
                                     <m:t>𝑡</m:t>
                                   </m:r>
                                   <m:r>
-                                    <a:rPr lang="en-US" i="1"/>
+                                    <a:rPr lang="en-US" i="1">
+                                      <a:latin typeface="Cambria Math" panose="02040503050406030204" pitchFamily="18" charset="0"/>
+                                    </a:rPr>
                                     <m:t>+</m:t>
                                   </m:r>
                                   <m:sSub>
                                     <m:sSubPr>
                                       <m:ctrlPr>
-                                        <a:rPr lang="en-US" i="1"/>
+                                        <a:rPr lang="en-US" i="1">
+                                          <a:latin typeface="Cambria Math" panose="02040503050406030204" pitchFamily="18" charset="0"/>
+                                        </a:rPr>
                                       </m:ctrlPr>
                                     </m:sSubPr>
                                     <m:e>
                                       <m:r>
-                                        <a:rPr lang="en-US" i="1"/>
+                                        <a:rPr lang="en-US" i="1">
+                                          <a:latin typeface="Cambria Math" panose="02040503050406030204" pitchFamily="18" charset="0"/>
+                                        </a:rPr>
                                         <m:t>𝜑</m:t>
                                       </m:r>
                                     </m:e>
                                     <m:sub>
                                       <m:r>
-                                        <a:rPr lang="en-US" i="1"/>
+                                        <a:rPr lang="en-US" i="1">
+                                          <a:latin typeface="Cambria Math" panose="02040503050406030204" pitchFamily="18" charset="0"/>
+                                        </a:rPr>
                                         <m:t>𝑜</m:t>
                                       </m:r>
                                     </m:sub>
@@ -7655,7 +6861,9 @@
                         </m:e>
                         <m:sub>
                           <m:r>
-                            <a:rPr lang="en-US" i="1"/>
+                            <a:rPr lang="en-US" i="1">
+                              <a:latin typeface="Cambria Math" panose="02040503050406030204" pitchFamily="18" charset="0"/>
+                            </a:rPr>
                             <m:t>𝑚𝑎𝑥</m:t>
                           </m:r>
                         </m:sub>
@@ -7663,50 +6871,68 @@
                     </m:oMath>
                     <m:oMath xmlns:m="http://schemas.openxmlformats.org/officeDocument/2006/math">
                       <m:r>
-                        <a:rPr lang="en-US" i="1"/>
+                        <a:rPr lang="en-US" i="1">
+                          <a:latin typeface="Cambria Math" panose="02040503050406030204" pitchFamily="18" charset="0"/>
+                        </a:rPr>
                         <m:t>𝑣</m:t>
                       </m:r>
                       <m:d>
                         <m:dPr>
                           <m:ctrlPr>
-                            <a:rPr lang="en-US" i="1"/>
+                            <a:rPr lang="en-US" i="1">
+                              <a:latin typeface="Cambria Math" panose="02040503050406030204" pitchFamily="18" charset="0"/>
+                            </a:rPr>
                           </m:ctrlPr>
                         </m:dPr>
                         <m:e>
                           <m:r>
-                            <a:rPr lang="en-US" i="1"/>
+                            <a:rPr lang="en-US" i="1">
+                              <a:latin typeface="Cambria Math" panose="02040503050406030204" pitchFamily="18" charset="0"/>
+                            </a:rPr>
                             <m:t>𝑡</m:t>
                           </m:r>
                         </m:e>
                       </m:d>
                       <m:r>
-                        <a:rPr lang="en-US" i="1"/>
+                        <a:rPr lang="en-US" i="1">
+                          <a:latin typeface="Cambria Math" panose="02040503050406030204" pitchFamily="18" charset="0"/>
+                        </a:rPr>
                         <m:t>=−</m:t>
                       </m:r>
                       <m:r>
-                        <a:rPr lang="en-US" i="1"/>
+                        <a:rPr lang="en-US" i="1">
+                          <a:latin typeface="Cambria Math" panose="02040503050406030204" pitchFamily="18" charset="0"/>
+                        </a:rPr>
                         <m:t>𝜔</m:t>
                       </m:r>
                       <m:sSub>
                         <m:sSubPr>
                           <m:ctrlPr>
-                            <a:rPr lang="en-US" i="1"/>
+                            <a:rPr lang="en-US" i="1">
+                              <a:latin typeface="Cambria Math" panose="02040503050406030204" pitchFamily="18" charset="0"/>
+                            </a:rPr>
                           </m:ctrlPr>
                         </m:sSubPr>
                         <m:e>
                           <m:r>
-                            <a:rPr lang="en-US" i="1"/>
+                            <a:rPr lang="en-US" i="1">
+                              <a:latin typeface="Cambria Math" panose="02040503050406030204" pitchFamily="18" charset="0"/>
+                            </a:rPr>
                             <m:t>𝑥</m:t>
                           </m:r>
                           <m:func>
                             <m:funcPr>
                               <m:ctrlPr>
-                                <a:rPr lang="en-US" i="1"/>
+                                <a:rPr lang="en-US" i="1">
+                                  <a:latin typeface="Cambria Math" panose="02040503050406030204" pitchFamily="18" charset="0"/>
+                                </a:rPr>
                               </m:ctrlPr>
                             </m:funcPr>
                             <m:fName>
                               <m:r>
-                                <a:rPr lang="en-US" i="1"/>
+                                <a:rPr lang="en-US" i="1">
+                                  <a:latin typeface="Cambria Math" panose="02040503050406030204" pitchFamily="18" charset="0"/>
+                                </a:rPr>
                                 <m:t>𝑠𝑖𝑛</m:t>
                               </m:r>
                             </m:fName>
@@ -7714,37 +6940,51 @@
                               <m:d>
                                 <m:dPr>
                                   <m:ctrlPr>
-                                    <a:rPr lang="en-US" i="1"/>
+                                    <a:rPr lang="en-US" i="1">
+                                      <a:latin typeface="Cambria Math" panose="02040503050406030204" pitchFamily="18" charset="0"/>
+                                    </a:rPr>
                                   </m:ctrlPr>
                                 </m:dPr>
                                 <m:e>
                                   <m:r>
-                                    <a:rPr lang="en-US" i="1"/>
+                                    <a:rPr lang="en-US" i="1">
+                                      <a:latin typeface="Cambria Math" panose="02040503050406030204" pitchFamily="18" charset="0"/>
+                                    </a:rPr>
                                     <m:t>𝜔</m:t>
                                   </m:r>
                                   <m:r>
-                                    <a:rPr lang="en-US" i="1"/>
+                                    <a:rPr lang="en-US" i="1">
+                                      <a:latin typeface="Cambria Math" panose="02040503050406030204" pitchFamily="18" charset="0"/>
+                                    </a:rPr>
                                     <m:t>𝑡</m:t>
                                   </m:r>
                                   <m:r>
-                                    <a:rPr lang="en-US" i="1"/>
+                                    <a:rPr lang="en-US" i="1">
+                                      <a:latin typeface="Cambria Math" panose="02040503050406030204" pitchFamily="18" charset="0"/>
+                                    </a:rPr>
                                     <m:t>+</m:t>
                                   </m:r>
                                   <m:sSub>
                                     <m:sSubPr>
                                       <m:ctrlPr>
-                                        <a:rPr lang="en-US" i="1"/>
+                                        <a:rPr lang="en-US" i="1">
+                                          <a:latin typeface="Cambria Math" panose="02040503050406030204" pitchFamily="18" charset="0"/>
+                                        </a:rPr>
                                       </m:ctrlPr>
                                     </m:sSubPr>
                                     <m:e>
                                       <m:r>
-                                        <a:rPr lang="en-US" i="1"/>
+                                        <a:rPr lang="en-US" i="1">
+                                          <a:latin typeface="Cambria Math" panose="02040503050406030204" pitchFamily="18" charset="0"/>
+                                        </a:rPr>
                                         <m:t>𝜑</m:t>
                                       </m:r>
                                     </m:e>
                                     <m:sub>
                                       <m:r>
-                                        <a:rPr lang="en-US" i="1"/>
+                                        <a:rPr lang="en-US" i="1">
+                                          <a:latin typeface="Cambria Math" panose="02040503050406030204" pitchFamily="18" charset="0"/>
+                                        </a:rPr>
                                         <m:t>𝑜</m:t>
                                       </m:r>
                                     </m:sub>
@@ -7756,7 +6996,9 @@
                         </m:e>
                         <m:sub>
                           <m:r>
-                            <a:rPr lang="en-US" i="1"/>
+                            <a:rPr lang="en-US" i="1">
+                              <a:latin typeface="Cambria Math" panose="02040503050406030204" pitchFamily="18" charset="0"/>
+                            </a:rPr>
                             <m:t>𝑚𝑎𝑥</m:t>
                           </m:r>
                         </m:sub>
@@ -7764,41 +7006,55 @@
                     </m:oMath>
                     <m:oMath xmlns:m="http://schemas.openxmlformats.org/officeDocument/2006/math">
                       <m:r>
-                        <a:rPr lang="en-US" i="1"/>
+                        <a:rPr lang="en-US" i="1">
+                          <a:latin typeface="Cambria Math" panose="02040503050406030204" pitchFamily="18" charset="0"/>
+                        </a:rPr>
                         <m:t>𝑎</m:t>
                       </m:r>
                       <m:d>
                         <m:dPr>
                           <m:ctrlPr>
-                            <a:rPr lang="en-US" i="1"/>
+                            <a:rPr lang="en-US" i="1">
+                              <a:latin typeface="Cambria Math" panose="02040503050406030204" pitchFamily="18" charset="0"/>
+                            </a:rPr>
                           </m:ctrlPr>
                         </m:dPr>
                         <m:e>
                           <m:r>
-                            <a:rPr lang="en-US" i="1"/>
+                            <a:rPr lang="en-US" i="1">
+                              <a:latin typeface="Cambria Math" panose="02040503050406030204" pitchFamily="18" charset="0"/>
+                            </a:rPr>
                             <m:t>𝑡</m:t>
                           </m:r>
                         </m:e>
                       </m:d>
                       <m:r>
-                        <a:rPr lang="en-US" i="1"/>
+                        <a:rPr lang="en-US" i="1">
+                          <a:latin typeface="Cambria Math" panose="02040503050406030204" pitchFamily="18" charset="0"/>
+                        </a:rPr>
                         <m:t>=−</m:t>
                       </m:r>
                       <m:sSup>
                         <m:sSupPr>
                           <m:ctrlPr>
-                            <a:rPr lang="en-US" i="1"/>
+                            <a:rPr lang="en-US" i="1">
+                              <a:latin typeface="Cambria Math" panose="02040503050406030204" pitchFamily="18" charset="0"/>
+                            </a:rPr>
                           </m:ctrlPr>
                         </m:sSupPr>
                         <m:e>
                           <m:r>
-                            <a:rPr lang="en-US" i="1"/>
+                            <a:rPr lang="en-US" i="1">
+                              <a:latin typeface="Cambria Math" panose="02040503050406030204" pitchFamily="18" charset="0"/>
+                            </a:rPr>
                             <m:t>𝜔</m:t>
                           </m:r>
                         </m:e>
                         <m:sup>
                           <m:r>
-                            <a:rPr lang="en-US" i="1"/>
+                            <a:rPr lang="en-US" i="1">
+                              <a:latin typeface="Cambria Math" panose="02040503050406030204" pitchFamily="18" charset="0"/>
+                            </a:rPr>
                             <m:t>2</m:t>
                           </m:r>
                         </m:sup>
@@ -7806,23 +7062,31 @@
                       <m:sSub>
                         <m:sSubPr>
                           <m:ctrlPr>
-                            <a:rPr lang="en-US" i="1"/>
+                            <a:rPr lang="en-US" i="1">
+                              <a:latin typeface="Cambria Math" panose="02040503050406030204" pitchFamily="18" charset="0"/>
+                            </a:rPr>
                           </m:ctrlPr>
                         </m:sSubPr>
                         <m:e>
                           <m:r>
-                            <a:rPr lang="en-US" i="1"/>
+                            <a:rPr lang="en-US" i="1">
+                              <a:latin typeface="Cambria Math" panose="02040503050406030204" pitchFamily="18" charset="0"/>
+                            </a:rPr>
                             <m:t>𝑥</m:t>
                           </m:r>
                           <m:func>
                             <m:funcPr>
                               <m:ctrlPr>
-                                <a:rPr lang="en-US" i="1"/>
+                                <a:rPr lang="en-US" i="1">
+                                  <a:latin typeface="Cambria Math" panose="02040503050406030204" pitchFamily="18" charset="0"/>
+                                </a:rPr>
                               </m:ctrlPr>
                             </m:funcPr>
                             <m:fName>
                               <m:r>
-                                <a:rPr lang="en-US" i="1"/>
+                                <a:rPr lang="en-US" i="1">
+                                  <a:latin typeface="Cambria Math" panose="02040503050406030204" pitchFamily="18" charset="0"/>
+                                </a:rPr>
                                 <m:t>𝑐𝑜𝑠</m:t>
                               </m:r>
                             </m:fName>
@@ -7830,37 +7094,51 @@
                               <m:d>
                                 <m:dPr>
                                   <m:ctrlPr>
-                                    <a:rPr lang="en-US" i="1"/>
+                                    <a:rPr lang="en-US" i="1">
+                                      <a:latin typeface="Cambria Math" panose="02040503050406030204" pitchFamily="18" charset="0"/>
+                                    </a:rPr>
                                   </m:ctrlPr>
                                 </m:dPr>
                                 <m:e>
                                   <m:r>
-                                    <a:rPr lang="en-US" i="1"/>
+                                    <a:rPr lang="en-US" i="1">
+                                      <a:latin typeface="Cambria Math" panose="02040503050406030204" pitchFamily="18" charset="0"/>
+                                    </a:rPr>
                                     <m:t>𝜔</m:t>
                                   </m:r>
                                   <m:r>
-                                    <a:rPr lang="en-US" i="1"/>
+                                    <a:rPr lang="en-US" i="1">
+                                      <a:latin typeface="Cambria Math" panose="02040503050406030204" pitchFamily="18" charset="0"/>
+                                    </a:rPr>
                                     <m:t>𝑡</m:t>
                                   </m:r>
                                   <m:r>
-                                    <a:rPr lang="en-US" i="1"/>
+                                    <a:rPr lang="en-US" i="1">
+                                      <a:latin typeface="Cambria Math" panose="02040503050406030204" pitchFamily="18" charset="0"/>
+                                    </a:rPr>
                                     <m:t>+</m:t>
                                   </m:r>
                                   <m:sSub>
                                     <m:sSubPr>
                                       <m:ctrlPr>
-                                        <a:rPr lang="en-US" i="1"/>
+                                        <a:rPr lang="en-US" i="1">
+                                          <a:latin typeface="Cambria Math" panose="02040503050406030204" pitchFamily="18" charset="0"/>
+                                        </a:rPr>
                                       </m:ctrlPr>
                                     </m:sSubPr>
                                     <m:e>
                                       <m:r>
-                                        <a:rPr lang="en-US" i="1"/>
+                                        <a:rPr lang="en-US" i="1">
+                                          <a:latin typeface="Cambria Math" panose="02040503050406030204" pitchFamily="18" charset="0"/>
+                                        </a:rPr>
                                         <m:t>𝜑</m:t>
                                       </m:r>
                                     </m:e>
                                     <m:sub>
                                       <m:r>
-                                        <a:rPr lang="en-US" i="1"/>
+                                        <a:rPr lang="en-US" i="1">
+                                          <a:latin typeface="Cambria Math" panose="02040503050406030204" pitchFamily="18" charset="0"/>
+                                        </a:rPr>
                                         <m:t>𝑜</m:t>
                                       </m:r>
                                     </m:sub>
@@ -7872,7 +7150,9 @@
                         </m:e>
                         <m:sub>
                           <m:r>
-                            <a:rPr lang="en-US" i="1"/>
+                            <a:rPr lang="en-US" i="1">
+                              <a:latin typeface="Cambria Math" panose="02040503050406030204" pitchFamily="18" charset="0"/>
+                            </a:rPr>
                             <m:t>𝑚𝑎𝑥</m:t>
                           </m:r>
                         </m:sub>
@@ -7899,19 +7179,27 @@
                     </m:oMathParaPr>
                     <m:oMath xmlns:m="http://schemas.openxmlformats.org/officeDocument/2006/math">
                       <m:r>
-                        <a:rPr lang="en-US" i="1"/>
+                        <a:rPr lang="en-US" i="1">
+                          <a:latin typeface="Cambria Math" panose="02040503050406030204" pitchFamily="18" charset="0"/>
+                        </a:rPr>
                         <m:t>𝜔</m:t>
                       </m:r>
                       <m:r>
-                        <a:rPr lang="en-US" i="1"/>
+                        <a:rPr lang="en-US" i="1">
+                          <a:latin typeface="Cambria Math" panose="02040503050406030204" pitchFamily="18" charset="0"/>
+                        </a:rPr>
                         <m:t>=2</m:t>
                       </m:r>
                       <m:r>
-                        <a:rPr lang="en-US" i="1"/>
+                        <a:rPr lang="en-US" i="1">
+                          <a:latin typeface="Cambria Math" panose="02040503050406030204" pitchFamily="18" charset="0"/>
+                        </a:rPr>
                         <m:t>𝜋</m:t>
                       </m:r>
                       <m:r>
-                        <a:rPr lang="en-US" i="1"/>
+                        <a:rPr lang="en-US" i="1">
+                          <a:latin typeface="Cambria Math" panose="02040503050406030204" pitchFamily="18" charset="0"/>
+                        </a:rPr>
                         <m:t>𝑓</m:t>
                       </m:r>
                     </m:oMath>
@@ -7932,45 +7220,61 @@
                     <m:sSub>
                       <m:sSubPr>
                         <m:ctrlPr>
-                          <a:rPr lang="en-US" i="1"/>
+                          <a:rPr lang="en-US" i="1">
+                            <a:latin typeface="Cambria Math" panose="02040503050406030204" pitchFamily="18" charset="0"/>
+                          </a:rPr>
                         </m:ctrlPr>
                       </m:sSubPr>
                       <m:e>
                         <m:r>
-                          <a:rPr lang="en-US" i="1"/>
+                          <a:rPr lang="en-US" i="1">
+                            <a:latin typeface="Cambria Math" panose="02040503050406030204" pitchFamily="18" charset="0"/>
+                          </a:rPr>
                           <m:t>𝑣</m:t>
                         </m:r>
                       </m:e>
                       <m:sub>
                         <m:r>
-                          <a:rPr lang="en-US" i="1"/>
+                          <a:rPr lang="en-US" i="1">
+                            <a:latin typeface="Cambria Math" panose="02040503050406030204" pitchFamily="18" charset="0"/>
+                          </a:rPr>
                           <m:t>𝑚</m:t>
                         </m:r>
                       </m:sub>
                     </m:sSub>
                     <m:r>
-                      <a:rPr lang="en-US" i="1"/>
+                      <a:rPr lang="en-US" i="1">
+                        <a:latin typeface="Cambria Math" panose="02040503050406030204" pitchFamily="18" charset="0"/>
+                      </a:rPr>
                       <m:t>=</m:t>
                     </m:r>
                     <m:r>
-                      <a:rPr lang="en-US" i="1"/>
+                      <a:rPr lang="en-US" i="1">
+                        <a:latin typeface="Cambria Math" panose="02040503050406030204" pitchFamily="18" charset="0"/>
+                      </a:rPr>
                       <m:t>𝜔</m:t>
                     </m:r>
                     <m:sSub>
                       <m:sSubPr>
                         <m:ctrlPr>
-                          <a:rPr lang="en-US" i="1"/>
+                          <a:rPr lang="en-US" i="1">
+                            <a:latin typeface="Cambria Math" panose="02040503050406030204" pitchFamily="18" charset="0"/>
+                          </a:rPr>
                         </m:ctrlPr>
                       </m:sSubPr>
                       <m:e>
                         <m:r>
-                          <a:rPr lang="en-US" i="1"/>
+                          <a:rPr lang="en-US" i="1">
+                            <a:latin typeface="Cambria Math" panose="02040503050406030204" pitchFamily="18" charset="0"/>
+                          </a:rPr>
                           <m:t>𝑥</m:t>
                         </m:r>
                       </m:e>
                       <m:sub>
                         <m:r>
-                          <a:rPr lang="en-US" i="1"/>
+                          <a:rPr lang="en-US" i="1">
+                            <a:latin typeface="Cambria Math" panose="02040503050406030204" pitchFamily="18" charset="0"/>
+                          </a:rPr>
                           <m:t>𝑚</m:t>
                         </m:r>
                       </m:sub>
@@ -7992,41 +7296,55 @@
                     <m:sSub>
                       <m:sSubPr>
                         <m:ctrlPr>
-                          <a:rPr lang="en-US" i="1"/>
+                          <a:rPr lang="en-US" i="1">
+                            <a:latin typeface="Cambria Math" panose="02040503050406030204" pitchFamily="18" charset="0"/>
+                          </a:rPr>
                         </m:ctrlPr>
                       </m:sSubPr>
                       <m:e>
                         <m:r>
-                          <a:rPr lang="en-US" i="1"/>
+                          <a:rPr lang="en-US" i="1">
+                            <a:latin typeface="Cambria Math" panose="02040503050406030204" pitchFamily="18" charset="0"/>
+                          </a:rPr>
                           <m:t>𝑎</m:t>
                         </m:r>
                       </m:e>
                       <m:sub>
                         <m:r>
-                          <a:rPr lang="en-US" i="1"/>
+                          <a:rPr lang="en-US" i="1">
+                            <a:latin typeface="Cambria Math" panose="02040503050406030204" pitchFamily="18" charset="0"/>
+                          </a:rPr>
                           <m:t>𝑚</m:t>
                         </m:r>
                       </m:sub>
                     </m:sSub>
                     <m:r>
-                      <a:rPr lang="en-US" i="1"/>
+                      <a:rPr lang="en-US" i="1">
+                        <a:latin typeface="Cambria Math" panose="02040503050406030204" pitchFamily="18" charset="0"/>
+                      </a:rPr>
                       <m:t>=</m:t>
                     </m:r>
                     <m:sSup>
                       <m:sSupPr>
                         <m:ctrlPr>
-                          <a:rPr lang="en-US" i="1"/>
+                          <a:rPr lang="en-US" i="1">
+                            <a:latin typeface="Cambria Math" panose="02040503050406030204" pitchFamily="18" charset="0"/>
+                          </a:rPr>
                         </m:ctrlPr>
                       </m:sSupPr>
                       <m:e>
                         <m:r>
-                          <a:rPr lang="en-US" i="1"/>
+                          <a:rPr lang="en-US" i="1">
+                            <a:latin typeface="Cambria Math" panose="02040503050406030204" pitchFamily="18" charset="0"/>
+                          </a:rPr>
                           <m:t>𝜔</m:t>
                         </m:r>
                       </m:e>
                       <m:sup>
                         <m:r>
-                          <a:rPr lang="en-US" i="1"/>
+                          <a:rPr lang="en-US" i="1">
+                            <a:latin typeface="Cambria Math" panose="02040503050406030204" pitchFamily="18" charset="0"/>
+                          </a:rPr>
                           <m:t>2</m:t>
                         </m:r>
                       </m:sup>
@@ -8034,18 +7352,24 @@
                     <m:sSub>
                       <m:sSubPr>
                         <m:ctrlPr>
-                          <a:rPr lang="en-US" i="1"/>
+                          <a:rPr lang="en-US" i="1">
+                            <a:latin typeface="Cambria Math" panose="02040503050406030204" pitchFamily="18" charset="0"/>
+                          </a:rPr>
                         </m:ctrlPr>
                       </m:sSubPr>
                       <m:e>
                         <m:r>
-                          <a:rPr lang="en-US" i="1"/>
+                          <a:rPr lang="en-US" i="1">
+                            <a:latin typeface="Cambria Math" panose="02040503050406030204" pitchFamily="18" charset="0"/>
+                          </a:rPr>
                           <m:t>𝑥</m:t>
                         </m:r>
                       </m:e>
                       <m:sub>
                         <m:r>
-                          <a:rPr lang="en-US" i="1"/>
+                          <a:rPr lang="en-US" i="1">
+                            <a:latin typeface="Cambria Math" panose="02040503050406030204" pitchFamily="18" charset="0"/>
+                          </a:rPr>
                           <m:t>𝑚</m:t>
                         </m:r>
                       </m:sub>
@@ -8065,28 +7389,38 @@
                 <a14:m>
                   <m:oMath xmlns:m="http://schemas.openxmlformats.org/officeDocument/2006/math">
                     <m:r>
-                      <a:rPr lang="en-US" i="1"/>
+                      <a:rPr lang="en-US" i="1">
+                        <a:latin typeface="Cambria Math" panose="02040503050406030204" pitchFamily="18" charset="0"/>
+                      </a:rPr>
                       <m:t>𝑇</m:t>
                     </m:r>
                     <m:r>
-                      <a:rPr lang="en-US" i="1"/>
+                      <a:rPr lang="en-US" i="1">
+                        <a:latin typeface="Cambria Math" panose="02040503050406030204" pitchFamily="18" charset="0"/>
+                      </a:rPr>
                       <m:t>=</m:t>
                     </m:r>
                     <m:f>
                       <m:fPr>
                         <m:ctrlPr>
-                          <a:rPr lang="en-US" i="1"/>
+                          <a:rPr lang="en-US" i="1">
+                            <a:latin typeface="Cambria Math" panose="02040503050406030204" pitchFamily="18" charset="0"/>
+                          </a:rPr>
                         </m:ctrlPr>
                       </m:fPr>
                       <m:num>
                         <m:r>
-                          <a:rPr lang="en-US" i="1"/>
+                          <a:rPr lang="en-US" i="1">
+                            <a:latin typeface="Cambria Math" panose="02040503050406030204" pitchFamily="18" charset="0"/>
+                          </a:rPr>
                           <m:t>1</m:t>
                         </m:r>
                       </m:num>
                       <m:den>
                         <m:r>
-                          <a:rPr lang="en-US" i="1"/>
+                          <a:rPr lang="en-US" i="1">
+                            <a:latin typeface="Cambria Math" panose="02040503050406030204" pitchFamily="18" charset="0"/>
+                          </a:rPr>
                           <m:t>𝑓</m:t>
                         </m:r>
                       </m:den>
@@ -8114,70 +7448,94 @@
                     <m:sSub>
                       <m:sSubPr>
                         <m:ctrlPr>
-                          <a:rPr lang="en-US" i="1"/>
+                          <a:rPr lang="en-US" i="1">
+                            <a:latin typeface="Cambria Math" panose="02040503050406030204" pitchFamily="18" charset="0"/>
+                          </a:rPr>
                         </m:ctrlPr>
                       </m:sSubPr>
                       <m:e>
                         <m:r>
-                          <a:rPr lang="en-US" i="1"/>
+                          <a:rPr lang="en-US" i="1">
+                            <a:latin typeface="Cambria Math" panose="02040503050406030204" pitchFamily="18" charset="0"/>
+                          </a:rPr>
                           <m:t>𝑈</m:t>
                         </m:r>
                       </m:e>
                       <m:sub>
                         <m:r>
-                          <a:rPr lang="en-US" i="1"/>
+                          <a:rPr lang="en-US" i="1">
+                            <a:latin typeface="Cambria Math" panose="02040503050406030204" pitchFamily="18" charset="0"/>
+                          </a:rPr>
                           <m:t>𝑠</m:t>
                         </m:r>
                       </m:sub>
                     </m:sSub>
                     <m:r>
-                      <a:rPr lang="en-US" i="1"/>
+                      <a:rPr lang="en-US" i="1">
+                        <a:latin typeface="Cambria Math" panose="02040503050406030204" pitchFamily="18" charset="0"/>
+                      </a:rPr>
                       <m:t>=</m:t>
                     </m:r>
                     <m:f>
                       <m:fPr>
                         <m:ctrlPr>
-                          <a:rPr lang="en-US" i="1"/>
+                          <a:rPr lang="en-US" i="1">
+                            <a:latin typeface="Cambria Math" panose="02040503050406030204" pitchFamily="18" charset="0"/>
+                          </a:rPr>
                         </m:ctrlPr>
                       </m:fPr>
                       <m:num>
                         <m:r>
-                          <a:rPr lang="en-US" i="1"/>
+                          <a:rPr lang="en-US" i="1">
+                            <a:latin typeface="Cambria Math" panose="02040503050406030204" pitchFamily="18" charset="0"/>
+                          </a:rPr>
                           <m:t>1</m:t>
                         </m:r>
                       </m:num>
                       <m:den>
                         <m:r>
-                          <a:rPr lang="en-US" i="1"/>
+                          <a:rPr lang="en-US" i="1">
+                            <a:latin typeface="Cambria Math" panose="02040503050406030204" pitchFamily="18" charset="0"/>
+                          </a:rPr>
                           <m:t>2</m:t>
                         </m:r>
                       </m:den>
                     </m:f>
                     <m:r>
-                      <a:rPr lang="en-US" i="1"/>
+                      <a:rPr lang="en-US" i="1">
+                        <a:latin typeface="Cambria Math" panose="02040503050406030204" pitchFamily="18" charset="0"/>
+                      </a:rPr>
                       <m:t>𝑘</m:t>
                     </m:r>
                     <m:sSubSup>
                       <m:sSubSupPr>
                         <m:ctrlPr>
-                          <a:rPr lang="en-US" i="1"/>
+                          <a:rPr lang="en-US" i="1">
+                            <a:latin typeface="Cambria Math" panose="02040503050406030204" pitchFamily="18" charset="0"/>
+                          </a:rPr>
                         </m:ctrlPr>
                       </m:sSubSupPr>
                       <m:e>
                         <m:r>
-                          <a:rPr lang="en-US" i="1"/>
+                          <a:rPr lang="en-US" i="1">
+                            <a:latin typeface="Cambria Math" panose="02040503050406030204" pitchFamily="18" charset="0"/>
+                          </a:rPr>
                           <m:t>𝑥</m:t>
                         </m:r>
                       </m:e>
                       <m:sub>
                         <m:r>
-                          <a:rPr lang="en-US" i="1"/>
+                          <a:rPr lang="en-US" i="1">
+                            <a:latin typeface="Cambria Math" panose="02040503050406030204" pitchFamily="18" charset="0"/>
+                          </a:rPr>
                           <m:t>𝑚𝑎𝑥</m:t>
                         </m:r>
                       </m:sub>
                       <m:sup>
                         <m:r>
-                          <a:rPr lang="en-US" i="1"/>
+                          <a:rPr lang="en-US" i="1">
+                            <a:latin typeface="Cambria Math" panose="02040503050406030204" pitchFamily="18" charset="0"/>
+                          </a:rPr>
                           <m:t>2</m:t>
                         </m:r>
                       </m:sup>
@@ -8278,51 +7636,69 @@
                 <a14:m>
                   <m:oMath xmlns:m="http://schemas.openxmlformats.org/officeDocument/2006/math">
                     <m:r>
-                      <a:rPr lang="en-US" i="1"/>
+                      <a:rPr lang="en-US" i="1">
+                        <a:latin typeface="Cambria Math" panose="02040503050406030204" pitchFamily="18" charset="0"/>
+                      </a:rPr>
                       <m:t>𝐾</m:t>
                     </m:r>
                     <m:r>
-                      <a:rPr lang="en-US" i="1"/>
+                      <a:rPr lang="en-US" i="1">
+                        <a:latin typeface="Cambria Math" panose="02040503050406030204" pitchFamily="18" charset="0"/>
+                      </a:rPr>
                       <m:t>=</m:t>
                     </m:r>
                     <m:f>
                       <m:fPr>
                         <m:ctrlPr>
-                          <a:rPr lang="en-US" i="1"/>
+                          <a:rPr lang="en-US" i="1">
+                            <a:latin typeface="Cambria Math" panose="02040503050406030204" pitchFamily="18" charset="0"/>
+                          </a:rPr>
                         </m:ctrlPr>
                       </m:fPr>
                       <m:num>
                         <m:r>
-                          <a:rPr lang="en-US" i="1"/>
+                          <a:rPr lang="en-US" i="1">
+                            <a:latin typeface="Cambria Math" panose="02040503050406030204" pitchFamily="18" charset="0"/>
+                          </a:rPr>
                           <m:t>1</m:t>
                         </m:r>
                       </m:num>
                       <m:den>
                         <m:r>
-                          <a:rPr lang="en-US" i="1"/>
+                          <a:rPr lang="en-US" i="1">
+                            <a:latin typeface="Cambria Math" panose="02040503050406030204" pitchFamily="18" charset="0"/>
+                          </a:rPr>
                           <m:t>2</m:t>
                         </m:r>
                       </m:den>
                     </m:f>
                     <m:r>
-                      <a:rPr lang="en-US" i="1"/>
+                      <a:rPr lang="en-US" i="1">
+                        <a:latin typeface="Cambria Math" panose="02040503050406030204" pitchFamily="18" charset="0"/>
+                      </a:rPr>
                       <m:t>𝑚</m:t>
                     </m:r>
                     <m:sSup>
                       <m:sSupPr>
                         <m:ctrlPr>
-                          <a:rPr lang="en-US" i="1"/>
+                          <a:rPr lang="en-US" i="1">
+                            <a:latin typeface="Cambria Math" panose="02040503050406030204" pitchFamily="18" charset="0"/>
+                          </a:rPr>
                         </m:ctrlPr>
                       </m:sSupPr>
                       <m:e>
                         <m:r>
-                          <a:rPr lang="en-US" i="1"/>
+                          <a:rPr lang="en-US" i="1">
+                            <a:latin typeface="Cambria Math" panose="02040503050406030204" pitchFamily="18" charset="0"/>
+                          </a:rPr>
                           <m:t>𝜔</m:t>
                         </m:r>
                       </m:e>
                       <m:sup>
                         <m:r>
-                          <a:rPr lang="en-US" i="1"/>
+                          <a:rPr lang="en-US" i="1">
+                            <a:latin typeface="Cambria Math" panose="02040503050406030204" pitchFamily="18" charset="0"/>
+                          </a:rPr>
                           <m:t>2</m:t>
                         </m:r>
                       </m:sup>
@@ -8330,24 +7706,32 @@
                     <m:sSubSup>
                       <m:sSubSupPr>
                         <m:ctrlPr>
-                          <a:rPr lang="en-US" i="1"/>
+                          <a:rPr lang="en-US" i="1">
+                            <a:latin typeface="Cambria Math" panose="02040503050406030204" pitchFamily="18" charset="0"/>
+                          </a:rPr>
                         </m:ctrlPr>
                       </m:sSubSupPr>
                       <m:e>
                         <m:r>
-                          <a:rPr lang="en-US" i="1"/>
+                          <a:rPr lang="en-US" i="1">
+                            <a:latin typeface="Cambria Math" panose="02040503050406030204" pitchFamily="18" charset="0"/>
+                          </a:rPr>
                           <m:t>𝑥</m:t>
                         </m:r>
                       </m:e>
                       <m:sub>
                         <m:r>
-                          <a:rPr lang="en-US" i="1"/>
+                          <a:rPr lang="en-US" i="1">
+                            <a:latin typeface="Cambria Math" panose="02040503050406030204" pitchFamily="18" charset="0"/>
+                          </a:rPr>
                           <m:t>𝑚𝑎𝑥</m:t>
                         </m:r>
                       </m:sub>
                       <m:sup>
                         <m:r>
-                          <a:rPr lang="en-US" i="1"/>
+                          <a:rPr lang="en-US" i="1">
+                            <a:latin typeface="Cambria Math" panose="02040503050406030204" pitchFamily="18" charset="0"/>
+                          </a:rPr>
                           <m:t>2</m:t>
                         </m:r>
                       </m:sup>
@@ -8446,22 +7830,30 @@
                 <a14:m>
                   <m:oMath xmlns:m="http://schemas.openxmlformats.org/officeDocument/2006/math">
                     <m:r>
-                      <a:rPr lang="en-US" i="1"/>
+                      <a:rPr lang="en-US" i="1">
+                        <a:latin typeface="Cambria Math" panose="02040503050406030204" pitchFamily="18" charset="0"/>
+                      </a:rPr>
                       <m:t>𝑇</m:t>
                     </m:r>
                     <m:r>
-                      <a:rPr lang="en-US" i="1"/>
+                      <a:rPr lang="en-US" i="1">
+                        <a:latin typeface="Cambria Math" panose="02040503050406030204" pitchFamily="18" charset="0"/>
+                      </a:rPr>
                       <m:t>=2</m:t>
                     </m:r>
                     <m:r>
-                      <a:rPr lang="en-US" i="1"/>
+                      <a:rPr lang="en-US" i="1">
+                        <a:latin typeface="Cambria Math" panose="02040503050406030204" pitchFamily="18" charset="0"/>
+                      </a:rPr>
                       <m:t>𝜋</m:t>
                     </m:r>
                     <m:rad>
                       <m:radPr>
                         <m:degHide m:val="on"/>
                         <m:ctrlPr>
-                          <a:rPr lang="en-US" i="1"/>
+                          <a:rPr lang="en-US" i="1">
+                            <a:latin typeface="Cambria Math" panose="02040503050406030204" pitchFamily="18" charset="0"/>
+                          </a:rPr>
                         </m:ctrlPr>
                       </m:radPr>
                       <m:deg/>
@@ -8469,18 +7861,24 @@
                         <m:f>
                           <m:fPr>
                             <m:ctrlPr>
-                              <a:rPr lang="en-US" i="1"/>
+                              <a:rPr lang="en-US" i="1">
+                                <a:latin typeface="Cambria Math" panose="02040503050406030204" pitchFamily="18" charset="0"/>
+                              </a:rPr>
                             </m:ctrlPr>
                           </m:fPr>
                           <m:num>
                             <m:r>
-                              <a:rPr lang="en-US" i="1"/>
+                              <a:rPr lang="en-US" i="1">
+                                <a:latin typeface="Cambria Math" panose="02040503050406030204" pitchFamily="18" charset="0"/>
+                              </a:rPr>
                               <m:t>𝑚</m:t>
                             </m:r>
                           </m:num>
                           <m:den>
                             <m:r>
-                              <a:rPr lang="en-US" i="1"/>
+                              <a:rPr lang="en-US" i="1">
+                                <a:latin typeface="Cambria Math" panose="02040503050406030204" pitchFamily="18" charset="0"/>
+                              </a:rPr>
                               <m:t>𝑘</m:t>
                             </m:r>
                           </m:den>
@@ -8505,32 +7903,44 @@
                     </m:oMathParaPr>
                     <m:oMath xmlns:m="http://schemas.openxmlformats.org/officeDocument/2006/math">
                       <m:r>
-                        <a:rPr lang="en-US" i="1"/>
+                        <a:rPr lang="en-US" i="1">
+                          <a:latin typeface="Cambria Math" panose="02040503050406030204" pitchFamily="18" charset="0"/>
+                        </a:rPr>
                         <m:t>𝑓</m:t>
                       </m:r>
                       <m:r>
-                        <a:rPr lang="en-US" i="1"/>
+                        <a:rPr lang="en-US" i="1">
+                          <a:latin typeface="Cambria Math" panose="02040503050406030204" pitchFamily="18" charset="0"/>
+                        </a:rPr>
                         <m:t>=</m:t>
                       </m:r>
                       <m:f>
                         <m:fPr>
                           <m:ctrlPr>
-                            <a:rPr lang="en-US" i="1"/>
+                            <a:rPr lang="en-US" i="1">
+                              <a:latin typeface="Cambria Math" panose="02040503050406030204" pitchFamily="18" charset="0"/>
+                            </a:rPr>
                           </m:ctrlPr>
                         </m:fPr>
                         <m:num>
                           <m:r>
-                            <a:rPr lang="en-US" i="1"/>
+                            <a:rPr lang="en-US" i="1">
+                              <a:latin typeface="Cambria Math" panose="02040503050406030204" pitchFamily="18" charset="0"/>
+                            </a:rPr>
                             <m:t>1</m:t>
                           </m:r>
                         </m:num>
                         <m:den>
                           <m:r>
-                            <a:rPr lang="en-US" i="1"/>
+                            <a:rPr lang="en-US" i="1">
+                              <a:latin typeface="Cambria Math" panose="02040503050406030204" pitchFamily="18" charset="0"/>
+                            </a:rPr>
                             <m:t>2</m:t>
                           </m:r>
                           <m:r>
-                            <a:rPr lang="en-US" i="1"/>
+                            <a:rPr lang="en-US" i="1">
+                              <a:latin typeface="Cambria Math" panose="02040503050406030204" pitchFamily="18" charset="0"/>
+                            </a:rPr>
                             <m:t>𝜋</m:t>
                           </m:r>
                         </m:den>
@@ -8539,7 +7949,9 @@
                         <m:radPr>
                           <m:degHide m:val="on"/>
                           <m:ctrlPr>
-                            <a:rPr lang="en-US" i="1"/>
+                            <a:rPr lang="en-US" i="1">
+                              <a:latin typeface="Cambria Math" panose="02040503050406030204" pitchFamily="18" charset="0"/>
+                            </a:rPr>
                           </m:ctrlPr>
                         </m:radPr>
                         <m:deg/>
@@ -8547,18 +7959,24 @@
                           <m:f>
                             <m:fPr>
                               <m:ctrlPr>
-                                <a:rPr lang="en-US" i="1"/>
+                                <a:rPr lang="en-US" i="1">
+                                  <a:latin typeface="Cambria Math" panose="02040503050406030204" pitchFamily="18" charset="0"/>
+                                </a:rPr>
                               </m:ctrlPr>
                             </m:fPr>
                             <m:num>
                               <m:r>
-                                <a:rPr lang="en-US" i="1"/>
+                                <a:rPr lang="en-US" i="1">
+                                  <a:latin typeface="Cambria Math" panose="02040503050406030204" pitchFamily="18" charset="0"/>
+                                </a:rPr>
                                 <m:t>𝑘</m:t>
                               </m:r>
                             </m:num>
                             <m:den>
                               <m:r>
-                                <a:rPr lang="en-US" i="1"/>
+                                <a:rPr lang="en-US" i="1">
+                                  <a:latin typeface="Cambria Math" panose="02040503050406030204" pitchFamily="18" charset="0"/>
+                                </a:rPr>
                                 <m:t>𝑚</m:t>
                               </m:r>
                             </m:den>
@@ -8588,7 +8006,7 @@
             </p:txBody>
           </p:sp>
         </mc:Choice>
-        <mc:Fallback>
+        <mc:Fallback xmlns="">
           <p:sp>
             <p:nvSpPr>
               <p:cNvPr id="3" name="Content Placeholder 2">
@@ -13808,8 +13226,8 @@
           </a:prstGeom>
         </p:spPr>
       </p:pic>
-      <mc:AlternateContent xmlns:mc="http://schemas.openxmlformats.org/markup-compatibility/2006">
-        <mc:Choice xmlns:a14="http://schemas.microsoft.com/office/drawing/2010/main" Requires="a14">
+      <mc:AlternateContent xmlns:mc="http://schemas.openxmlformats.org/markup-compatibility/2006" xmlns:a14="http://schemas.microsoft.com/office/drawing/2010/main">
+        <mc:Choice Requires="a14">
           <p:sp>
             <p:nvSpPr>
               <p:cNvPr id="9" name="TextBox 8">
@@ -13838,6 +13256,7 @@
               </a:bodyPr>
               <a:lstStyle/>
               <a:p>
+                <a:pPr/>
                 <a14:m>
                   <m:oMathPara xmlns:m="http://schemas.openxmlformats.org/officeDocument/2006/math">
                     <m:oMathParaPr>
@@ -13912,7 +13331,7 @@
             </p:txBody>
           </p:sp>
         </mc:Choice>
-        <mc:Fallback>
+        <mc:Fallback xmlns="">
           <p:sp>
             <p:nvSpPr>
               <p:cNvPr id="9" name="TextBox 8">
@@ -13957,8 +13376,8 @@
           </p:sp>
         </mc:Fallback>
       </mc:AlternateContent>
-      <mc:AlternateContent xmlns:mc="http://schemas.openxmlformats.org/markup-compatibility/2006">
-        <mc:Choice xmlns:a14="http://schemas.microsoft.com/office/drawing/2010/main" Requires="a14">
+      <mc:AlternateContent xmlns:mc="http://schemas.openxmlformats.org/markup-compatibility/2006" xmlns:a14="http://schemas.microsoft.com/office/drawing/2010/main">
+        <mc:Choice Requires="a14">
           <p:sp>
             <p:nvSpPr>
               <p:cNvPr id="10" name="TextBox 9">
@@ -13987,6 +13406,7 @@
               </a:bodyPr>
               <a:lstStyle/>
               <a:p>
+                <a:pPr/>
                 <a14:m>
                   <m:oMathPara xmlns:m="http://schemas.openxmlformats.org/officeDocument/2006/math">
                     <m:oMathParaPr>
@@ -14044,7 +13464,7 @@
             </p:txBody>
           </p:sp>
         </mc:Choice>
-        <mc:Fallback>
+        <mc:Fallback xmlns="">
           <p:sp>
             <p:nvSpPr>
               <p:cNvPr id="10" name="TextBox 9">
@@ -14785,9 +14205,9 @@
         <p:grpSpPr bwMode="auto">
           <a:xfrm>
             <a:off x="7559675" y="1504950"/>
-            <a:ext cx="2141538" cy="2781300"/>
+            <a:ext cx="2141538" cy="2784475"/>
             <a:chOff x="3766" y="847"/>
-            <a:chExt cx="1349" cy="1752"/>
+            <a:chExt cx="1349" cy="1754"/>
           </a:xfrm>
         </p:grpSpPr>
         <p:sp>
@@ -15868,7 +15288,7 @@
           <p:spPr bwMode="auto">
             <a:xfrm>
               <a:off x="4627" y="2368"/>
-              <a:ext cx="316" cy="231"/>
+              <a:ext cx="254" cy="233"/>
             </a:xfrm>
             <a:prstGeom prst="rect">
               <a:avLst/>
@@ -16002,8 +15422,15 @@
             <a:p>
               <a:pPr eaLnBrk="1" hangingPunct="1"/>
               <a:r>
-                <a:rPr lang="en-US"/>
-                <a:t>mg</a:t>
+                <a:rPr lang="en-US" dirty="0">
+                  <a:solidFill>
+                    <a:schemeClr val="tx2">
+                      <a:lumMod val="75000"/>
+                      <a:lumOff val="25000"/>
+                    </a:schemeClr>
+                  </a:solidFill>
+                </a:rPr>
+                <a:t>W</a:t>
               </a:r>
             </a:p>
           </p:txBody>
@@ -33556,38 +32983,74 @@
             <p:ph type="body" idx="1"/>
           </p:nvPr>
         </p:nvSpPr>
-        <p:spPr/>
+        <p:spPr>
+          <a:xfrm>
+            <a:off x="838200" y="1825625"/>
+            <a:ext cx="10515600" cy="4895850"/>
+          </a:xfrm>
+        </p:spPr>
         <p:txBody>
-          <a:bodyPr/>
+          <a:bodyPr>
+            <a:normAutofit fontScale="92500" lnSpcReduction="10000"/>
+          </a:bodyPr>
           <a:lstStyle/>
           <a:p>
             <a:pPr marL="623888" indent="-319088"/>
-            <a:endParaRPr lang="en-US" sz="1800"/>
+            <a:endParaRPr lang="en-US" sz="1800" dirty="0"/>
           </a:p>
           <a:p>
             <a:pPr marL="623888" indent="-319088"/>
-            <a:endParaRPr lang="en-US" sz="1800"/>
+            <a:endParaRPr lang="en-US" sz="1800" dirty="0"/>
           </a:p>
           <a:p>
             <a:pPr marL="623888" indent="-319088"/>
             <a:r>
-              <a:rPr lang="en-US" sz="1800"/>
+              <a:rPr lang="en-US" sz="1800" dirty="0"/>
               <a:t>Where</a:t>
             </a:r>
           </a:p>
           <a:p>
             <a:pPr marL="623888" indent="-319088"/>
-            <a:endParaRPr lang="en-US" sz="1800"/>
+            <a:endParaRPr lang="en-US" sz="1800" dirty="0"/>
           </a:p>
           <a:p>
             <a:pPr marL="623888" indent="-319088"/>
-            <a:endParaRPr lang="en-US" sz="1800"/>
+            <a:endParaRPr lang="en-US" sz="1800" dirty="0"/>
           </a:p>
           <a:p>
             <a:pPr marL="623888" indent="-319088"/>
             <a:r>
-              <a:rPr lang="en-US" sz="1800"/>
+              <a:rPr lang="en-US" sz="1800" dirty="0"/>
               <a:t>Three Cases</a:t>
+            </a:r>
+          </a:p>
+          <a:p>
+            <a:pPr marL="971550" lvl="1" indent="-234950">
+              <a:buNone/>
+            </a:pPr>
+            <a:r>
+              <a:rPr lang="en-US" sz="1800" dirty="0"/>
+              <a:t>1.  The retarding force is small: (</a:t>
+            </a:r>
+            <a:r>
+              <a:rPr lang="en-US" sz="1800" dirty="0" err="1"/>
+              <a:t>bv</a:t>
+            </a:r>
+            <a:r>
+              <a:rPr lang="en-US" sz="1800" baseline="-25000" dirty="0" err="1"/>
+              <a:t>max</a:t>
+            </a:r>
+            <a:r>
+              <a:rPr lang="en-US" sz="1800" dirty="0"/>
+              <a:t>&lt; kA), the system oscillates, but the amplitude is smaller as </a:t>
+            </a:r>
+            <a:r>
+              <a:rPr lang="en-US" sz="1800" dirty="0" err="1"/>
+              <a:t>as</a:t>
+            </a:r>
+            <a:r>
+              <a:rPr lang="en-US" sz="1800" dirty="0"/>
+              <a:t> time goes on. We call this "underdamped“</a:t>
             </a:r>
           </a:p>
           <a:p>
@@ -33595,50 +33058,72 @@
               <a:buFontTx/>
               <a:buAutoNum type="arabicPeriod"/>
             </a:pPr>
+            <a:endParaRPr lang="en-US" sz="1800" dirty="0"/>
+          </a:p>
+          <a:p>
+            <a:pPr marL="1027113" lvl="1" indent="-290513">
+              <a:buNone/>
+            </a:pPr>
             <a:r>
-              <a:rPr lang="en-US" sz="1800"/>
-              <a:t>The retarding force is small: (bv</a:t>
+              <a:rPr lang="en-US" sz="1800" dirty="0"/>
+              <a:t> 2. The retarding force is large: (</a:t>
             </a:r>
             <a:r>
-              <a:rPr lang="en-US" sz="1800" baseline="-25000"/>
+              <a:rPr lang="en-US" sz="1800" dirty="0" err="1"/>
+              <a:t>bv</a:t>
+            </a:r>
+            <a:r>
+              <a:rPr lang="en-US" sz="1800" baseline="-25000" dirty="0" err="1"/>
               <a:t>max</a:t>
             </a:r>
             <a:r>
-              <a:rPr lang="en-US" sz="1800"/>
-              <a:t>&lt; kA), the system oscillates, but the amplitude is smaller as as time goes on. We call this "underdamped"</a:t>
+              <a:rPr lang="en-US" sz="1800" dirty="0"/>
+              <a:t>&gt; kA), The system does not oscillate. we call this "overdamped." We can also say that             </a:t>
             </a:r>
           </a:p>
           <a:p>
-            <a:pPr marL="914400" lvl="1" indent="-176213">
-              <a:buFontTx/>
-              <a:buAutoNum type="arabicPeriod"/>
+            <a:pPr marL="738187" lvl="1" indent="0">
+              <a:buNone/>
             </a:pPr>
             <a:r>
-              <a:rPr lang="en-US" sz="1800"/>
-              <a:t> The retarding force is large: (bv</a:t>
+              <a:rPr lang="en-US" sz="1800" dirty="0"/>
+              <a:t>     </a:t>
+            </a:r>
+          </a:p>
+          <a:p>
+            <a:pPr marL="738187" lvl="1" indent="0">
+              <a:buNone/>
+            </a:pPr>
+            <a:endParaRPr lang="en-US" sz="1800" dirty="0"/>
+          </a:p>
+          <a:p>
+            <a:pPr marL="738187" lvl="1" indent="0">
+              <a:buNone/>
+            </a:pPr>
+            <a:endParaRPr lang="en-US" sz="1800" dirty="0"/>
+          </a:p>
+          <a:p>
+            <a:pPr marL="738187" lvl="1" indent="0">
+              <a:buNone/>
+            </a:pPr>
+            <a:r>
+              <a:rPr lang="en-US" sz="1800" dirty="0"/>
+              <a:t>       (after we define </a:t>
             </a:r>
             <a:r>
-              <a:rPr lang="en-US" sz="1800" baseline="-25000"/>
-              <a:t>max</a:t>
-            </a:r>
-            <a:r>
-              <a:rPr lang="en-US" sz="1800"/>
-              <a:t>&gt; kA), The system does not oscillate. we call this "overdamped." We can also say that             (after we define </a:t>
-            </a:r>
-            <a:r>
-              <a:rPr lang="en-US" sz="1800">
+              <a:rPr lang="en-US" sz="1800" dirty="0">
                 <a:sym typeface="Symbol" pitchFamily="18" charset="2"/>
               </a:rPr>
               <a:t></a:t>
             </a:r>
             <a:r>
-              <a:rPr lang="en-US" sz="1800" baseline="-25000">
+              <a:rPr lang="en-US" sz="1800" baseline="-25000" dirty="0">
                 <a:sym typeface="Symbol" pitchFamily="18" charset="2"/>
               </a:rPr>
-              <a:t>o</a:t>
+              <a:t>N</a:t>
             </a:r>
             <a:r>
-              <a:rPr lang="en-US" sz="1800"/>
+              <a:rPr lang="en-US" sz="1800" dirty="0"/>
               <a:t> below)</a:t>
             </a:r>
           </a:p>
@@ -33647,9 +33132,15 @@
               <a:buFontTx/>
               <a:buAutoNum type="arabicPeriod"/>
             </a:pPr>
+            <a:endParaRPr lang="en-US" sz="1800" dirty="0"/>
+          </a:p>
+          <a:p>
+            <a:pPr marL="738187" lvl="1" indent="0">
+              <a:buNone/>
+            </a:pPr>
             <a:r>
-              <a:rPr lang="en-US" sz="1800"/>
-              <a:t> Case The system is critically damped (see below)</a:t>
+              <a:rPr lang="en-US" sz="1800" dirty="0"/>
+              <a:t>3.  Case The system is critically damped (see below)</a:t>
             </a:r>
           </a:p>
         </p:txBody>
@@ -33710,10 +33201,16 @@
           <p:cNvGraphicFramePr>
             <a:graphicFrameLocks noChangeAspect="1"/>
           </p:cNvGraphicFramePr>
-          <p:nvPr/>
+          <p:nvPr>
+            <p:extLst>
+              <p:ext uri="{D42A27DB-BD31-4B8C-83A1-F6EECF244321}">
+                <p14:modId xmlns:p14="http://schemas.microsoft.com/office/powerpoint/2010/main" val="2741392713"/>
+              </p:ext>
+            </p:extLst>
+          </p:nvPr>
         </p:nvGraphicFramePr>
         <p:xfrm>
-          <a:off x="4803775" y="1685925"/>
+          <a:off x="4713464" y="1317991"/>
           <a:ext cx="3416300" cy="573088"/>
         </p:xfrm>
         <a:graphic>
@@ -33750,7 +33247,7 @@
                     </p:blipFill>
                     <p:spPr bwMode="auto">
                       <a:xfrm>
-                        <a:off x="4803775" y="1685925"/>
+                        <a:off x="4713464" y="1317991"/>
                         <a:ext cx="3416300" cy="573088"/>
                       </a:xfrm>
                       <a:prstGeom prst="rect">
@@ -33846,14 +33343,14 @@
           <p:nvPr>
             <p:extLst>
               <p:ext uri="{D42A27DB-BD31-4B8C-83A1-F6EECF244321}">
-                <p14:modId xmlns:p14="http://schemas.microsoft.com/office/powerpoint/2010/main" val="1460304110"/>
+                <p14:modId xmlns:p14="http://schemas.microsoft.com/office/powerpoint/2010/main" val="2864676412"/>
               </p:ext>
             </p:extLst>
           </p:nvPr>
         </p:nvGraphicFramePr>
         <p:xfrm>
-          <a:off x="5348806" y="2747354"/>
-          <a:ext cx="1494388" cy="679267"/>
+          <a:off x="5181394" y="2147899"/>
+          <a:ext cx="2180883" cy="991310"/>
         </p:xfrm>
         <a:graphic>
           <a:graphicData uri="http://schemas.openxmlformats.org/presentationml/2006/ole">
@@ -33889,8 +33386,8 @@
                     </p:blipFill>
                     <p:spPr bwMode="auto">
                       <a:xfrm>
-                        <a:off x="5348806" y="2747354"/>
-                        <a:ext cx="1494388" cy="679267"/>
+                        <a:off x="5181394" y="2147899"/>
+                        <a:ext cx="2180883" cy="991310"/>
                       </a:xfrm>
                       <a:prstGeom prst="rect">
                         <a:avLst/>
@@ -34007,89 +33504,176 @@
           </a:p>
         </p:txBody>
       </p:sp>
-      <p:graphicFrame>
-        <p:nvGraphicFramePr>
-          <p:cNvPr id="13323" name="Object 10"/>
-          <p:cNvGraphicFramePr>
-            <a:graphicFrameLocks noChangeAspect="1"/>
-          </p:cNvGraphicFramePr>
-          <p:nvPr/>
-        </p:nvGraphicFramePr>
-        <p:xfrm>
-          <a:off x="8969376" y="4281489"/>
-          <a:ext cx="741363" cy="338137"/>
-        </p:xfrm>
-        <a:graphic>
-          <a:graphicData uri="http://schemas.openxmlformats.org/presentationml/2006/ole">
-            <mc:AlternateContent xmlns:mc="http://schemas.openxmlformats.org/markup-compatibility/2006">
-              <mc:Choice xmlns:v="urn:schemas-microsoft-com:vml" Requires="v">
-                <p:oleObj name="Equation" r:id="rId6" imgW="495085" imgH="228501" progId="Equation.3">
-                  <p:embed/>
-                </p:oleObj>
-              </mc:Choice>
-              <mc:Fallback>
-                <p:oleObj name="Equation" r:id="rId6" imgW="495085" imgH="228501" progId="Equation.3">
-                  <p:embed/>
-                  <p:pic>
-                    <p:nvPicPr>
-                      <p:cNvPr id="13323" name="Object 10"/>
-                      <p:cNvPicPr>
-                        <a:picLocks noChangeAspect="1" noChangeArrowheads="1"/>
-                      </p:cNvPicPr>
-                      <p:nvPr/>
-                    </p:nvPicPr>
-                    <p:blipFill>
-                      <a:blip r:embed="rId7">
-                        <a:extLst>
-                          <a:ext uri="{28A0092B-C50C-407E-A947-70E740481C1C}">
-                            <a14:useLocalDpi xmlns:a14="http://schemas.microsoft.com/office/drawing/2010/main" val="0"/>
-                          </a:ext>
-                        </a:extLst>
-                      </a:blip>
-                      <a:srcRect/>
-                      <a:stretch>
-                        <a:fillRect/>
-                      </a:stretch>
-                    </p:blipFill>
-                    <p:spPr bwMode="auto">
-                      <a:xfrm>
-                        <a:off x="8969376" y="4281489"/>
-                        <a:ext cx="741363" cy="338137"/>
-                      </a:xfrm>
-                      <a:prstGeom prst="rect">
-                        <a:avLst/>
-                      </a:prstGeom>
-                      <a:noFill/>
-                      <a:ln>
-                        <a:noFill/>
-                      </a:ln>
-                      <a:extLst>
-                        <a:ext uri="{909E8E84-426E-40DD-AFC4-6F175D3DCCD1}">
-                          <a14:hiddenFill xmlns:a14="http://schemas.microsoft.com/office/drawing/2010/main">
-                            <a:solidFill>
-                              <a:srgbClr val="FFFFFF"/>
-                            </a:solidFill>
-                          </a14:hiddenFill>
-                        </a:ext>
-                        <a:ext uri="{91240B29-F687-4F45-9708-019B960494DF}">
-                          <a14:hiddenLine xmlns:a14="http://schemas.microsoft.com/office/drawing/2010/main" w="9525">
-                            <a:solidFill>
-                              <a:srgbClr val="000000"/>
-                            </a:solidFill>
-                            <a:miter lim="800000"/>
-                            <a:headEnd/>
-                            <a:tailEnd/>
-                          </a14:hiddenLine>
-                        </a:ext>
-                      </a:extLst>
-                    </p:spPr>
-                  </p:pic>
-                </p:oleObj>
-              </mc:Fallback>
-            </mc:AlternateContent>
-          </a:graphicData>
-        </a:graphic>
-      </p:graphicFrame>
+      <mc:AlternateContent xmlns:mc="http://schemas.openxmlformats.org/markup-compatibility/2006">
+        <mc:Choice xmlns:a14="http://schemas.microsoft.com/office/drawing/2010/main" Requires="a14">
+          <p:sp>
+            <p:nvSpPr>
+              <p:cNvPr id="13323" name="Object 10"/>
+              <p:cNvSpPr txBox="1"/>
+              <p:nvPr/>
+            </p:nvSpPr>
+            <p:spPr bwMode="auto">
+              <a:xfrm>
+                <a:off x="5395883" y="5027966"/>
+                <a:ext cx="1614517" cy="684212"/>
+              </a:xfrm>
+              <a:prstGeom prst="rect">
+                <a:avLst/>
+              </a:prstGeom>
+              <a:noFill/>
+              <a:ln>
+                <a:noFill/>
+              </a:ln>
+            </p:spPr>
+            <p:txBody>
+              <a:bodyPr>
+                <a:normAutofit/>
+              </a:bodyPr>
+              <a:lstStyle/>
+              <a:p>
+                <a:pPr/>
+                <a14:m>
+                  <m:oMathPara xmlns:m="http://schemas.openxmlformats.org/officeDocument/2006/math">
+                    <m:oMathParaPr>
+                      <m:jc m:val="left"/>
+                    </m:oMathParaPr>
+                    <m:oMath xmlns:m="http://schemas.openxmlformats.org/officeDocument/2006/math">
+                      <m:f>
+                        <m:fPr>
+                          <m:ctrlPr>
+                            <a:rPr lang="en-US" i="1" smtClean="0">
+                              <a:solidFill>
+                                <a:srgbClr val="000000"/>
+                              </a:solidFill>
+                              <a:latin typeface="Cambria Math" panose="02040503050406030204" pitchFamily="18" charset="0"/>
+                            </a:rPr>
+                          </m:ctrlPr>
+                        </m:fPr>
+                        <m:num>
+                          <m:r>
+                            <a:rPr lang="en-US" i="1">
+                              <a:solidFill>
+                                <a:srgbClr val="000000"/>
+                              </a:solidFill>
+                              <a:latin typeface="Cambria Math" panose="02040503050406030204" pitchFamily="18" charset="0"/>
+                            </a:rPr>
+                            <m:t>𝑏</m:t>
+                          </m:r>
+                        </m:num>
+                        <m:den>
+                          <m:r>
+                            <a:rPr lang="en-US" i="1">
+                              <a:solidFill>
+                                <a:srgbClr val="000000"/>
+                              </a:solidFill>
+                              <a:latin typeface="Cambria Math" panose="02040503050406030204" pitchFamily="18" charset="0"/>
+                            </a:rPr>
+                            <m:t>2</m:t>
+                          </m:r>
+                          <m:r>
+                            <a:rPr lang="en-US" i="1">
+                              <a:solidFill>
+                                <a:srgbClr val="000000"/>
+                              </a:solidFill>
+                              <a:latin typeface="Cambria Math" panose="02040503050406030204" pitchFamily="18" charset="0"/>
+                            </a:rPr>
+                            <m:t>𝑚</m:t>
+                          </m:r>
+                        </m:den>
+                      </m:f>
+                      <m:r>
+                        <a:rPr lang="en-US" i="1">
+                          <a:solidFill>
+                            <a:srgbClr val="000000"/>
+                          </a:solidFill>
+                          <a:latin typeface="Cambria Math" panose="02040503050406030204" pitchFamily="18" charset="0"/>
+                        </a:rPr>
+                        <m:t>&gt;</m:t>
+                      </m:r>
+                      <m:sSub>
+                        <m:sSubPr>
+                          <m:ctrlPr>
+                            <a:rPr lang="en-US" i="1">
+                              <a:solidFill>
+                                <a:srgbClr val="000000"/>
+                              </a:solidFill>
+                              <a:latin typeface="Cambria Math" panose="02040503050406030204" pitchFamily="18" charset="0"/>
+                            </a:rPr>
+                          </m:ctrlPr>
+                        </m:sSubPr>
+                        <m:e>
+                          <m:r>
+                            <a:rPr lang="en-US" i="1">
+                              <a:solidFill>
+                                <a:srgbClr val="000000"/>
+                              </a:solidFill>
+                              <a:latin typeface="Cambria Math" panose="02040503050406030204" pitchFamily="18" charset="0"/>
+                            </a:rPr>
+                            <m:t>𝜔</m:t>
+                          </m:r>
+                        </m:e>
+                        <m:sub>
+                          <m:r>
+                            <a:rPr lang="en-US" b="0" i="1" smtClean="0">
+                              <a:solidFill>
+                                <a:srgbClr val="000000"/>
+                              </a:solidFill>
+                              <a:latin typeface="Cambria Math" panose="02040503050406030204" pitchFamily="18" charset="0"/>
+                            </a:rPr>
+                            <m:t>𝑁</m:t>
+                          </m:r>
+                        </m:sub>
+                      </m:sSub>
+                    </m:oMath>
+                  </m:oMathPara>
+                </a14:m>
+                <a:endParaRPr lang="en-US" dirty="0"/>
+              </a:p>
+            </p:txBody>
+          </p:sp>
+        </mc:Choice>
+        <mc:Fallback>
+          <p:sp>
+            <p:nvSpPr>
+              <p:cNvPr id="13323" name="Object 10"/>
+              <p:cNvSpPr txBox="1">
+                <a:spLocks noRot="1" noChangeAspect="1" noMove="1" noResize="1" noEditPoints="1" noAdjustHandles="1" noChangeArrowheads="1" noChangeShapeType="1" noTextEdit="1"/>
+              </p:cNvSpPr>
+              <p:nvPr/>
+            </p:nvSpPr>
+            <p:spPr bwMode="auto">
+              <a:xfrm>
+                <a:off x="5395883" y="5027966"/>
+                <a:ext cx="1614517" cy="684212"/>
+              </a:xfrm>
+              <a:prstGeom prst="rect">
+                <a:avLst/>
+              </a:prstGeom>
+              <a:blipFill>
+                <a:blip r:embed="rId6"/>
+                <a:stretch>
+                  <a:fillRect/>
+                </a:stretch>
+              </a:blipFill>
+              <a:ln>
+                <a:noFill/>
+              </a:ln>
+            </p:spPr>
+            <p:txBody>
+              <a:bodyPr/>
+              <a:lstStyle/>
+              <a:p>
+                <a:r>
+                  <a:rPr lang="en-US">
+                    <a:noFill/>
+                  </a:rPr>
+                  <a:t> </a:t>
+                </a:r>
+              </a:p>
+            </p:txBody>
+          </p:sp>
+        </mc:Fallback>
+      </mc:AlternateContent>
     </p:spTree>
   </p:cSld>
   <p:clrMapOvr>
@@ -34439,89 +34023,6 @@
           </a:graphicData>
         </a:graphic>
       </p:graphicFrame>
-      <p:graphicFrame>
-        <p:nvGraphicFramePr>
-          <p:cNvPr id="14343" name="Object 6"/>
-          <p:cNvGraphicFramePr>
-            <a:graphicFrameLocks noChangeAspect="1"/>
-          </p:cNvGraphicFramePr>
-          <p:nvPr/>
-        </p:nvGraphicFramePr>
-        <p:xfrm>
-          <a:off x="7770813" y="5553076"/>
-          <a:ext cx="679450" cy="290513"/>
-        </p:xfrm>
-        <a:graphic>
-          <a:graphicData uri="http://schemas.openxmlformats.org/presentationml/2006/ole">
-            <mc:AlternateContent xmlns:mc="http://schemas.openxmlformats.org/markup-compatibility/2006">
-              <mc:Choice xmlns:v="urn:schemas-microsoft-com:vml" Requires="v">
-                <p:oleObj name="Equation" r:id="rId4" imgW="533169" imgH="228501" progId="Equation.3">
-                  <p:embed/>
-                </p:oleObj>
-              </mc:Choice>
-              <mc:Fallback>
-                <p:oleObj name="Equation" r:id="rId4" imgW="533169" imgH="228501" progId="Equation.3">
-                  <p:embed/>
-                  <p:pic>
-                    <p:nvPicPr>
-                      <p:cNvPr id="14343" name="Object 6"/>
-                      <p:cNvPicPr>
-                        <a:picLocks noChangeAspect="1" noChangeArrowheads="1"/>
-                      </p:cNvPicPr>
-                      <p:nvPr/>
-                    </p:nvPicPr>
-                    <p:blipFill>
-                      <a:blip r:embed="rId5">
-                        <a:extLst>
-                          <a:ext uri="{28A0092B-C50C-407E-A947-70E740481C1C}">
-                            <a14:useLocalDpi xmlns:a14="http://schemas.microsoft.com/office/drawing/2010/main" val="0"/>
-                          </a:ext>
-                        </a:extLst>
-                      </a:blip>
-                      <a:srcRect/>
-                      <a:stretch>
-                        <a:fillRect/>
-                      </a:stretch>
-                    </p:blipFill>
-                    <p:spPr bwMode="auto">
-                      <a:xfrm>
-                        <a:off x="7770813" y="5553076"/>
-                        <a:ext cx="679450" cy="290513"/>
-                      </a:xfrm>
-                      <a:prstGeom prst="rect">
-                        <a:avLst/>
-                      </a:prstGeom>
-                      <a:noFill/>
-                      <a:ln>
-                        <a:noFill/>
-                      </a:ln>
-                      <a:extLst>
-                        <a:ext uri="{909E8E84-426E-40DD-AFC4-6F175D3DCCD1}">
-                          <a14:hiddenFill xmlns:a14="http://schemas.microsoft.com/office/drawing/2010/main">
-                            <a:solidFill>
-                              <a:srgbClr val="FFFFFF"/>
-                            </a:solidFill>
-                          </a14:hiddenFill>
-                        </a:ext>
-                        <a:ext uri="{91240B29-F687-4F45-9708-019B960494DF}">
-                          <a14:hiddenLine xmlns:a14="http://schemas.microsoft.com/office/drawing/2010/main" w="9525">
-                            <a:solidFill>
-                              <a:srgbClr val="000000"/>
-                            </a:solidFill>
-                            <a:miter lim="800000"/>
-                            <a:headEnd/>
-                            <a:tailEnd/>
-                          </a14:hiddenLine>
-                        </a:ext>
-                      </a:extLst>
-                    </p:spPr>
-                  </p:pic>
-                </p:oleObj>
-              </mc:Fallback>
-            </mc:AlternateContent>
-          </a:graphicData>
-        </a:graphic>
-      </p:graphicFrame>
       <p:sp>
         <p:nvSpPr>
           <p:cNvPr id="14344" name="Rectangle 7"/>
@@ -34581,7 +34082,7 @@
           <p:nvPr/>
         </p:nvPicPr>
         <p:blipFill>
-          <a:blip r:embed="rId6">
+          <a:blip r:embed="rId4">
             <a:extLst>
               <a:ext uri="{28A0092B-C50C-407E-A947-70E740481C1C}">
                 <a14:useLocalDpi xmlns:a14="http://schemas.microsoft.com/office/drawing/2010/main" val="0"/>
@@ -34636,6 +34137,76 @@
           </a:extLst>
         </p:spPr>
       </p:pic>
+      <p:graphicFrame>
+        <p:nvGraphicFramePr>
+          <p:cNvPr id="14343" name="Object 6"/>
+          <p:cNvGraphicFramePr>
+            <a:graphicFrameLocks noChangeAspect="1"/>
+          </p:cNvGraphicFramePr>
+          <p:nvPr>
+            <p:extLst>
+              <p:ext uri="{D42A27DB-BD31-4B8C-83A1-F6EECF244321}">
+                <p14:modId xmlns:p14="http://schemas.microsoft.com/office/powerpoint/2010/main" val="4088029885"/>
+              </p:ext>
+            </p:extLst>
+          </p:nvPr>
+        </p:nvGraphicFramePr>
+        <p:xfrm>
+          <a:off x="5935909" y="2712546"/>
+          <a:ext cx="784406" cy="335389"/>
+        </p:xfrm>
+        <a:graphic>
+          <a:graphicData uri="http://schemas.openxmlformats.org/presentationml/2006/ole">
+            <mc:AlternateContent xmlns:mc="http://schemas.openxmlformats.org/markup-compatibility/2006">
+              <mc:Choice xmlns:v="urn:schemas-microsoft-com:vml" Requires="v">
+                <p:oleObj name="Equation" r:id="rId5" imgW="533169" imgH="228501" progId="Equation.3">
+                  <p:embed/>
+                </p:oleObj>
+              </mc:Choice>
+              <mc:Fallback>
+                <p:oleObj name="Equation" r:id="rId5" imgW="533169" imgH="228501" progId="Equation.3">
+                  <p:embed/>
+                  <p:pic>
+                    <p:nvPicPr>
+                      <p:cNvPr id="14343" name="Object 6"/>
+                      <p:cNvPicPr>
+                        <a:picLocks noChangeAspect="1" noChangeArrowheads="1"/>
+                      </p:cNvPicPr>
+                      <p:nvPr/>
+                    </p:nvPicPr>
+                    <p:blipFill>
+                      <a:blip r:embed="rId6">
+                        <a:extLst>
+                          <a:ext uri="{28A0092B-C50C-407E-A947-70E740481C1C}">
+                            <a14:useLocalDpi xmlns:a14="http://schemas.microsoft.com/office/drawing/2010/main" val="0"/>
+                          </a:ext>
+                        </a:extLst>
+                      </a:blip>
+                      <a:srcRect/>
+                      <a:stretch>
+                        <a:fillRect/>
+                      </a:stretch>
+                    </p:blipFill>
+                    <p:spPr bwMode="auto">
+                      <a:xfrm>
+                        <a:off x="5935909" y="2712546"/>
+                        <a:ext cx="784406" cy="335389"/>
+                      </a:xfrm>
+                      <a:prstGeom prst="rect">
+                        <a:avLst/>
+                      </a:prstGeom>
+                      <a:noFill/>
+                      <a:ln>
+                        <a:noFill/>
+                      </a:ln>
+                    </p:spPr>
+                  </p:pic>
+                </p:oleObj>
+              </mc:Fallback>
+            </mc:AlternateContent>
+          </a:graphicData>
+        </a:graphic>
+      </p:graphicFrame>
     </p:spTree>
   </p:cSld>
   <p:clrMapOvr>
@@ -36236,89 +35807,235 @@
           </a:p>
         </p:txBody>
       </p:sp>
-      <p:graphicFrame>
-        <p:nvGraphicFramePr>
-          <p:cNvPr id="17414" name="Object 5"/>
-          <p:cNvGraphicFramePr>
-            <a:graphicFrameLocks noChangeAspect="1"/>
-          </p:cNvGraphicFramePr>
-          <p:nvPr/>
-        </p:nvGraphicFramePr>
-        <p:xfrm>
-          <a:off x="6961189" y="1252539"/>
-          <a:ext cx="1296987" cy="592137"/>
-        </p:xfrm>
-        <a:graphic>
-          <a:graphicData uri="http://schemas.openxmlformats.org/presentationml/2006/ole">
-            <mc:AlternateContent xmlns:mc="http://schemas.openxmlformats.org/markup-compatibility/2006">
-              <mc:Choice xmlns:v="urn:schemas-microsoft-com:vml" Requires="v">
-                <p:oleObj name="Equation" r:id="rId2" imgW="977476" imgH="444307" progId="Equation.3">
-                  <p:embed/>
-                </p:oleObj>
-              </mc:Choice>
-              <mc:Fallback>
-                <p:oleObj name="Equation" r:id="rId2" imgW="977476" imgH="444307" progId="Equation.3">
-                  <p:embed/>
-                  <p:pic>
-                    <p:nvPicPr>
-                      <p:cNvPr id="17414" name="Object 5"/>
-                      <p:cNvPicPr>
-                        <a:picLocks noChangeAspect="1" noChangeArrowheads="1"/>
-                      </p:cNvPicPr>
-                      <p:nvPr/>
-                    </p:nvPicPr>
-                    <p:blipFill>
-                      <a:blip r:embed="rId3">
-                        <a:extLst>
-                          <a:ext uri="{28A0092B-C50C-407E-A947-70E740481C1C}">
-                            <a14:useLocalDpi xmlns:a14="http://schemas.microsoft.com/office/drawing/2010/main" val="0"/>
-                          </a:ext>
-                        </a:extLst>
-                      </a:blip>
-                      <a:srcRect/>
-                      <a:stretch>
-                        <a:fillRect/>
-                      </a:stretch>
-                    </p:blipFill>
-                    <p:spPr bwMode="auto">
-                      <a:xfrm>
-                        <a:off x="6961189" y="1252539"/>
-                        <a:ext cx="1296987" cy="592137"/>
-                      </a:xfrm>
-                      <a:prstGeom prst="rect">
-                        <a:avLst/>
-                      </a:prstGeom>
-                      <a:noFill/>
-                      <a:ln>
-                        <a:noFill/>
-                      </a:ln>
-                      <a:extLst>
-                        <a:ext uri="{909E8E84-426E-40DD-AFC4-6F175D3DCCD1}">
-                          <a14:hiddenFill xmlns:a14="http://schemas.microsoft.com/office/drawing/2010/main">
-                            <a:solidFill>
-                              <a:srgbClr val="FFFFFF"/>
-                            </a:solidFill>
-                          </a14:hiddenFill>
-                        </a:ext>
-                        <a:ext uri="{91240B29-F687-4F45-9708-019B960494DF}">
-                          <a14:hiddenLine xmlns:a14="http://schemas.microsoft.com/office/drawing/2010/main" w="9525">
-                            <a:solidFill>
-                              <a:srgbClr val="000000"/>
-                            </a:solidFill>
-                            <a:miter lim="800000"/>
-                            <a:headEnd/>
-                            <a:tailEnd/>
-                          </a14:hiddenLine>
-                        </a:ext>
-                      </a:extLst>
-                    </p:spPr>
-                  </p:pic>
-                </p:oleObj>
-              </mc:Fallback>
-            </mc:AlternateContent>
-          </a:graphicData>
-        </a:graphic>
-      </p:graphicFrame>
+      <mc:AlternateContent xmlns:mc="http://schemas.openxmlformats.org/markup-compatibility/2006">
+        <mc:Choice xmlns:a14="http://schemas.microsoft.com/office/drawing/2010/main" Requires="a14">
+          <p:sp>
+            <p:nvSpPr>
+              <p:cNvPr id="17414" name="Object 5"/>
+              <p:cNvSpPr txBox="1"/>
+              <p:nvPr/>
+            </p:nvSpPr>
+            <p:spPr bwMode="auto">
+              <a:xfrm>
+                <a:off x="6961188" y="1252538"/>
+                <a:ext cx="1296987" cy="592137"/>
+              </a:xfrm>
+              <a:prstGeom prst="rect">
+                <a:avLst/>
+              </a:prstGeom>
+              <a:noFill/>
+              <a:ln>
+                <a:noFill/>
+              </a:ln>
+            </p:spPr>
+            <p:txBody>
+              <a:bodyPr>
+                <a:normAutofit fontScale="62500" lnSpcReduction="20000"/>
+              </a:bodyPr>
+              <a:lstStyle/>
+              <a:p>
+                <a:pPr/>
+                <a14:m>
+                  <m:oMathPara xmlns:m="http://schemas.openxmlformats.org/officeDocument/2006/math">
+                    <m:oMathParaPr>
+                      <m:jc m:val="left"/>
+                    </m:oMathParaPr>
+                    <m:oMath xmlns:m="http://schemas.openxmlformats.org/officeDocument/2006/math">
+                      <m:f>
+                        <m:fPr>
+                          <m:ctrlPr>
+                            <a:rPr lang="en-US" i="1" smtClean="0">
+                              <a:solidFill>
+                                <a:srgbClr val="000000"/>
+                              </a:solidFill>
+                              <a:latin typeface="Cambria Math" panose="02040503050406030204" pitchFamily="18" charset="0"/>
+                            </a:rPr>
+                          </m:ctrlPr>
+                        </m:fPr>
+                        <m:num>
+                          <m:r>
+                            <a:rPr lang="en-US" i="1">
+                              <a:solidFill>
+                                <a:srgbClr val="000000"/>
+                              </a:solidFill>
+                              <a:latin typeface="Cambria Math" panose="02040503050406030204" pitchFamily="18" charset="0"/>
+                            </a:rPr>
+                            <m:t>𝑏</m:t>
+                          </m:r>
+                        </m:num>
+                        <m:den>
+                          <m:r>
+                            <a:rPr lang="en-US" i="1">
+                              <a:solidFill>
+                                <a:srgbClr val="000000"/>
+                              </a:solidFill>
+                              <a:latin typeface="Cambria Math" panose="02040503050406030204" pitchFamily="18" charset="0"/>
+                            </a:rPr>
+                            <m:t>2</m:t>
+                          </m:r>
+                          <m:r>
+                            <a:rPr lang="en-US" i="1">
+                              <a:solidFill>
+                                <a:srgbClr val="000000"/>
+                              </a:solidFill>
+                              <a:latin typeface="Cambria Math" panose="02040503050406030204" pitchFamily="18" charset="0"/>
+                            </a:rPr>
+                            <m:t>𝑚</m:t>
+                          </m:r>
+                        </m:den>
+                      </m:f>
+                      <m:r>
+                        <a:rPr lang="en-US" i="1">
+                          <a:solidFill>
+                            <a:srgbClr val="000000"/>
+                          </a:solidFill>
+                          <a:latin typeface="Cambria Math" panose="02040503050406030204" pitchFamily="18" charset="0"/>
+                        </a:rPr>
+                        <m:t>=</m:t>
+                      </m:r>
+                      <m:sSub>
+                        <m:sSubPr>
+                          <m:ctrlPr>
+                            <a:rPr lang="en-US" i="1">
+                              <a:solidFill>
+                                <a:srgbClr val="000000"/>
+                              </a:solidFill>
+                              <a:latin typeface="Cambria Math" panose="02040503050406030204" pitchFamily="18" charset="0"/>
+                            </a:rPr>
+                          </m:ctrlPr>
+                        </m:sSubPr>
+                        <m:e>
+                          <m:r>
+                            <a:rPr lang="en-US" i="1">
+                              <a:solidFill>
+                                <a:srgbClr val="000000"/>
+                              </a:solidFill>
+                              <a:latin typeface="Cambria Math" panose="02040503050406030204" pitchFamily="18" charset="0"/>
+                            </a:rPr>
+                            <m:t>𝜔</m:t>
+                          </m:r>
+                        </m:e>
+                        <m:sub>
+                          <m:r>
+                            <a:rPr lang="en-US" b="0" i="1" smtClean="0">
+                              <a:solidFill>
+                                <a:srgbClr val="000000"/>
+                              </a:solidFill>
+                              <a:latin typeface="Cambria Math" panose="02040503050406030204" pitchFamily="18" charset="0"/>
+                            </a:rPr>
+                            <m:t>𝑁</m:t>
+                          </m:r>
+                        </m:sub>
+                      </m:sSub>
+                      <m:r>
+                        <a:rPr lang="en-US" i="1">
+                          <a:solidFill>
+                            <a:srgbClr val="000000"/>
+                          </a:solidFill>
+                          <a:latin typeface="Cambria Math" panose="02040503050406030204" pitchFamily="18" charset="0"/>
+                        </a:rPr>
+                        <m:t>=</m:t>
+                      </m:r>
+                      <m:rad>
+                        <m:radPr>
+                          <m:degHide m:val="on"/>
+                          <m:ctrlPr>
+                            <a:rPr lang="en-US" i="1">
+                              <a:solidFill>
+                                <a:srgbClr val="000000"/>
+                              </a:solidFill>
+                              <a:latin typeface="Cambria Math" panose="02040503050406030204" pitchFamily="18" charset="0"/>
+                            </a:rPr>
+                          </m:ctrlPr>
+                        </m:radPr>
+                        <m:deg/>
+                        <m:e>
+                          <m:f>
+                            <m:fPr>
+                              <m:ctrlPr>
+                                <a:rPr lang="en-US" i="1">
+                                  <a:solidFill>
+                                    <a:srgbClr val="000000"/>
+                                  </a:solidFill>
+                                  <a:latin typeface="Cambria Math" panose="02040503050406030204" pitchFamily="18" charset="0"/>
+                                </a:rPr>
+                              </m:ctrlPr>
+                            </m:fPr>
+                            <m:num>
+                              <m:r>
+                                <a:rPr lang="en-US" i="1">
+                                  <a:solidFill>
+                                    <a:srgbClr val="000000"/>
+                                  </a:solidFill>
+                                  <a:latin typeface="Cambria Math" panose="02040503050406030204" pitchFamily="18" charset="0"/>
+                                </a:rPr>
+                                <m:t>𝑘</m:t>
+                              </m:r>
+                            </m:num>
+                            <m:den>
+                              <m:r>
+                                <a:rPr lang="en-US" i="1">
+                                  <a:solidFill>
+                                    <a:srgbClr val="000000"/>
+                                  </a:solidFill>
+                                  <a:latin typeface="Cambria Math" panose="02040503050406030204" pitchFamily="18" charset="0"/>
+                                </a:rPr>
+                                <m:t>𝑚</m:t>
+                              </m:r>
+                            </m:den>
+                          </m:f>
+                        </m:e>
+                      </m:rad>
+                    </m:oMath>
+                  </m:oMathPara>
+                </a14:m>
+                <a:endParaRPr lang="en-US" dirty="0"/>
+              </a:p>
+            </p:txBody>
+          </p:sp>
+        </mc:Choice>
+        <mc:Fallback>
+          <p:sp>
+            <p:nvSpPr>
+              <p:cNvPr id="17414" name="Object 5"/>
+              <p:cNvSpPr txBox="1">
+                <a:spLocks noRot="1" noChangeAspect="1" noMove="1" noResize="1" noEditPoints="1" noAdjustHandles="1" noChangeArrowheads="1" noChangeShapeType="1" noTextEdit="1"/>
+              </p:cNvSpPr>
+              <p:nvPr/>
+            </p:nvSpPr>
+            <p:spPr bwMode="auto">
+              <a:xfrm>
+                <a:off x="6961188" y="1252538"/>
+                <a:ext cx="1296987" cy="592137"/>
+              </a:xfrm>
+              <a:prstGeom prst="rect">
+                <a:avLst/>
+              </a:prstGeom>
+              <a:blipFill>
+                <a:blip r:embed="rId2"/>
+                <a:stretch>
+                  <a:fillRect/>
+                </a:stretch>
+              </a:blipFill>
+              <a:ln>
+                <a:noFill/>
+              </a:ln>
+            </p:spPr>
+            <p:txBody>
+              <a:bodyPr/>
+              <a:lstStyle/>
+              <a:p>
+                <a:r>
+                  <a:rPr lang="en-US">
+                    <a:noFill/>
+                  </a:rPr>
+                  <a:t> </a:t>
+                </a:r>
+              </a:p>
+            </p:txBody>
+          </p:sp>
+        </mc:Fallback>
+      </mc:AlternateContent>
       <p:sp>
         <p:nvSpPr>
           <p:cNvPr id="17415" name="Rectangle 6"/>
@@ -36391,12 +36108,12 @@
           <a:graphicData uri="http://schemas.openxmlformats.org/presentationml/2006/ole">
             <mc:AlternateContent xmlns:mc="http://schemas.openxmlformats.org/markup-compatibility/2006">
               <mc:Choice xmlns:v="urn:schemas-microsoft-com:vml" Requires="v">
-                <p:oleObj name="Equation" r:id="rId4" imgW="1358900" imgH="508000" progId="Equation.3">
+                <p:oleObj name="Equation" r:id="rId3" imgW="1358900" imgH="508000" progId="Equation.3">
                   <p:embed/>
                 </p:oleObj>
               </mc:Choice>
               <mc:Fallback>
-                <p:oleObj name="Equation" r:id="rId4" imgW="1358900" imgH="508000" progId="Equation.3">
+                <p:oleObj name="Equation" r:id="rId3" imgW="1358900" imgH="508000" progId="Equation.3">
                   <p:embed/>
                   <p:pic>
                     <p:nvPicPr>
@@ -36407,7 +36124,7 @@
                       <p:nvPr/>
                     </p:nvPicPr>
                     <p:blipFill>
-                      <a:blip r:embed="rId5">
+                      <a:blip r:embed="rId4">
                         <a:extLst>
                           <a:ext uri="{28A0092B-C50C-407E-A947-70E740481C1C}">
                             <a14:useLocalDpi xmlns:a14="http://schemas.microsoft.com/office/drawing/2010/main" val="0"/>
@@ -36508,95 +36225,183 @@
           </a:p>
         </p:txBody>
       </p:sp>
-      <p:graphicFrame>
-        <p:nvGraphicFramePr>
-          <p:cNvPr id="17418" name="Object 9"/>
-          <p:cNvGraphicFramePr>
-            <a:graphicFrameLocks noChangeAspect="1"/>
-          </p:cNvGraphicFramePr>
-          <p:nvPr>
-            <p:extLst>
-              <p:ext uri="{D42A27DB-BD31-4B8C-83A1-F6EECF244321}">
-                <p14:modId xmlns:p14="http://schemas.microsoft.com/office/powerpoint/2010/main" val="2457363167"/>
-              </p:ext>
-            </p:extLst>
-          </p:nvPr>
-        </p:nvGraphicFramePr>
-        <p:xfrm>
-          <a:off x="3221038" y="2715141"/>
-          <a:ext cx="844550" cy="615950"/>
-        </p:xfrm>
-        <a:graphic>
-          <a:graphicData uri="http://schemas.openxmlformats.org/presentationml/2006/ole">
-            <mc:AlternateContent xmlns:mc="http://schemas.openxmlformats.org/markup-compatibility/2006">
-              <mc:Choice xmlns:v="urn:schemas-microsoft-com:vml" Requires="v">
-                <p:oleObj name="Equation" r:id="rId6" imgW="609336" imgH="444307" progId="Equation.3">
-                  <p:embed/>
-                </p:oleObj>
-              </mc:Choice>
-              <mc:Fallback>
-                <p:oleObj name="Equation" r:id="rId6" imgW="609336" imgH="444307" progId="Equation.3">
-                  <p:embed/>
-                  <p:pic>
-                    <p:nvPicPr>
-                      <p:cNvPr id="17418" name="Object 9"/>
-                      <p:cNvPicPr>
-                        <a:picLocks noChangeAspect="1" noChangeArrowheads="1"/>
-                      </p:cNvPicPr>
-                      <p:nvPr/>
-                    </p:nvPicPr>
-                    <p:blipFill>
-                      <a:blip r:embed="rId7">
-                        <a:extLst>
-                          <a:ext uri="{28A0092B-C50C-407E-A947-70E740481C1C}">
-                            <a14:useLocalDpi xmlns:a14="http://schemas.microsoft.com/office/drawing/2010/main" val="0"/>
-                          </a:ext>
-                        </a:extLst>
-                      </a:blip>
-                      <a:srcRect/>
-                      <a:stretch>
-                        <a:fillRect/>
-                      </a:stretch>
-                    </p:blipFill>
-                    <p:spPr bwMode="auto">
-                      <a:xfrm>
-                        <a:off x="3221038" y="2715141"/>
-                        <a:ext cx="844550" cy="615950"/>
-                      </a:xfrm>
-                      <a:prstGeom prst="rect">
-                        <a:avLst/>
-                      </a:prstGeom>
-                      <a:noFill/>
-                      <a:ln>
-                        <a:noFill/>
-                      </a:ln>
-                      <a:extLst>
-                        <a:ext uri="{909E8E84-426E-40DD-AFC4-6F175D3DCCD1}">
-                          <a14:hiddenFill xmlns:a14="http://schemas.microsoft.com/office/drawing/2010/main">
-                            <a:solidFill>
-                              <a:srgbClr val="FFFFFF"/>
-                            </a:solidFill>
-                          </a14:hiddenFill>
-                        </a:ext>
-                        <a:ext uri="{91240B29-F687-4F45-9708-019B960494DF}">
-                          <a14:hiddenLine xmlns:a14="http://schemas.microsoft.com/office/drawing/2010/main" w="9525">
-                            <a:solidFill>
-                              <a:srgbClr val="000000"/>
-                            </a:solidFill>
-                            <a:miter lim="800000"/>
-                            <a:headEnd/>
-                            <a:tailEnd/>
-                          </a14:hiddenLine>
-                        </a:ext>
-                      </a:extLst>
-                    </p:spPr>
-                  </p:pic>
-                </p:oleObj>
-              </mc:Fallback>
-            </mc:AlternateContent>
-          </a:graphicData>
-        </a:graphic>
-      </p:graphicFrame>
+      <mc:AlternateContent xmlns:mc="http://schemas.openxmlformats.org/markup-compatibility/2006">
+        <mc:Choice xmlns:a14="http://schemas.microsoft.com/office/drawing/2010/main" Requires="a14">
+          <p:sp>
+            <p:nvSpPr>
+              <p:cNvPr id="17418" name="Object 9"/>
+              <p:cNvSpPr txBox="1"/>
+              <p:nvPr/>
+            </p:nvSpPr>
+            <p:spPr bwMode="auto">
+              <a:xfrm>
+                <a:off x="3221038" y="2714625"/>
+                <a:ext cx="844550" cy="615950"/>
+              </a:xfrm>
+              <a:prstGeom prst="rect">
+                <a:avLst/>
+              </a:prstGeom>
+              <a:noFill/>
+              <a:ln>
+                <a:noFill/>
+              </a:ln>
+            </p:spPr>
+            <p:txBody>
+              <a:bodyPr>
+                <a:normAutofit fontScale="62500" lnSpcReduction="20000"/>
+              </a:bodyPr>
+              <a:lstStyle/>
+              <a:p>
+                <a:pPr/>
+                <a14:m>
+                  <m:oMathPara xmlns:m="http://schemas.openxmlformats.org/officeDocument/2006/math">
+                    <m:oMathParaPr>
+                      <m:jc m:val="left"/>
+                    </m:oMathParaPr>
+                    <m:oMath xmlns:m="http://schemas.openxmlformats.org/officeDocument/2006/math">
+                      <m:sSub>
+                        <m:sSubPr>
+                          <m:ctrlPr>
+                            <a:rPr lang="en-US" i="1" smtClean="0">
+                              <a:solidFill>
+                                <a:srgbClr val="000000"/>
+                              </a:solidFill>
+                              <a:latin typeface="Cambria Math" panose="02040503050406030204" pitchFamily="18" charset="0"/>
+                            </a:rPr>
+                          </m:ctrlPr>
+                        </m:sSubPr>
+                        <m:e>
+                          <m:r>
+                            <a:rPr lang="en-US" i="1">
+                              <a:solidFill>
+                                <a:srgbClr val="000000"/>
+                              </a:solidFill>
+                              <a:latin typeface="Cambria Math" panose="02040503050406030204" pitchFamily="18" charset="0"/>
+                            </a:rPr>
+                            <m:t>𝜔</m:t>
+                          </m:r>
+                        </m:e>
+                        <m:sub>
+                          <m:r>
+                            <a:rPr lang="en-US" b="0" i="1" smtClean="0">
+                              <a:solidFill>
+                                <a:srgbClr val="000000"/>
+                              </a:solidFill>
+                              <a:latin typeface="Cambria Math" panose="02040503050406030204" pitchFamily="18" charset="0"/>
+                            </a:rPr>
+                            <m:t>𝑁</m:t>
+                          </m:r>
+                        </m:sub>
+                      </m:sSub>
+                      <m:r>
+                        <a:rPr lang="en-US" i="1">
+                          <a:solidFill>
+                            <a:srgbClr val="000000"/>
+                          </a:solidFill>
+                          <a:latin typeface="Cambria Math" panose="02040503050406030204" pitchFamily="18" charset="0"/>
+                        </a:rPr>
+                        <m:t>=</m:t>
+                      </m:r>
+                      <m:rad>
+                        <m:radPr>
+                          <m:degHide m:val="on"/>
+                          <m:ctrlPr>
+                            <a:rPr lang="en-US" i="1">
+                              <a:solidFill>
+                                <a:srgbClr val="000000"/>
+                              </a:solidFill>
+                              <a:latin typeface="Cambria Math" panose="02040503050406030204" pitchFamily="18" charset="0"/>
+                            </a:rPr>
+                          </m:ctrlPr>
+                        </m:radPr>
+                        <m:deg/>
+                        <m:e>
+                          <m:f>
+                            <m:fPr>
+                              <m:ctrlPr>
+                                <a:rPr lang="en-US" i="1">
+                                  <a:solidFill>
+                                    <a:srgbClr val="000000"/>
+                                  </a:solidFill>
+                                  <a:latin typeface="Cambria Math" panose="02040503050406030204" pitchFamily="18" charset="0"/>
+                                </a:rPr>
+                              </m:ctrlPr>
+                            </m:fPr>
+                            <m:num>
+                              <m:r>
+                                <a:rPr lang="en-US" i="1">
+                                  <a:solidFill>
+                                    <a:srgbClr val="000000"/>
+                                  </a:solidFill>
+                                  <a:latin typeface="Cambria Math" panose="02040503050406030204" pitchFamily="18" charset="0"/>
+                                </a:rPr>
+                                <m:t>𝑘</m:t>
+                              </m:r>
+                            </m:num>
+                            <m:den>
+                              <m:r>
+                                <a:rPr lang="en-US" i="1">
+                                  <a:solidFill>
+                                    <a:srgbClr val="000000"/>
+                                  </a:solidFill>
+                                  <a:latin typeface="Cambria Math" panose="02040503050406030204" pitchFamily="18" charset="0"/>
+                                </a:rPr>
+                                <m:t>𝑚</m:t>
+                              </m:r>
+                            </m:den>
+                          </m:f>
+                        </m:e>
+                      </m:rad>
+                    </m:oMath>
+                  </m:oMathPara>
+                </a14:m>
+                <a:endParaRPr lang="en-US" dirty="0"/>
+              </a:p>
+            </p:txBody>
+          </p:sp>
+        </mc:Choice>
+        <mc:Fallback>
+          <p:sp>
+            <p:nvSpPr>
+              <p:cNvPr id="17418" name="Object 9"/>
+              <p:cNvSpPr txBox="1">
+                <a:spLocks noRot="1" noChangeAspect="1" noMove="1" noResize="1" noEditPoints="1" noAdjustHandles="1" noChangeArrowheads="1" noChangeShapeType="1" noTextEdit="1"/>
+              </p:cNvSpPr>
+              <p:nvPr/>
+            </p:nvSpPr>
+            <p:spPr bwMode="auto">
+              <a:xfrm>
+                <a:off x="3221038" y="2714625"/>
+                <a:ext cx="844550" cy="615950"/>
+              </a:xfrm>
+              <a:prstGeom prst="rect">
+                <a:avLst/>
+              </a:prstGeom>
+              <a:blipFill>
+                <a:blip r:embed="rId5"/>
+                <a:stretch>
+                  <a:fillRect/>
+                </a:stretch>
+              </a:blipFill>
+              <a:ln>
+                <a:noFill/>
+              </a:ln>
+            </p:spPr>
+            <p:txBody>
+              <a:bodyPr/>
+              <a:lstStyle/>
+              <a:p>
+                <a:r>
+                  <a:rPr lang="en-US">
+                    <a:noFill/>
+                  </a:rPr>
+                  <a:t> </a:t>
+                </a:r>
+              </a:p>
+            </p:txBody>
+          </p:sp>
+        </mc:Fallback>
+      </mc:AlternateContent>
       <p:sp>
         <p:nvSpPr>
           <p:cNvPr id="17419" name="Rectangle 10"/>
@@ -36647,95 +36452,176 @@
           </a:p>
         </p:txBody>
       </p:sp>
-      <p:graphicFrame>
-        <p:nvGraphicFramePr>
-          <p:cNvPr id="17420" name="Object 11"/>
-          <p:cNvGraphicFramePr>
-            <a:graphicFrameLocks noChangeAspect="1"/>
-          </p:cNvGraphicFramePr>
-          <p:nvPr>
-            <p:extLst>
-              <p:ext uri="{D42A27DB-BD31-4B8C-83A1-F6EECF244321}">
-                <p14:modId xmlns:p14="http://schemas.microsoft.com/office/powerpoint/2010/main" val="1136934317"/>
-              </p:ext>
-            </p:extLst>
-          </p:nvPr>
-        </p:nvGraphicFramePr>
-        <p:xfrm>
-          <a:off x="3819526" y="3636549"/>
-          <a:ext cx="1243012" cy="423862"/>
-        </p:xfrm>
-        <a:graphic>
-          <a:graphicData uri="http://schemas.openxmlformats.org/presentationml/2006/ole">
-            <mc:AlternateContent xmlns:mc="http://schemas.openxmlformats.org/markup-compatibility/2006">
-              <mc:Choice xmlns:v="urn:schemas-microsoft-com:vml" Requires="v">
-                <p:oleObj name="Equation" r:id="rId8" imgW="672808" imgH="228501" progId="Equation.3">
-                  <p:embed/>
-                </p:oleObj>
-              </mc:Choice>
-              <mc:Fallback>
-                <p:oleObj name="Equation" r:id="rId8" imgW="672808" imgH="228501" progId="Equation.3">
-                  <p:embed/>
-                  <p:pic>
-                    <p:nvPicPr>
-                      <p:cNvPr id="17420" name="Object 11"/>
-                      <p:cNvPicPr>
-                        <a:picLocks noChangeAspect="1" noChangeArrowheads="1"/>
-                      </p:cNvPicPr>
-                      <p:nvPr/>
-                    </p:nvPicPr>
-                    <p:blipFill>
-                      <a:blip r:embed="rId9">
-                        <a:extLst>
-                          <a:ext uri="{28A0092B-C50C-407E-A947-70E740481C1C}">
-                            <a14:useLocalDpi xmlns:a14="http://schemas.microsoft.com/office/drawing/2010/main" val="0"/>
-                          </a:ext>
-                        </a:extLst>
-                      </a:blip>
-                      <a:srcRect/>
-                      <a:stretch>
-                        <a:fillRect/>
-                      </a:stretch>
-                    </p:blipFill>
-                    <p:spPr bwMode="auto">
-                      <a:xfrm>
-                        <a:off x="3819526" y="3636549"/>
-                        <a:ext cx="1243012" cy="423862"/>
-                      </a:xfrm>
-                      <a:prstGeom prst="rect">
-                        <a:avLst/>
-                      </a:prstGeom>
-                      <a:noFill/>
-                      <a:ln>
-                        <a:noFill/>
-                      </a:ln>
-                      <a:extLst>
-                        <a:ext uri="{909E8E84-426E-40DD-AFC4-6F175D3DCCD1}">
-                          <a14:hiddenFill xmlns:a14="http://schemas.microsoft.com/office/drawing/2010/main">
-                            <a:solidFill>
-                              <a:srgbClr val="FFFFFF"/>
-                            </a:solidFill>
-                          </a14:hiddenFill>
-                        </a:ext>
-                        <a:ext uri="{91240B29-F687-4F45-9708-019B960494DF}">
-                          <a14:hiddenLine xmlns:a14="http://schemas.microsoft.com/office/drawing/2010/main" w="9525">
-                            <a:solidFill>
-                              <a:srgbClr val="000000"/>
-                            </a:solidFill>
-                            <a:miter lim="800000"/>
-                            <a:headEnd/>
-                            <a:tailEnd/>
-                          </a14:hiddenLine>
-                        </a:ext>
-                      </a:extLst>
-                    </p:spPr>
-                  </p:pic>
-                </p:oleObj>
-              </mc:Fallback>
-            </mc:AlternateContent>
-          </a:graphicData>
-        </a:graphic>
-      </p:graphicFrame>
+      <mc:AlternateContent xmlns:mc="http://schemas.openxmlformats.org/markup-compatibility/2006">
+        <mc:Choice xmlns:a14="http://schemas.microsoft.com/office/drawing/2010/main" Requires="a14">
+          <p:sp>
+            <p:nvSpPr>
+              <p:cNvPr id="17420" name="Object 11"/>
+              <p:cNvSpPr txBox="1"/>
+              <p:nvPr/>
+            </p:nvSpPr>
+            <p:spPr bwMode="auto">
+              <a:xfrm>
+                <a:off x="3819525" y="3636963"/>
+                <a:ext cx="1243013" cy="423862"/>
+              </a:xfrm>
+              <a:prstGeom prst="rect">
+                <a:avLst/>
+              </a:prstGeom>
+              <a:noFill/>
+              <a:ln>
+                <a:noFill/>
+              </a:ln>
+            </p:spPr>
+            <p:txBody>
+              <a:bodyPr>
+                <a:normAutofit fontScale="85000" lnSpcReduction="10000"/>
+              </a:bodyPr>
+              <a:lstStyle/>
+              <a:p>
+                <a:pPr/>
+                <a14:m>
+                  <m:oMathPara xmlns:m="http://schemas.openxmlformats.org/officeDocument/2006/math">
+                    <m:oMathParaPr>
+                      <m:jc m:val="left"/>
+                    </m:oMathParaPr>
+                    <m:oMath xmlns:m="http://schemas.openxmlformats.org/officeDocument/2006/math">
+                      <m:sSub>
+                        <m:sSubPr>
+                          <m:ctrlPr>
+                            <a:rPr lang="en-US" i="1" smtClean="0">
+                              <a:solidFill>
+                                <a:srgbClr val="000000"/>
+                              </a:solidFill>
+                              <a:latin typeface="Cambria Math" panose="02040503050406030204" pitchFamily="18" charset="0"/>
+                            </a:rPr>
+                          </m:ctrlPr>
+                        </m:sSubPr>
+                        <m:e>
+                          <m:r>
+                            <a:rPr lang="en-US" i="1">
+                              <a:solidFill>
+                                <a:srgbClr val="000000"/>
+                              </a:solidFill>
+                              <a:latin typeface="Cambria Math" panose="02040503050406030204" pitchFamily="18" charset="0"/>
+                            </a:rPr>
+                            <m:t>𝑏</m:t>
+                          </m:r>
+                        </m:e>
+                        <m:sub>
+                          <m:r>
+                            <a:rPr lang="en-US" i="1">
+                              <a:solidFill>
+                                <a:srgbClr val="000000"/>
+                              </a:solidFill>
+                              <a:latin typeface="Cambria Math" panose="02040503050406030204" pitchFamily="18" charset="0"/>
+                            </a:rPr>
+                            <m:t>𝑐</m:t>
+                          </m:r>
+                        </m:sub>
+                      </m:sSub>
+                      <m:r>
+                        <a:rPr lang="en-US" i="1">
+                          <a:solidFill>
+                            <a:srgbClr val="000000"/>
+                          </a:solidFill>
+                          <a:latin typeface="Cambria Math" panose="02040503050406030204" pitchFamily="18" charset="0"/>
+                        </a:rPr>
+                        <m:t>=2</m:t>
+                      </m:r>
+                      <m:r>
+                        <a:rPr lang="en-US" i="1">
+                          <a:solidFill>
+                            <a:srgbClr val="000000"/>
+                          </a:solidFill>
+                          <a:latin typeface="Cambria Math" panose="02040503050406030204" pitchFamily="18" charset="0"/>
+                        </a:rPr>
+                        <m:t>𝑚</m:t>
+                      </m:r>
+                      <m:sSub>
+                        <m:sSubPr>
+                          <m:ctrlPr>
+                            <a:rPr lang="en-US" i="1" smtClean="0">
+                              <a:solidFill>
+                                <a:srgbClr val="000000"/>
+                              </a:solidFill>
+                              <a:latin typeface="Cambria Math" panose="02040503050406030204" pitchFamily="18" charset="0"/>
+                            </a:rPr>
+                          </m:ctrlPr>
+                        </m:sSubPr>
+                        <m:e>
+                          <m:r>
+                            <a:rPr lang="en-US" i="1">
+                              <a:solidFill>
+                                <a:srgbClr val="000000"/>
+                              </a:solidFill>
+                              <a:latin typeface="Cambria Math" panose="02040503050406030204" pitchFamily="18" charset="0"/>
+                            </a:rPr>
+                            <m:t>𝜔</m:t>
+                          </m:r>
+                        </m:e>
+                        <m:sub>
+                          <m:r>
+                            <a:rPr lang="en-US" b="0" i="1" smtClean="0">
+                              <a:solidFill>
+                                <a:srgbClr val="000000"/>
+                              </a:solidFill>
+                              <a:latin typeface="Cambria Math" panose="02040503050406030204" pitchFamily="18" charset="0"/>
+                            </a:rPr>
+                            <m:t>𝑁</m:t>
+                          </m:r>
+                        </m:sub>
+                      </m:sSub>
+                    </m:oMath>
+                  </m:oMathPara>
+                </a14:m>
+                <a:endParaRPr lang="en-US" dirty="0"/>
+              </a:p>
+            </p:txBody>
+          </p:sp>
+        </mc:Choice>
+        <mc:Fallback>
+          <p:sp>
+            <p:nvSpPr>
+              <p:cNvPr id="17420" name="Object 11"/>
+              <p:cNvSpPr txBox="1">
+                <a:spLocks noRot="1" noChangeAspect="1" noMove="1" noResize="1" noEditPoints="1" noAdjustHandles="1" noChangeArrowheads="1" noChangeShapeType="1" noTextEdit="1"/>
+              </p:cNvSpPr>
+              <p:nvPr/>
+            </p:nvSpPr>
+            <p:spPr bwMode="auto">
+              <a:xfrm>
+                <a:off x="3819525" y="3636963"/>
+                <a:ext cx="1243013" cy="423862"/>
+              </a:xfrm>
+              <a:prstGeom prst="rect">
+                <a:avLst/>
+              </a:prstGeom>
+              <a:blipFill>
+                <a:blip r:embed="rId6"/>
+                <a:stretch>
+                  <a:fillRect/>
+                </a:stretch>
+              </a:blipFill>
+              <a:ln>
+                <a:noFill/>
+              </a:ln>
+            </p:spPr>
+            <p:txBody>
+              <a:bodyPr/>
+              <a:lstStyle/>
+              <a:p>
+                <a:r>
+                  <a:rPr lang="en-US">
+                    <a:noFill/>
+                  </a:rPr>
+                  <a:t> </a:t>
+                </a:r>
+              </a:p>
+            </p:txBody>
+          </p:sp>
+        </mc:Fallback>
+      </mc:AlternateContent>
       <p:sp>
         <p:nvSpPr>
           <p:cNvPr id="17421" name="Rectangle 12"/>
@@ -36786,95 +36672,176 @@
           </a:p>
         </p:txBody>
       </p:sp>
-      <p:graphicFrame>
-        <p:nvGraphicFramePr>
-          <p:cNvPr id="17422" name="Object 13"/>
-          <p:cNvGraphicFramePr>
-            <a:graphicFrameLocks noChangeAspect="1"/>
-          </p:cNvGraphicFramePr>
-          <p:nvPr>
-            <p:extLst>
-              <p:ext uri="{D42A27DB-BD31-4B8C-83A1-F6EECF244321}">
-                <p14:modId xmlns:p14="http://schemas.microsoft.com/office/powerpoint/2010/main" val="1845892320"/>
-              </p:ext>
-            </p:extLst>
-          </p:nvPr>
-        </p:nvGraphicFramePr>
-        <p:xfrm>
-          <a:off x="4041300" y="4426829"/>
-          <a:ext cx="728662" cy="346075"/>
-        </p:xfrm>
-        <a:graphic>
-          <a:graphicData uri="http://schemas.openxmlformats.org/presentationml/2006/ole">
-            <mc:AlternateContent xmlns:mc="http://schemas.openxmlformats.org/markup-compatibility/2006">
-              <mc:Choice xmlns:v="urn:schemas-microsoft-com:vml" Requires="v">
-                <p:oleObj name="Equation" r:id="rId10" imgW="482391" imgH="228501" progId="Equation.3">
-                  <p:embed/>
-                </p:oleObj>
-              </mc:Choice>
-              <mc:Fallback>
-                <p:oleObj name="Equation" r:id="rId10" imgW="482391" imgH="228501" progId="Equation.3">
-                  <p:embed/>
-                  <p:pic>
-                    <p:nvPicPr>
-                      <p:cNvPr id="17422" name="Object 13"/>
-                      <p:cNvPicPr>
-                        <a:picLocks noChangeAspect="1" noChangeArrowheads="1"/>
-                      </p:cNvPicPr>
-                      <p:nvPr/>
-                    </p:nvPicPr>
-                    <p:blipFill>
-                      <a:blip r:embed="rId11">
-                        <a:extLst>
-                          <a:ext uri="{28A0092B-C50C-407E-A947-70E740481C1C}">
-                            <a14:useLocalDpi xmlns:a14="http://schemas.microsoft.com/office/drawing/2010/main" val="0"/>
-                          </a:ext>
-                        </a:extLst>
-                      </a:blip>
-                      <a:srcRect/>
-                      <a:stretch>
-                        <a:fillRect/>
-                      </a:stretch>
-                    </p:blipFill>
-                    <p:spPr bwMode="auto">
-                      <a:xfrm>
-                        <a:off x="4041300" y="4426829"/>
-                        <a:ext cx="728662" cy="346075"/>
-                      </a:xfrm>
-                      <a:prstGeom prst="rect">
-                        <a:avLst/>
-                      </a:prstGeom>
-                      <a:noFill/>
-                      <a:ln>
-                        <a:noFill/>
-                      </a:ln>
-                      <a:extLst>
-                        <a:ext uri="{909E8E84-426E-40DD-AFC4-6F175D3DCCD1}">
-                          <a14:hiddenFill xmlns:a14="http://schemas.microsoft.com/office/drawing/2010/main">
-                            <a:solidFill>
-                              <a:srgbClr val="FFFFFF"/>
-                            </a:solidFill>
-                          </a14:hiddenFill>
-                        </a:ext>
-                        <a:ext uri="{91240B29-F687-4F45-9708-019B960494DF}">
-                          <a14:hiddenLine xmlns:a14="http://schemas.microsoft.com/office/drawing/2010/main" w="9525">
-                            <a:solidFill>
-                              <a:srgbClr val="000000"/>
-                            </a:solidFill>
-                            <a:miter lim="800000"/>
-                            <a:headEnd/>
-                            <a:tailEnd/>
-                          </a14:hiddenLine>
-                        </a:ext>
-                      </a:extLst>
-                    </p:spPr>
-                  </p:pic>
-                </p:oleObj>
-              </mc:Fallback>
-            </mc:AlternateContent>
-          </a:graphicData>
-        </a:graphic>
-      </p:graphicFrame>
+      <mc:AlternateContent xmlns:mc="http://schemas.openxmlformats.org/markup-compatibility/2006">
+        <mc:Choice xmlns:a14="http://schemas.microsoft.com/office/drawing/2010/main" Requires="a14">
+          <p:sp>
+            <p:nvSpPr>
+              <p:cNvPr id="17422" name="Object 13"/>
+              <p:cNvSpPr txBox="1"/>
+              <p:nvPr/>
+            </p:nvSpPr>
+            <p:spPr bwMode="auto">
+              <a:xfrm>
+                <a:off x="4065588" y="4384260"/>
+                <a:ext cx="841905" cy="389353"/>
+              </a:xfrm>
+              <a:prstGeom prst="rect">
+                <a:avLst/>
+              </a:prstGeom>
+              <a:noFill/>
+              <a:ln>
+                <a:noFill/>
+              </a:ln>
+            </p:spPr>
+            <p:txBody>
+              <a:bodyPr>
+                <a:normAutofit fontScale="55000" lnSpcReduction="20000"/>
+              </a:bodyPr>
+              <a:lstStyle/>
+              <a:p>
+                <a:pPr/>
+                <a14:m>
+                  <m:oMathPara xmlns:m="http://schemas.openxmlformats.org/officeDocument/2006/math">
+                    <m:oMathParaPr>
+                      <m:jc m:val="left"/>
+                    </m:oMathParaPr>
+                    <m:oMath xmlns:m="http://schemas.openxmlformats.org/officeDocument/2006/math">
+                      <m:f>
+                        <m:fPr>
+                          <m:ctrlPr>
+                            <a:rPr lang="en-US" i="1" smtClean="0">
+                              <a:solidFill>
+                                <a:srgbClr val="000000"/>
+                              </a:solidFill>
+                              <a:latin typeface="Cambria Math" panose="02040503050406030204" pitchFamily="18" charset="0"/>
+                            </a:rPr>
+                          </m:ctrlPr>
+                        </m:fPr>
+                        <m:num>
+                          <m:r>
+                            <a:rPr lang="en-US" i="1">
+                              <a:solidFill>
+                                <a:srgbClr val="000000"/>
+                              </a:solidFill>
+                              <a:latin typeface="Cambria Math" panose="02040503050406030204" pitchFamily="18" charset="0"/>
+                            </a:rPr>
+                            <m:t>𝑏</m:t>
+                          </m:r>
+                        </m:num>
+                        <m:den>
+                          <m:r>
+                            <a:rPr lang="en-US" i="1">
+                              <a:solidFill>
+                                <a:srgbClr val="000000"/>
+                              </a:solidFill>
+                              <a:latin typeface="Cambria Math" panose="02040503050406030204" pitchFamily="18" charset="0"/>
+                            </a:rPr>
+                            <m:t>2</m:t>
+                          </m:r>
+                          <m:r>
+                            <a:rPr lang="en-US" i="1">
+                              <a:solidFill>
+                                <a:srgbClr val="000000"/>
+                              </a:solidFill>
+                              <a:latin typeface="Cambria Math" panose="02040503050406030204" pitchFamily="18" charset="0"/>
+                            </a:rPr>
+                            <m:t>𝜋</m:t>
+                          </m:r>
+                        </m:den>
+                      </m:f>
+                      <m:r>
+                        <a:rPr lang="en-US" i="1">
+                          <a:solidFill>
+                            <a:srgbClr val="000000"/>
+                          </a:solidFill>
+                          <a:latin typeface="Cambria Math" panose="02040503050406030204" pitchFamily="18" charset="0"/>
+                        </a:rPr>
+                        <m:t>≥</m:t>
+                      </m:r>
+                      <m:sSub>
+                        <m:sSubPr>
+                          <m:ctrlPr>
+                            <a:rPr lang="en-US" i="1">
+                              <a:solidFill>
+                                <a:srgbClr val="000000"/>
+                              </a:solidFill>
+                              <a:latin typeface="Cambria Math" panose="02040503050406030204" pitchFamily="18" charset="0"/>
+                            </a:rPr>
+                          </m:ctrlPr>
+                        </m:sSubPr>
+                        <m:e>
+                          <m:r>
+                            <a:rPr lang="en-US" i="1">
+                              <a:solidFill>
+                                <a:srgbClr val="000000"/>
+                              </a:solidFill>
+                              <a:latin typeface="Cambria Math" panose="02040503050406030204" pitchFamily="18" charset="0"/>
+                            </a:rPr>
+                            <m:t>𝜔</m:t>
+                          </m:r>
+                        </m:e>
+                        <m:sub>
+                          <m:r>
+                            <a:rPr lang="en-US" b="0" i="1" smtClean="0">
+                              <a:solidFill>
+                                <a:srgbClr val="000000"/>
+                              </a:solidFill>
+                              <a:latin typeface="Cambria Math" panose="02040503050406030204" pitchFamily="18" charset="0"/>
+                            </a:rPr>
+                            <m:t>𝑁</m:t>
+                          </m:r>
+                        </m:sub>
+                      </m:sSub>
+                    </m:oMath>
+                  </m:oMathPara>
+                </a14:m>
+                <a:endParaRPr lang="en-US" dirty="0"/>
+              </a:p>
+            </p:txBody>
+          </p:sp>
+        </mc:Choice>
+        <mc:Fallback>
+          <p:sp>
+            <p:nvSpPr>
+              <p:cNvPr id="17422" name="Object 13"/>
+              <p:cNvSpPr txBox="1">
+                <a:spLocks noRot="1" noChangeAspect="1" noMove="1" noResize="1" noEditPoints="1" noAdjustHandles="1" noChangeArrowheads="1" noChangeShapeType="1" noTextEdit="1"/>
+              </p:cNvSpPr>
+              <p:nvPr/>
+            </p:nvSpPr>
+            <p:spPr bwMode="auto">
+              <a:xfrm>
+                <a:off x="4065588" y="4384260"/>
+                <a:ext cx="841905" cy="389353"/>
+              </a:xfrm>
+              <a:prstGeom prst="rect">
+                <a:avLst/>
+              </a:prstGeom>
+              <a:blipFill>
+                <a:blip r:embed="rId7"/>
+                <a:stretch>
+                  <a:fillRect/>
+                </a:stretch>
+              </a:blipFill>
+              <a:ln>
+                <a:noFill/>
+              </a:ln>
+            </p:spPr>
+            <p:txBody>
+              <a:bodyPr/>
+              <a:lstStyle/>
+              <a:p>
+                <a:r>
+                  <a:rPr lang="en-US">
+                    <a:noFill/>
+                  </a:rPr>
+                  <a:t> </a:t>
+                </a:r>
+              </a:p>
+            </p:txBody>
+          </p:sp>
+        </mc:Fallback>
+      </mc:AlternateContent>
     </p:spTree>
   </p:cSld>
   <p:clrMapOvr>

</xml_diff>